<commit_message>
vault backup: 2026-09-09 16:30:56
</commit_message>
<xml_diff>
--- a/SDLC/Projects/TMP-specimen-sorter-api — Specimen Sorter API/assets/Specimen Sorter API.pptx
+++ b/SDLC/Projects/TMP-specimen-sorter-api — Specimen Sorter API/assets/Specimen Sorter API.pptx
@@ -1920,7 +1920,7 @@
         <p:spPr>
           <a:xfrm>
             <a:off x="685800" y="4892040"/>
-            <a:ext cx="2023110" cy="868680"/>
+            <a:ext cx="2532888" cy="868680"/>
           </a:xfrm>
           <a:prstGeom prst="roundRect">
             <a:avLst>
@@ -1947,7 +1947,7 @@
         <p:spPr>
           <a:xfrm>
             <a:off x="886968" y="5029200"/>
-            <a:ext cx="1611630" cy="219456"/>
+            <a:ext cx="2121408" cy="219456"/>
           </a:xfrm>
           <a:prstGeom prst="rect">
             <a:avLst/>
@@ -1989,7 +1989,7 @@
         <p:spPr>
           <a:xfrm>
             <a:off x="886968" y="5266944"/>
-            <a:ext cx="1611630" cy="310896"/>
+            <a:ext cx="2121408" cy="310896"/>
           </a:xfrm>
           <a:prstGeom prst="rect">
             <a:avLst/>
@@ -2030,8 +2030,8 @@
         </p:nvSpPr>
         <p:spPr>
           <a:xfrm>
-            <a:off x="2983230" y="4892040"/>
-            <a:ext cx="2023110" cy="868680"/>
+            <a:off x="3493008" y="4892040"/>
+            <a:ext cx="2532888" cy="868680"/>
           </a:xfrm>
           <a:prstGeom prst="roundRect">
             <a:avLst>
@@ -2057,8 +2057,8 @@
         </p:nvSpPr>
         <p:spPr>
           <a:xfrm>
-            <a:off x="3184398" y="5029200"/>
-            <a:ext cx="1611630" cy="219456"/>
+            <a:off x="3694176" y="5029200"/>
+            <a:ext cx="2121408" cy="219456"/>
           </a:xfrm>
           <a:prstGeom prst="rect">
             <a:avLst/>
@@ -2099,8 +2099,8 @@
         </p:nvSpPr>
         <p:spPr>
           <a:xfrm>
-            <a:off x="3184398" y="5266944"/>
-            <a:ext cx="1611630" cy="310896"/>
+            <a:off x="3694176" y="5266944"/>
+            <a:ext cx="2121408" cy="310896"/>
           </a:xfrm>
           <a:prstGeom prst="rect">
             <a:avLst/>
@@ -2141,8 +2141,8 @@
         </p:nvSpPr>
         <p:spPr>
           <a:xfrm>
-            <a:off x="5280660" y="4892040"/>
-            <a:ext cx="2023110" cy="868680"/>
+            <a:off x="6300216" y="4892040"/>
+            <a:ext cx="2532888" cy="868680"/>
           </a:xfrm>
           <a:prstGeom prst="roundRect">
             <a:avLst>
@@ -2168,8 +2168,8 @@
         </p:nvSpPr>
         <p:spPr>
           <a:xfrm>
-            <a:off x="5481828" y="5029200"/>
-            <a:ext cx="1611630" cy="219456"/>
+            <a:off x="6501384" y="5029200"/>
+            <a:ext cx="2121408" cy="219456"/>
           </a:xfrm>
           <a:prstGeom prst="rect">
             <a:avLst/>
@@ -2210,8 +2210,8 @@
         </p:nvSpPr>
         <p:spPr>
           <a:xfrm>
-            <a:off x="5481828" y="5266944"/>
-            <a:ext cx="1611630" cy="310896"/>
+            <a:off x="6501384" y="5266944"/>
+            <a:ext cx="2121408" cy="310896"/>
           </a:xfrm>
           <a:prstGeom prst="rect">
             <a:avLst/>
@@ -2252,8 +2252,8 @@
         </p:nvSpPr>
         <p:spPr>
           <a:xfrm>
-            <a:off x="7578090" y="4892040"/>
-            <a:ext cx="2023110" cy="868680"/>
+            <a:off x="9107424" y="4892040"/>
+            <a:ext cx="2532888" cy="868680"/>
           </a:xfrm>
           <a:prstGeom prst="roundRect">
             <a:avLst>
@@ -2279,8 +2279,8 @@
         </p:nvSpPr>
         <p:spPr>
           <a:xfrm>
-            <a:off x="7779258" y="5029200"/>
-            <a:ext cx="1611630" cy="219456"/>
+            <a:off x="9308592" y="5029200"/>
+            <a:ext cx="2121408" cy="219456"/>
           </a:xfrm>
           <a:prstGeom prst="rect">
             <a:avLst/>
@@ -2321,8 +2321,8 @@
         </p:nvSpPr>
         <p:spPr>
           <a:xfrm>
-            <a:off x="7779258" y="5266944"/>
-            <a:ext cx="1611630" cy="310896"/>
+            <a:off x="9308592" y="5266944"/>
+            <a:ext cx="2121408" cy="310896"/>
           </a:xfrm>
           <a:prstGeom prst="rect">
             <a:avLst/>
@@ -3969,7 +3969,7 @@
                 <a:ea typeface="Calibri" pitchFamily="34" charset="-122"/>
                 <a:cs typeface="Calibri" pitchFamily="34" charset="-120"/>
               </a:rPr>
-              <a:t>Lookup and writes live in lis-crs-spec-ack-svc. Packing still sits in Flex GcrSpecAckDataConvertor.</a:t>
+              <a:t>Lookup and writes live in the Spec Ack service. Packing still sits in Flex.</a:t>
             </a:r>
             <a:endParaRPr lang="en-US" sz="1400" dirty="0"/>
           </a:p>
@@ -4275,7 +4275,7 @@
                 <a:ea typeface="Calibri" pitchFamily="34" charset="-122"/>
                 <a:cs typeface="Calibri" pitchFamily="34" charset="-120"/>
               </a:rPr>
-              <a:t>GET /retrieveGcrOrder hard-codes user ltc611. The sorter must not call it.</a:t>
+              <a:t>GET /retrieveGcrOrder hard-codes user ltc611. Do not call it.</a:t>
             </a:r>
             <a:endParaRPr lang="en-US" sz="1400" dirty="0"/>
           </a:p>
@@ -8522,7 +8522,7 @@
                 <a:ea typeface="Calibri" pitchFamily="34" charset="-122"/>
                 <a:cs typeface="Calibri" pitchFamily="34" charset="-120"/>
               </a:rPr>
-              <a:t>Dedicated LIS user. It appears on LOE_AUDIT_TRAIL.loeaud_usercode. Not ltc611.</a:t>
+              <a:t>Dedicated LIS user on LOE_AUDIT_TRAIL. Not ltc611.</a:t>
             </a:r>
             <a:endParaRPr lang="en-US" sz="1300" dirty="0"/>
           </a:p>
@@ -8717,7 +8717,7 @@
                 <a:ea typeface="Calibri" pitchFamily="34" charset="-122"/>
                 <a:cs typeface="Calibri" pitchFamily="34" charset="-120"/>
               </a:rPr>
-              <a:t>One row per physical sorter: hosp, lab, station name, location, default printer.</a:t>
+              <a:t>One row per sorter: hosp, lab, station name, location, printer.</a:t>
             </a:r>
             <a:endParaRPr lang="en-US" sz="1300" dirty="0"/>
           </a:p>
@@ -8912,7 +8912,7 @@
                 <a:ea typeface="Calibri" pitchFamily="34" charset="-122"/>
                 <a:cs typeface="Calibri" pitchFamily="34" charset="-120"/>
               </a:rPr>
-              <a:t>Sorter id, user, workbench id, lab, hosp, server name. Printer stays on workbench.</a:t>
+              <a:t>Sorter id, user, workbench id, lab, hosp, server name.</a:t>
             </a:r>
             <a:endParaRPr lang="en-US" sz="1300" dirty="0"/>
           </a:p>
@@ -8932,201 +8932,6 @@
           <a:prstGeom prst="roundRect">
             <a:avLst>
               <a:gd name="adj" fmla="val 2564"/>
-            </a:avLst>
-          </a:prstGeom>
-          <a:solidFill>
-            <a:srgbClr val="08323B"/>
-          </a:solidFill>
-          <a:ln w="12700">
-            <a:solidFill>
-              <a:srgbClr val="08323B"/>
-            </a:solidFill>
-            <a:prstDash val="solid"/>
-          </a:ln>
-        </p:spPr>
-      </p:sp>
-      <p:sp>
-        <p:nvSpPr>
-          <p:cNvPr id="20" name="Text 18"/>
-          <p:cNvSpPr/>
-          <p:nvPr/>
-        </p:nvSpPr>
-        <p:spPr>
-          <a:xfrm>
-            <a:off x="6496812" y="3675888"/>
-            <a:ext cx="384048" cy="384048"/>
-          </a:xfrm>
-          <a:prstGeom prst="ellipse">
-            <a:avLst/>
-          </a:prstGeom>
-          <a:solidFill>
-            <a:srgbClr val="0B6E7F"/>
-          </a:solidFill>
-          <a:ln>
-            <a:solidFill>
-              <a:srgbClr val="0B6E7F"/>
-            </a:solidFill>
-          </a:ln>
-        </p:spPr>
-        <p:txBody>
-          <a:bodyPr wrap="square" rtlCol="0" anchor="ctr"/>
-          <a:lstStyle/>
-          <a:p>
-            <a:pPr algn="ctr" indent="0" marL="0">
-              <a:buNone/>
-            </a:pPr>
-            <a:r>
-              <a:rPr lang="en-US" sz="1300" b="1" dirty="0">
-                <a:solidFill>
-                  <a:srgbClr val="FFFFFF"/>
-                </a:solidFill>
-                <a:latin typeface="Calibri" pitchFamily="34" charset="0"/>
-                <a:ea typeface="Calibri" pitchFamily="34" charset="-122"/>
-                <a:cs typeface="Calibri" pitchFamily="34" charset="-120"/>
-              </a:rPr>
-              <a:t>4</a:t>
-            </a:r>
-            <a:endParaRPr lang="en-US" sz="1300" dirty="0"/>
-          </a:p>
-        </p:txBody>
-      </p:sp>
-      <p:sp>
-        <p:nvSpPr>
-          <p:cNvPr id="21" name="Text 19"/>
-          <p:cNvSpPr/>
-          <p:nvPr/>
-        </p:nvSpPr>
-        <p:spPr>
-          <a:xfrm>
-            <a:off x="6496812" y="4242816"/>
-            <a:ext cx="4869180" cy="274320"/>
-          </a:xfrm>
-          <a:prstGeom prst="rect">
-            <a:avLst/>
-          </a:prstGeom>
-          <a:noFill/>
-          <a:ln/>
-        </p:spPr>
-        <p:txBody>
-          <a:bodyPr wrap="square" rtlCol="0" anchor="ctr"/>
-          <a:lstStyle/>
-          <a:p>
-            <a:pPr algn="l" indent="0" marL="0">
-              <a:buNone/>
-            </a:pPr>
-            <a:r>
-              <a:rPr lang="en-US" sz="1100" dirty="0">
-                <a:solidFill>
-                  <a:srgbClr val="8FBAC3"/>
-                </a:solidFill>
-                <a:latin typeface="Courier New" pitchFamily="34" charset="0"/>
-                <a:ea typeface="Courier New" pitchFamily="34" charset="-122"/>
-                <a:cs typeface="Courier New" pitchFamily="34" charset="-120"/>
-              </a:rPr>
-              <a:t>deploy</a:t>
-            </a:r>
-            <a:endParaRPr lang="en-US" sz="1100" dirty="0"/>
-          </a:p>
-        </p:txBody>
-      </p:sp>
-      <p:sp>
-        <p:nvSpPr>
-          <p:cNvPr id="22" name="Text 20"/>
-          <p:cNvSpPr/>
-          <p:nvPr/>
-        </p:nvSpPr>
-        <p:spPr>
-          <a:xfrm>
-            <a:off x="6496812" y="4608576"/>
-            <a:ext cx="4869180" cy="457200"/>
-          </a:xfrm>
-          <a:prstGeom prst="rect">
-            <a:avLst/>
-          </a:prstGeom>
-          <a:noFill/>
-          <a:ln/>
-        </p:spPr>
-        <p:txBody>
-          <a:bodyPr wrap="square" rtlCol="0" anchor="t"/>
-          <a:lstStyle/>
-          <a:p>
-            <a:pPr algn="l" indent="0" marL="0">
-              <a:lnSpc>
-                <a:spcPct val="115000"/>
-              </a:lnSpc>
-              <a:buNone/>
-            </a:pPr>
-            <a:r>
-              <a:rPr lang="en-US" sz="1700" dirty="0">
-                <a:solidFill>
-                  <a:srgbClr val="FFFFFF"/>
-                </a:solidFill>
-                <a:latin typeface="Cambria" pitchFamily="34" charset="0"/>
-                <a:ea typeface="Cambria" pitchFamily="34" charset="-122"/>
-                <a:cs typeface="Cambria" pitchFamily="34" charset="-120"/>
-              </a:rPr>
-              <a:t>Deploy and open the path</a:t>
-            </a:r>
-            <a:endParaRPr lang="en-US" sz="1700" dirty="0"/>
-          </a:p>
-        </p:txBody>
-      </p:sp>
-      <p:sp>
-        <p:nvSpPr>
-          <p:cNvPr id="23" name="Text 21"/>
-          <p:cNvSpPr/>
-          <p:nvPr/>
-        </p:nvSpPr>
-        <p:spPr>
-          <a:xfrm>
-            <a:off x="6496812" y="5138928"/>
-            <a:ext cx="4869180" cy="-475488"/>
-          </a:xfrm>
-          <a:prstGeom prst="rect">
-            <a:avLst/>
-          </a:prstGeom>
-          <a:noFill/>
-          <a:ln/>
-        </p:spPr>
-        <p:txBody>
-          <a:bodyPr wrap="square" rtlCol="0" anchor="t"/>
-          <a:lstStyle/>
-          <a:p>
-            <a:pPr algn="l" indent="0" marL="0">
-              <a:lnSpc>
-                <a:spcPct val="115000"/>
-              </a:lnSpc>
-              <a:buNone/>
-            </a:pPr>
-            <a:r>
-              <a:rPr lang="en-US" sz="1300" dirty="0">
-                <a:solidFill>
-                  <a:srgbClr val="8FBAC3"/>
-                </a:solidFill>
-                <a:latin typeface="Calibri" pitchFamily="34" charset="0"/>
-                <a:ea typeface="Calibri" pitchFamily="34" charset="-122"/>
-                <a:cs typeface="Calibri" pitchFamily="34" charset="-120"/>
-              </a:rPr>
-              <a:t>Deploy lis-crs-spec-ack-svc. NetworkPolicy for middleware. No API key in v1.</a:t>
-            </a:r>
-            <a:endParaRPr lang="en-US" sz="1300" dirty="0"/>
-          </a:p>
-        </p:txBody>
-      </p:sp>
-      <p:sp>
-        <p:nvSpPr>
-          <p:cNvPr id="24" name="Shape 22"/>
-          <p:cNvSpPr/>
-          <p:nvPr/>
-        </p:nvSpPr>
-        <p:spPr>
-          <a:xfrm>
-            <a:off x="548640" y="4983480"/>
-            <a:ext cx="11091672" cy="868680"/>
-          </a:xfrm>
-          <a:prstGeom prst="roundRect">
-            <a:avLst>
-              <a:gd name="adj" fmla="val 4211"/>
             </a:avLst>
           </a:prstGeom>
           <a:solidFill>
@@ -9142,6 +8947,201 @@
       </p:sp>
       <p:sp>
         <p:nvSpPr>
+          <p:cNvPr id="20" name="Text 18"/>
+          <p:cNvSpPr/>
+          <p:nvPr/>
+        </p:nvSpPr>
+        <p:spPr>
+          <a:xfrm>
+            <a:off x="6496812" y="3675888"/>
+            <a:ext cx="384048" cy="384048"/>
+          </a:xfrm>
+          <a:prstGeom prst="ellipse">
+            <a:avLst/>
+          </a:prstGeom>
+          <a:solidFill>
+            <a:srgbClr val="9A5C15"/>
+          </a:solidFill>
+          <a:ln>
+            <a:solidFill>
+              <a:srgbClr val="9A5C15"/>
+            </a:solidFill>
+          </a:ln>
+        </p:spPr>
+        <p:txBody>
+          <a:bodyPr wrap="square" rtlCol="0" anchor="ctr"/>
+          <a:lstStyle/>
+          <a:p>
+            <a:pPr algn="ctr" indent="0" marL="0">
+              <a:buNone/>
+            </a:pPr>
+            <a:r>
+              <a:rPr lang="en-US" sz="1300" b="1" dirty="0">
+                <a:solidFill>
+                  <a:srgbClr val="FFFFFF"/>
+                </a:solidFill>
+                <a:latin typeface="Calibri" pitchFamily="34" charset="0"/>
+                <a:ea typeface="Calibri" pitchFamily="34" charset="-122"/>
+                <a:cs typeface="Calibri" pitchFamily="34" charset="-120"/>
+              </a:rPr>
+              <a:t>4</a:t>
+            </a:r>
+            <a:endParaRPr lang="en-US" sz="1300" dirty="0"/>
+          </a:p>
+        </p:txBody>
+      </p:sp>
+      <p:sp>
+        <p:nvSpPr>
+          <p:cNvPr id="21" name="Text 19"/>
+          <p:cNvSpPr/>
+          <p:nvPr/>
+        </p:nvSpPr>
+        <p:spPr>
+          <a:xfrm>
+            <a:off x="6496812" y="4242816"/>
+            <a:ext cx="4869180" cy="274320"/>
+          </a:xfrm>
+          <a:prstGeom prst="rect">
+            <a:avLst/>
+          </a:prstGeom>
+          <a:noFill/>
+          <a:ln/>
+        </p:spPr>
+        <p:txBody>
+          <a:bodyPr wrap="square" rtlCol="0" anchor="ctr"/>
+          <a:lstStyle/>
+          <a:p>
+            <a:pPr algn="l" indent="0" marL="0">
+              <a:buNone/>
+            </a:pPr>
+            <a:r>
+              <a:rPr lang="en-US" sz="1100" dirty="0">
+                <a:solidFill>
+                  <a:srgbClr val="9A5C15"/>
+                </a:solidFill>
+                <a:latin typeface="Courier New" pitchFamily="34" charset="0"/>
+                <a:ea typeface="Courier New" pitchFamily="34" charset="-122"/>
+                <a:cs typeface="Courier New" pitchFamily="34" charset="-120"/>
+              </a:rPr>
+              <a:t>deploy</a:t>
+            </a:r>
+            <a:endParaRPr lang="en-US" sz="1100" dirty="0"/>
+          </a:p>
+        </p:txBody>
+      </p:sp>
+      <p:sp>
+        <p:nvSpPr>
+          <p:cNvPr id="22" name="Text 20"/>
+          <p:cNvSpPr/>
+          <p:nvPr/>
+        </p:nvSpPr>
+        <p:spPr>
+          <a:xfrm>
+            <a:off x="6496812" y="4608576"/>
+            <a:ext cx="4869180" cy="457200"/>
+          </a:xfrm>
+          <a:prstGeom prst="rect">
+            <a:avLst/>
+          </a:prstGeom>
+          <a:noFill/>
+          <a:ln/>
+        </p:spPr>
+        <p:txBody>
+          <a:bodyPr wrap="square" rtlCol="0" anchor="t"/>
+          <a:lstStyle/>
+          <a:p>
+            <a:pPr algn="l" indent="0" marL="0">
+              <a:lnSpc>
+                <a:spcPct val="115000"/>
+              </a:lnSpc>
+              <a:buNone/>
+            </a:pPr>
+            <a:r>
+              <a:rPr lang="en-US" sz="1700" dirty="0">
+                <a:solidFill>
+                  <a:srgbClr val="08323B"/>
+                </a:solidFill>
+                <a:latin typeface="Cambria" pitchFamily="34" charset="0"/>
+                <a:ea typeface="Cambria" pitchFamily="34" charset="-122"/>
+                <a:cs typeface="Cambria" pitchFamily="34" charset="-120"/>
+              </a:rPr>
+              <a:t>Deploy and open the path</a:t>
+            </a:r>
+            <a:endParaRPr lang="en-US" sz="1700" dirty="0"/>
+          </a:p>
+        </p:txBody>
+      </p:sp>
+      <p:sp>
+        <p:nvSpPr>
+          <p:cNvPr id="23" name="Text 21"/>
+          <p:cNvSpPr/>
+          <p:nvPr/>
+        </p:nvSpPr>
+        <p:spPr>
+          <a:xfrm>
+            <a:off x="6496812" y="5138928"/>
+            <a:ext cx="4869180" cy="-475488"/>
+          </a:xfrm>
+          <a:prstGeom prst="rect">
+            <a:avLst/>
+          </a:prstGeom>
+          <a:noFill/>
+          <a:ln/>
+        </p:spPr>
+        <p:txBody>
+          <a:bodyPr wrap="square" rtlCol="0" anchor="t"/>
+          <a:lstStyle/>
+          <a:p>
+            <a:pPr algn="l" indent="0" marL="0">
+              <a:lnSpc>
+                <a:spcPct val="115000"/>
+              </a:lnSpc>
+              <a:buNone/>
+            </a:pPr>
+            <a:r>
+              <a:rPr lang="en-US" sz="1300" dirty="0">
+                <a:solidFill>
+                  <a:srgbClr val="56676C"/>
+                </a:solidFill>
+                <a:latin typeface="Calibri" pitchFamily="34" charset="0"/>
+                <a:ea typeface="Calibri" pitchFamily="34" charset="-122"/>
+                <a:cs typeface="Calibri" pitchFamily="34" charset="-120"/>
+              </a:rPr>
+              <a:t>Deploy lis-crs-spec-ack-svc. NetworkPolicy only. No API key in v1.</a:t>
+            </a:r>
+            <a:endParaRPr lang="en-US" sz="1300" dirty="0"/>
+          </a:p>
+        </p:txBody>
+      </p:sp>
+      <p:sp>
+        <p:nvSpPr>
+          <p:cNvPr id="24" name="Shape 22"/>
+          <p:cNvSpPr/>
+          <p:nvPr/>
+        </p:nvSpPr>
+        <p:spPr>
+          <a:xfrm>
+            <a:off x="548640" y="4983480"/>
+            <a:ext cx="11091672" cy="868680"/>
+          </a:xfrm>
+          <a:prstGeom prst="roundRect">
+            <a:avLst>
+              <a:gd name="adj" fmla="val 4211"/>
+            </a:avLst>
+          </a:prstGeom>
+          <a:solidFill>
+            <a:srgbClr val="FAEEDB"/>
+          </a:solidFill>
+          <a:ln w="12700">
+            <a:solidFill>
+              <a:srgbClr val="FAEEDB"/>
+            </a:solidFill>
+            <a:prstDash val="solid"/>
+          </a:ln>
+        </p:spPr>
+      </p:sp>
+      <p:sp>
+        <p:nvSpPr>
           <p:cNvPr id="25" name="Text 23"/>
           <p:cNvSpPr/>
           <p:nvPr/>
@@ -9176,7 +9176,7 @@
                 <a:ea typeface="Calibri" pitchFamily="34" charset="-122"/>
                 <a:cs typeface="Calibri" pitchFamily="34" charset="-120"/>
               </a:rPr>
-              <a:t>Add SORT_REG, SORT_SO, SORT_RELABEL, SORT_FAIL to the Audit Trail action filter. Still write REG and SEND_OUT.</a:t>
+              <a:t>Add SORT_* to the Audit Trail filter. Still write REG and SEND_OUT.</a:t>
             </a:r>
             <a:endParaRPr lang="en-US" sz="1400" dirty="0"/>
           </a:p>
@@ -10192,7 +10192,7 @@
                 <a:ea typeface="Calibri" pitchFamily="34" charset="-122"/>
                 <a:cs typeface="Calibri" pitchFamily="34" charset="-120"/>
               </a:rPr>
-              <a:t>Staff Spec Ack only warns. Sorter has no click (D3).</a:t>
+              <a:t>Staff Spec Ack only warns (D3).</a:t>
             </a:r>
             <a:endParaRPr lang="en-US" sz="1200" dirty="0"/>
           </a:p>
@@ -10279,7 +10279,7 @@
                 <a:ea typeface="Cambria" pitchFamily="34" charset="-122"/>
                 <a:cs typeface="Cambria" pitchFamily="34" charset="-120"/>
               </a:rPr>
-              <a:t>Print worksheets and PHLC only after Registered, after the HTTP return?</a:t>
+              <a:t>Print worksheets and PHLC only after Registered, after HTTP return?</a:t>
             </a:r>
             <a:endParaRPr lang="en-US" sz="1500" dirty="0"/>
           </a:p>
@@ -10321,7 +10321,7 @@
                 <a:ea typeface="Calibri" pitchFamily="34" charset="-122"/>
                 <a:cs typeface="Calibri" pitchFamily="34" charset="-120"/>
               </a:rPr>
-              <a:t>Matches constructSaveActions. Send-out prints nothing (D11, D4, D5).</a:t>
+              <a:t>Send-out prints nothing (D11, D4, D5).</a:t>
             </a:r>
             <a:endParaRPr lang="en-US" sz="1200" dirty="0"/>
           </a:p>
@@ -10408,7 +10408,7 @@
                 <a:ea typeface="Cambria" pitchFamily="34" charset="-122"/>
                 <a:cs typeface="Cambria" pitchFamily="34" charset="-120"/>
               </a:rPr>
-              <a:t>Show SORT_REG, SORT_SO, SORT_RELABEL, SORT_FAIL on the Audit Trail filter?</a:t>
+              <a:t>Show SORT_* actions on the Audit Trail filter?</a:t>
             </a:r>
             <a:endParaRPr lang="en-US" sz="1500" dirty="0"/>
           </a:p>
@@ -10450,7 +10450,7 @@
                 <a:ea typeface="Calibri" pitchFamily="34" charset="-122"/>
                 <a:cs typeface="Calibri" pitchFamily="34" charset="-120"/>
               </a:rPr>
-              <a:t>Still write REG and SEND_OUT as well (D6).</a:t>
+              <a:t>Still write REG and SEND_OUT (D6).</a:t>
             </a:r>
             <a:endParaRPr lang="en-US" sz="1200" dirty="0"/>
           </a:p>
@@ -10519,7 +10519,7 @@
                 <a:ea typeface="Calibri" pitchFamily="34" charset="-122"/>
                 <a:cs typeface="Calibri" pitchFamily="34" charset="-120"/>
               </a:rPr>
-              <a:t>Requester already answered D1-D11 on the design note. This room is the ratification.</a:t>
+              <a:t>Requester already answered D1-D11. This room ratifies.</a:t>
             </a:r>
             <a:endParaRPr lang="en-US" sz="1400" dirty="0"/>
           </a:p>

</xml_diff>

<commit_message>
vault backup: 2026-09-09 16:31:37
</commit_message>
<xml_diff>
--- a/SDLC/Projects/TMP-specimen-sorter-api — Specimen Sorter API/assets/Specimen Sorter API.pptx
+++ b/SDLC/Projects/TMP-specimen-sorter-api — Specimen Sorter API/assets/Specimen Sorter API.pptx
@@ -776,7 +776,7 @@
           <a:p>
             <a:r>
               <a:rPr lang="en-US" dirty="0"/>
-              <a:t>Writes are not the gap. Middleware cannot call /gcrSpecAckRegister without the packing object the screen builds today.</a:t>
+              <a:t>Writes are not the gap. Middleware cannot call /gcrSpecAckRegister without the packing the screen builds today.</a:t>
             </a:r>
             <a:endParaRPr lang="en-US" dirty="0"/>
           </a:p>
@@ -3749,7 +3749,7 @@
                 <a:ea typeface="Calibri" pitchFamily="34" charset="-122"/>
                 <a:cs typeface="Calibri" pitchFamily="34" charset="-120"/>
               </a:rPr>
-              <a:t>A USID is scanned on Specimen Acknowledgement. Staff then click Send-out or Register.</a:t>
+              <a:t>Staff scan a USID, then click Send-out or Register.</a:t>
             </a:r>
             <a:endParaRPr lang="en-US" sz="1400" dirty="0"/>
           </a:p>
@@ -4189,7 +4189,7 @@
                 <a:ea typeface="Calibri" pitchFamily="34" charset="-122"/>
                 <a:cs typeface="Calibri" pitchFamily="34" charset="-120"/>
               </a:rPr>
-              <a:t>The sorter must bin the tube from one LIS response in under four seconds.</a:t>
+              <a:t>The sorter bins the tube from one LIS response in under four seconds.</a:t>
             </a:r>
             <a:endParaRPr lang="en-US" sz="1400" dirty="0"/>
           </a:p>

</xml_diff>

<commit_message>
vault backup: 2026-09-09 16:33:53
</commit_message>
<xml_diff>
--- a/SDLC/Projects/TMP-specimen-sorter-api — Specimen Sorter API/assets/Specimen Sorter API.pptx
+++ b/SDLC/Projects/TMP-specimen-sorter-api — Specimen Sorter API/assets/Specimen Sorter API.pptx
@@ -1216,7 +1216,7 @@
           <a:p>
             <a:r>
               <a:rPr lang="en-US" dirty="0"/>
-              <a:t>Printer and STAR location come from workbench, not copied onto the map. Audit workstation is wkbh_station_name. Pilot CPS and HMS; Relabel and Failure bins go back to staff Spec Ack.</a:t>
+              <a:t>Printer and STAR location come from workbench, not copied onto the map. Audit workstation is wkbh_station_name. Still write REG and SEND_OUT. Pilot CPS and HMS; Relabel and Failure bins go back to staff Spec Ack.</a:t>
             </a:r>
             <a:endParaRPr lang="en-US" dirty="0"/>
           </a:p>
@@ -2433,7 +2433,7 @@
                 <a:ea typeface="Calibri" pitchFamily="34" charset="-122"/>
                 <a:cs typeface="Calibri" pitchFamily="34" charset="-120"/>
               </a:rPr>
-              <a:t>Design reviewed by Tony Chong  ·  reference SEM20260612  ·  production JIRA not assigned</a:t>
+              <a:t>Reviewed by Tony Chong  ·  SEM20260612  ·  JIRA not assigned</a:t>
             </a:r>
             <a:endParaRPr lang="en-US" sz="1100" dirty="0"/>
           </a:p>
@@ -8342,11 +8342,11 @@
         <p:spPr>
           <a:xfrm>
             <a:off x="548640" y="1737360"/>
-            <a:ext cx="5417820" cy="1426464"/>
+            <a:ext cx="5417820" cy="1975104"/>
           </a:xfrm>
           <a:prstGeom prst="roundRect">
             <a:avLst>
-              <a:gd name="adj" fmla="val 2564"/>
+              <a:gd name="adj" fmla="val 1852"/>
             </a:avLst>
           </a:prstGeom>
           <a:solidFill>
@@ -8414,45 +8414,6 @@
         <p:spPr>
           <a:xfrm>
             <a:off x="822960" y="2560320"/>
-            <a:ext cx="4869180" cy="274320"/>
-          </a:xfrm>
-          <a:prstGeom prst="rect">
-            <a:avLst/>
-          </a:prstGeom>
-          <a:noFill/>
-          <a:ln/>
-        </p:spPr>
-        <p:txBody>
-          <a:bodyPr wrap="square" rtlCol="0" anchor="ctr"/>
-          <a:lstStyle/>
-          <a:p>
-            <a:pPr algn="l" indent="0" marL="0">
-              <a:buNone/>
-            </a:pPr>
-            <a:r>
-              <a:rPr lang="en-US" sz="1100" dirty="0">
-                <a:solidFill>
-                  <a:srgbClr val="0B6E7F"/>
-                </a:solidFill>
-                <a:latin typeface="Courier New" pitchFamily="34" charset="0"/>
-                <a:ea typeface="Courier New" pitchFamily="34" charset="-122"/>
-                <a:cs typeface="Courier New" pitchFamily="34" charset="-120"/>
-              </a:rPr>
-              <a:t>LIS user</a:t>
-            </a:r>
-            <a:endParaRPr lang="en-US" sz="1100" dirty="0"/>
-          </a:p>
-        </p:txBody>
-      </p:sp>
-      <p:sp>
-        <p:nvSpPr>
-          <p:cNvPr id="7" name="Text 5"/>
-          <p:cNvSpPr/>
-          <p:nvPr/>
-        </p:nvSpPr>
-        <p:spPr>
-          <a:xfrm>
-            <a:off x="822960" y="2926080"/>
             <a:ext cx="4869180" cy="457200"/>
           </a:xfrm>
           <a:prstGeom prst="rect">
@@ -8488,14 +8449,14 @@
       </p:sp>
       <p:sp>
         <p:nvSpPr>
-          <p:cNvPr id="8" name="Text 6"/>
-          <p:cNvSpPr/>
-          <p:nvPr/>
-        </p:nvSpPr>
-        <p:spPr>
-          <a:xfrm>
-            <a:off x="822960" y="3456432"/>
-            <a:ext cx="4869180" cy="-475488"/>
+          <p:cNvPr id="7" name="Text 5"/>
+          <p:cNvSpPr/>
+          <p:nvPr/>
+        </p:nvSpPr>
+        <p:spPr>
+          <a:xfrm>
+            <a:off x="822960" y="3090672"/>
+            <a:ext cx="4869180" cy="438912"/>
           </a:xfrm>
           <a:prstGeom prst="rect">
             <a:avLst/>
@@ -8530,18 +8491,18 @@
       </p:sp>
       <p:sp>
         <p:nvSpPr>
-          <p:cNvPr id="9" name="Shape 7"/>
+          <p:cNvPr id="8" name="Shape 6"/>
           <p:cNvSpPr/>
           <p:nvPr/>
         </p:nvSpPr>
         <p:spPr>
           <a:xfrm>
             <a:off x="6222492" y="1737360"/>
-            <a:ext cx="5417820" cy="1426464"/>
+            <a:ext cx="5417820" cy="1975104"/>
           </a:xfrm>
           <a:prstGeom prst="roundRect">
             <a:avLst>
-              <a:gd name="adj" fmla="val 2564"/>
+              <a:gd name="adj" fmla="val 1852"/>
             </a:avLst>
           </a:prstGeom>
           <a:solidFill>
@@ -8557,7 +8518,7 @@
       </p:sp>
       <p:sp>
         <p:nvSpPr>
-          <p:cNvPr id="10" name="Text 8"/>
+          <p:cNvPr id="9" name="Text 7"/>
           <p:cNvSpPr/>
           <p:nvPr/>
         </p:nvSpPr>
@@ -8602,52 +8563,13 @@
       </p:sp>
       <p:sp>
         <p:nvSpPr>
-          <p:cNvPr id="11" name="Text 9"/>
+          <p:cNvPr id="10" name="Text 8"/>
           <p:cNvSpPr/>
           <p:nvPr/>
         </p:nvSpPr>
         <p:spPr>
           <a:xfrm>
             <a:off x="6496812" y="2560320"/>
-            <a:ext cx="4869180" cy="274320"/>
-          </a:xfrm>
-          <a:prstGeom prst="rect">
-            <a:avLst/>
-          </a:prstGeom>
-          <a:noFill/>
-          <a:ln/>
-        </p:spPr>
-        <p:txBody>
-          <a:bodyPr wrap="square" rtlCol="0" anchor="ctr"/>
-          <a:lstStyle/>
-          <a:p>
-            <a:pPr algn="l" indent="0" marL="0">
-              <a:buNone/>
-            </a:pPr>
-            <a:r>
-              <a:rPr lang="en-US" sz="1100" dirty="0">
-                <a:solidFill>
-                  <a:srgbClr val="56676C"/>
-                </a:solidFill>
-                <a:latin typeface="Courier New" pitchFamily="34" charset="0"/>
-                <a:ea typeface="Courier New" pitchFamily="34" charset="-122"/>
-                <a:cs typeface="Courier New" pitchFamily="34" charset="-120"/>
-              </a:rPr>
-              <a:t>workbench</a:t>
-            </a:r>
-            <a:endParaRPr lang="en-US" sz="1100" dirty="0"/>
-          </a:p>
-        </p:txBody>
-      </p:sp>
-      <p:sp>
-        <p:nvSpPr>
-          <p:cNvPr id="12" name="Text 10"/>
-          <p:cNvSpPr/>
-          <p:nvPr/>
-        </p:nvSpPr>
-        <p:spPr>
-          <a:xfrm>
-            <a:off x="6496812" y="2926080"/>
             <a:ext cx="4869180" cy="457200"/>
           </a:xfrm>
           <a:prstGeom prst="rect">
@@ -8683,14 +8605,14 @@
       </p:sp>
       <p:sp>
         <p:nvSpPr>
-          <p:cNvPr id="13" name="Text 11"/>
-          <p:cNvSpPr/>
-          <p:nvPr/>
-        </p:nvSpPr>
-        <p:spPr>
-          <a:xfrm>
-            <a:off x="6496812" y="3456432"/>
-            <a:ext cx="4869180" cy="-475488"/>
+          <p:cNvPr id="11" name="Text 9"/>
+          <p:cNvSpPr/>
+          <p:nvPr/>
+        </p:nvSpPr>
+        <p:spPr>
+          <a:xfrm>
+            <a:off x="6496812" y="3090672"/>
+            <a:ext cx="4869180" cy="438912"/>
           </a:xfrm>
           <a:prstGeom prst="rect">
             <a:avLst/>
@@ -8725,18 +8647,18 @@
       </p:sp>
       <p:sp>
         <p:nvSpPr>
-          <p:cNvPr id="14" name="Shape 12"/>
-          <p:cNvSpPr/>
-          <p:nvPr/>
-        </p:nvSpPr>
-        <p:spPr>
-          <a:xfrm>
-            <a:off x="548640" y="3419856"/>
-            <a:ext cx="5417820" cy="1426464"/>
+          <p:cNvPr id="12" name="Shape 10"/>
+          <p:cNvSpPr/>
+          <p:nvPr/>
+        </p:nvSpPr>
+        <p:spPr>
+          <a:xfrm>
+            <a:off x="548640" y="3968496"/>
+            <a:ext cx="5417820" cy="1975104"/>
           </a:xfrm>
           <a:prstGeom prst="roundRect">
             <a:avLst>
-              <a:gd name="adj" fmla="val 2564"/>
+              <a:gd name="adj" fmla="val 1852"/>
             </a:avLst>
           </a:prstGeom>
           <a:solidFill>
@@ -8752,13 +8674,13 @@
       </p:sp>
       <p:sp>
         <p:nvSpPr>
-          <p:cNvPr id="15" name="Text 13"/>
-          <p:cNvSpPr/>
-          <p:nvPr/>
-        </p:nvSpPr>
-        <p:spPr>
-          <a:xfrm>
-            <a:off x="822960" y="3675888"/>
+          <p:cNvPr id="13" name="Text 11"/>
+          <p:cNvSpPr/>
+          <p:nvPr/>
+        </p:nvSpPr>
+        <p:spPr>
+          <a:xfrm>
+            <a:off x="822960" y="4224528"/>
             <a:ext cx="384048" cy="384048"/>
           </a:xfrm>
           <a:prstGeom prst="ellipse">
@@ -8797,52 +8719,13 @@
       </p:sp>
       <p:sp>
         <p:nvSpPr>
-          <p:cNvPr id="16" name="Text 14"/>
-          <p:cNvSpPr/>
-          <p:nvPr/>
-        </p:nvSpPr>
-        <p:spPr>
-          <a:xfrm>
-            <a:off x="822960" y="4242816"/>
-            <a:ext cx="4869180" cy="274320"/>
-          </a:xfrm>
-          <a:prstGeom prst="rect">
-            <a:avLst/>
-          </a:prstGeom>
-          <a:noFill/>
-          <a:ln/>
-        </p:spPr>
-        <p:txBody>
-          <a:bodyPr wrap="square" rtlCol="0" anchor="ctr"/>
-          <a:lstStyle/>
-          <a:p>
-            <a:pPr algn="l" indent="0" marL="0">
-              <a:buNone/>
-            </a:pPr>
-            <a:r>
-              <a:rPr lang="en-US" sz="1100" dirty="0">
-                <a:solidFill>
-                  <a:srgbClr val="56676C"/>
-                </a:solidFill>
-                <a:latin typeface="Courier New" pitchFamily="34" charset="0"/>
-                <a:ea typeface="Courier New" pitchFamily="34" charset="-122"/>
-                <a:cs typeface="Courier New" pitchFamily="34" charset="-120"/>
-              </a:rPr>
-              <a:t>loe_sorter_map</a:t>
-            </a:r>
-            <a:endParaRPr lang="en-US" sz="1100" dirty="0"/>
-          </a:p>
-        </p:txBody>
-      </p:sp>
-      <p:sp>
-        <p:nvSpPr>
-          <p:cNvPr id="17" name="Text 15"/>
-          <p:cNvSpPr/>
-          <p:nvPr/>
-        </p:nvSpPr>
-        <p:spPr>
-          <a:xfrm>
-            <a:off x="822960" y="4608576"/>
+          <p:cNvPr id="14" name="Text 12"/>
+          <p:cNvSpPr/>
+          <p:nvPr/>
+        </p:nvSpPr>
+        <p:spPr>
+          <a:xfrm>
+            <a:off x="822960" y="4791456"/>
             <a:ext cx="4869180" cy="457200"/>
           </a:xfrm>
           <a:prstGeom prst="rect">
@@ -8878,14 +8761,14 @@
       </p:sp>
       <p:sp>
         <p:nvSpPr>
-          <p:cNvPr id="18" name="Text 16"/>
-          <p:cNvSpPr/>
-          <p:nvPr/>
-        </p:nvSpPr>
-        <p:spPr>
-          <a:xfrm>
-            <a:off x="822960" y="5138928"/>
-            <a:ext cx="4869180" cy="-475488"/>
+          <p:cNvPr id="15" name="Text 13"/>
+          <p:cNvSpPr/>
+          <p:nvPr/>
+        </p:nvSpPr>
+        <p:spPr>
+          <a:xfrm>
+            <a:off x="822960" y="5321808"/>
+            <a:ext cx="4869180" cy="438912"/>
           </a:xfrm>
           <a:prstGeom prst="rect">
             <a:avLst/>
@@ -8912,7 +8795,7 @@
                 <a:ea typeface="Calibri" pitchFamily="34" charset="-122"/>
                 <a:cs typeface="Calibri" pitchFamily="34" charset="-120"/>
               </a:rPr>
-              <a:t>Sorter id, user, workbench id, lab, hosp, server name.</a:t>
+              <a:t>Sorter id, user, workbench id, lab, hosp, server name on loe_sorter_map.</a:t>
             </a:r>
             <a:endParaRPr lang="en-US" sz="1300" dirty="0"/>
           </a:p>
@@ -8920,18 +8803,18 @@
       </p:sp>
       <p:sp>
         <p:nvSpPr>
-          <p:cNvPr id="19" name="Shape 17"/>
-          <p:cNvSpPr/>
-          <p:nvPr/>
-        </p:nvSpPr>
-        <p:spPr>
-          <a:xfrm>
-            <a:off x="6222492" y="3419856"/>
-            <a:ext cx="5417820" cy="1426464"/>
+          <p:cNvPr id="16" name="Shape 14"/>
+          <p:cNvSpPr/>
+          <p:nvPr/>
+        </p:nvSpPr>
+        <p:spPr>
+          <a:xfrm>
+            <a:off x="6222492" y="3968496"/>
+            <a:ext cx="5417820" cy="1975104"/>
           </a:xfrm>
           <a:prstGeom prst="roundRect">
             <a:avLst>
-              <a:gd name="adj" fmla="val 2564"/>
+              <a:gd name="adj" fmla="val 1852"/>
             </a:avLst>
           </a:prstGeom>
           <a:solidFill>
@@ -8947,13 +8830,13 @@
       </p:sp>
       <p:sp>
         <p:nvSpPr>
-          <p:cNvPr id="20" name="Text 18"/>
-          <p:cNvSpPr/>
-          <p:nvPr/>
-        </p:nvSpPr>
-        <p:spPr>
-          <a:xfrm>
-            <a:off x="6496812" y="3675888"/>
+          <p:cNvPr id="17" name="Text 15"/>
+          <p:cNvSpPr/>
+          <p:nvPr/>
+        </p:nvSpPr>
+        <p:spPr>
+          <a:xfrm>
+            <a:off x="6496812" y="4224528"/>
             <a:ext cx="384048" cy="384048"/>
           </a:xfrm>
           <a:prstGeom prst="ellipse">
@@ -8992,52 +8875,13 @@
       </p:sp>
       <p:sp>
         <p:nvSpPr>
-          <p:cNvPr id="21" name="Text 19"/>
-          <p:cNvSpPr/>
-          <p:nvPr/>
-        </p:nvSpPr>
-        <p:spPr>
-          <a:xfrm>
-            <a:off x="6496812" y="4242816"/>
-            <a:ext cx="4869180" cy="274320"/>
-          </a:xfrm>
-          <a:prstGeom prst="rect">
-            <a:avLst/>
-          </a:prstGeom>
-          <a:noFill/>
-          <a:ln/>
-        </p:spPr>
-        <p:txBody>
-          <a:bodyPr wrap="square" rtlCol="0" anchor="ctr"/>
-          <a:lstStyle/>
-          <a:p>
-            <a:pPr algn="l" indent="0" marL="0">
-              <a:buNone/>
-            </a:pPr>
-            <a:r>
-              <a:rPr lang="en-US" sz="1100" dirty="0">
-                <a:solidFill>
-                  <a:srgbClr val="9A5C15"/>
-                </a:solidFill>
-                <a:latin typeface="Courier New" pitchFamily="34" charset="0"/>
-                <a:ea typeface="Courier New" pitchFamily="34" charset="-122"/>
-                <a:cs typeface="Courier New" pitchFamily="34" charset="-120"/>
-              </a:rPr>
-              <a:t>deploy</a:t>
-            </a:r>
-            <a:endParaRPr lang="en-US" sz="1100" dirty="0"/>
-          </a:p>
-        </p:txBody>
-      </p:sp>
-      <p:sp>
-        <p:nvSpPr>
-          <p:cNvPr id="22" name="Text 20"/>
-          <p:cNvSpPr/>
-          <p:nvPr/>
-        </p:nvSpPr>
-        <p:spPr>
-          <a:xfrm>
-            <a:off x="6496812" y="4608576"/>
+          <p:cNvPr id="18" name="Text 16"/>
+          <p:cNvSpPr/>
+          <p:nvPr/>
+        </p:nvSpPr>
+        <p:spPr>
+          <a:xfrm>
+            <a:off x="6496812" y="4791456"/>
             <a:ext cx="4869180" cy="457200"/>
           </a:xfrm>
           <a:prstGeom prst="rect">
@@ -9073,14 +8917,14 @@
       </p:sp>
       <p:sp>
         <p:nvSpPr>
-          <p:cNvPr id="23" name="Text 21"/>
-          <p:cNvSpPr/>
-          <p:nvPr/>
-        </p:nvSpPr>
-        <p:spPr>
-          <a:xfrm>
-            <a:off x="6496812" y="5138928"/>
-            <a:ext cx="4869180" cy="-475488"/>
+          <p:cNvPr id="19" name="Text 17"/>
+          <p:cNvSpPr/>
+          <p:nvPr/>
+        </p:nvSpPr>
+        <p:spPr>
+          <a:xfrm>
+            <a:off x="6496812" y="5321808"/>
+            <a:ext cx="4869180" cy="438912"/>
           </a:xfrm>
           <a:prstGeom prst="rect">
             <a:avLst/>
@@ -9107,7 +8951,7 @@
                 <a:ea typeface="Calibri" pitchFamily="34" charset="-122"/>
                 <a:cs typeface="Calibri" pitchFamily="34" charset="-120"/>
               </a:rPr>
-              <a:t>Deploy lis-crs-spec-ack-svc. NetworkPolicy only. No API key in v1.</a:t>
+              <a:t>Deploy lis-crs-spec-ack-svc. NetworkPolicy only. Add SORT_* to the Audit Trail filter.</a:t>
             </a:r>
             <a:endParaRPr lang="en-US" sz="1300" dirty="0"/>
           </a:p>
@@ -9115,76 +8959,7 @@
       </p:sp>
       <p:sp>
         <p:nvSpPr>
-          <p:cNvPr id="24" name="Shape 22"/>
-          <p:cNvSpPr/>
-          <p:nvPr/>
-        </p:nvSpPr>
-        <p:spPr>
-          <a:xfrm>
-            <a:off x="548640" y="4983480"/>
-            <a:ext cx="11091672" cy="868680"/>
-          </a:xfrm>
-          <a:prstGeom prst="roundRect">
-            <a:avLst>
-              <a:gd name="adj" fmla="val 4211"/>
-            </a:avLst>
-          </a:prstGeom>
-          <a:solidFill>
-            <a:srgbClr val="FAEEDB"/>
-          </a:solidFill>
-          <a:ln w="12700">
-            <a:solidFill>
-              <a:srgbClr val="FAEEDB"/>
-            </a:solidFill>
-            <a:prstDash val="solid"/>
-          </a:ln>
-        </p:spPr>
-      </p:sp>
-      <p:sp>
-        <p:nvSpPr>
-          <p:cNvPr id="25" name="Text 23"/>
-          <p:cNvSpPr/>
-          <p:nvPr/>
-        </p:nvSpPr>
-        <p:spPr>
-          <a:xfrm>
-            <a:off x="868680" y="5120640"/>
-            <a:ext cx="10424160" cy="594360"/>
-          </a:xfrm>
-          <a:prstGeom prst="rect">
-            <a:avLst/>
-          </a:prstGeom>
-          <a:noFill/>
-          <a:ln/>
-        </p:spPr>
-        <p:txBody>
-          <a:bodyPr wrap="square" rtlCol="0" anchor="ctr"/>
-          <a:lstStyle/>
-          <a:p>
-            <a:pPr algn="l" indent="0" marL="0">
-              <a:lnSpc>
-                <a:spcPct val="120000"/>
-              </a:lnSpc>
-              <a:buNone/>
-            </a:pPr>
-            <a:r>
-              <a:rPr lang="en-US" sz="1400" dirty="0">
-                <a:solidFill>
-                  <a:srgbClr val="08323B"/>
-                </a:solidFill>
-                <a:latin typeface="Calibri" pitchFamily="34" charset="0"/>
-                <a:ea typeface="Calibri" pitchFamily="34" charset="-122"/>
-                <a:cs typeface="Calibri" pitchFamily="34" charset="-120"/>
-              </a:rPr>
-              <a:t>Add SORT_* to the Audit Trail filter. Still write REG and SEND_OUT.</a:t>
-            </a:r>
-            <a:endParaRPr lang="en-US" sz="1400" dirty="0"/>
-          </a:p>
-        </p:txBody>
-      </p:sp>
-      <p:sp>
-        <p:nvSpPr>
-          <p:cNvPr id="26" name="Text 24"/>
+          <p:cNvPr id="20" name="Text 18"/>
           <p:cNvSpPr/>
           <p:nvPr/>
         </p:nvSpPr>

</xml_diff>

<commit_message>
vault backup: 2026-09-09 16:55:23
</commit_message>
<xml_diff>
--- a/SDLC/Projects/TMP-specimen-sorter-api — Specimen Sorter API/assets/Specimen Sorter API.pptx
+++ b/SDLC/Projects/TMP-specimen-sorter-api — Specimen Sorter API/assets/Specimen Sorter API.pptx
@@ -600,7 +600,7 @@
           <a:p>
             <a:r>
               <a:rPr lang="en-US" dirty="0"/>
-              <a:t>Likely questions: why not overload /gcrSpecAckRegister; why DFT skips /api/dftreg; why workbench lab is not checked against the test lab.</a:t>
+              <a:t>Likely questions: why not reuse the staff register API; why DFT does not use a separate DFT API; why workbench lab is not checked against the test lab.</a:t>
             </a:r>
             <a:endParaRPr lang="en-US" dirty="0"/>
           </a:p>
@@ -776,7 +776,7 @@
           <a:p>
             <a:r>
               <a:rPr lang="en-US" dirty="0"/>
-              <a:t>Writes are not the gap. Middleware cannot call /gcrSpecAckRegister without the packing the screen builds today.</a:t>
+              <a:t>Writes are not the gap. Middleware cannot call staff register without the payload the screen builds today.</a:t>
             </a:r>
             <a:endParaRPr lang="en-US" dirty="0"/>
           </a:p>
@@ -864,7 +864,7 @@
           <a:p>
             <a:r>
               <a:rPr lang="en-US" dirty="0"/>
-              <a:t>Overloading /gcrSpecAckRegister would keep the staff packing contract. Overloading ECPath5 register would keep a hard-coded user. The convertor has to move or the caller invents a second packing shape.</a:t>
+              <a:t>Staff register keeps screen packing. ECPath5 register keeps a hard-coded user.</a:t>
             </a:r>
             <a:endParaRPr lang="en-US" dirty="0"/>
           </a:p>
@@ -952,7 +952,7 @@
           <a:p>
             <a:r>
               <a:rPr lang="en-US" dirty="0"/>
-              <a:t>STAR with no wkbh_location is Failure 4422. Mixed local and send-out is Failure, not ALS. DFT uses the same Spec Ack register() packing.</a:t>
+              <a:t>STAR with no workbench location is Failure. Mixed local and send-out is Failure, not a warning. DFT uses the same Spec Ack register packing as an ordinary specimen.</a:t>
             </a:r>
             <a:endParaRPr lang="en-US" dirty="0"/>
           </a:p>
@@ -1040,7 +1040,7 @@
           <a:p>
             <a:r>
               <a:rPr lang="en-US" dirty="0"/>
-              <a:t>register() already assumes this packing. Skipping the convertor and porting only the validator still leaves an empty test-group list.</a:t>
+              <a:t>Moving only the hard checks still leaves an empty test-group list.</a:t>
             </a:r>
             <a:endParaRPr lang="en-US" dirty="0"/>
           </a:p>
@@ -1128,7 +1128,7 @@
           <a:p>
             <a:r>
               <a:rPr lang="en-US" dirty="0"/>
-              <a:t>Spec Ack sendOutActions never prints. The ack auto-print flag is not used. Staff picker goes away: print all on the registration path.</a:t>
+              <a:t>Send-out never prints. The ack auto-print flag is not used. Staff picker goes away: print all on the registration path.</a:t>
             </a:r>
             <a:endParaRPr lang="en-US" dirty="0"/>
           </a:p>
@@ -1216,7 +1216,7 @@
           <a:p>
             <a:r>
               <a:rPr lang="en-US" dirty="0"/>
-              <a:t>Printer and STAR location come from workbench, not copied onto the map. Audit workstation is wkbh_station_name. Still write REG and SEND_OUT. Pilot CPS and HMS; Relabel and Failure bins go back to staff Spec Ack.</a:t>
+              <a:t>Printer and STAR location come from workbench, not copied onto the map. Audit workstation is the workbench station name. Still write REG and SEND_OUT. Pilot CPS and HMS; Relabel and Failure bins go back to staff Spec Ack.</a:t>
             </a:r>
             <a:endParaRPr lang="en-US" dirty="0"/>
           </a:p>
@@ -1905,7 +1905,7 @@
                 <a:ea typeface="Calibri" pitchFamily="34" charset="-122"/>
                 <a:cs typeface="Calibri" pitchFamily="34" charset="-120"/>
               </a:rPr>
-              <a:t>Sorter middleware calls lis-crs-spec-ack-svc. Flex packing, alerts, and hard checks move behind that call. Staff Spec Ack stays as the fallback.</a:t>
+              <a:t>Sorter middleware calls the Specimen Acknowledgement service. Soft alerts, hard checks, and packing move behind that call. Staff Spec Ack stays as the fallback.</a:t>
             </a:r>
             <a:endParaRPr lang="en-US" sz="1500" dirty="0"/>
           </a:p>
@@ -3145,7 +3145,7 @@
                 <a:ea typeface="Calibri" pitchFamily="34" charset="-122"/>
                 <a:cs typeface="Calibri" pitchFamily="34" charset="-120"/>
               </a:rPr>
-              <a:t>New orchestrator on lis-crs-spec-ack-svc, including the packing convertor.</a:t>
+              <a:t>New orchestrator on lis-crs-spec-ack-svc, including the packing the screen does today.</a:t>
             </a:r>
             <a:endParaRPr lang="en-US" sz="1200" dirty="0"/>
           </a:p>
@@ -3969,7 +3969,7 @@
                 <a:ea typeface="Calibri" pitchFamily="34" charset="-122"/>
                 <a:cs typeface="Calibri" pitchFamily="34" charset="-120"/>
               </a:rPr>
-              <a:t>Lookup and writes live in the Spec Ack service. Packing still sits in Flex.</a:t>
+              <a:t>Lookup and writes live in Spec Ack. The screen still builds the register payload.</a:t>
             </a:r>
             <a:endParaRPr lang="en-US" sz="1400" dirty="0"/>
           </a:p>
@@ -4258,7 +4258,7 @@
                 <a:ea typeface="Calibri" pitchFamily="34" charset="-122"/>
                 <a:cs typeface="Calibri" pitchFamily="34" charset="-120"/>
               </a:rPr>
-              <a:t>Do not use the staff GET:  </a:t>
+              <a:t>Do not reuse staff retrieve:  </a:t>
             </a:r>
             <a:pPr algn="l" indent="0" marL="0">
               <a:lnSpc>
@@ -4275,7 +4275,7 @@
                 <a:ea typeface="Calibri" pitchFamily="34" charset="-122"/>
                 <a:cs typeface="Calibri" pitchFamily="34" charset="-120"/>
               </a:rPr>
-              <a:t>GET /retrieveGcrOrder hard-codes user ltc611. Do not call it.</a:t>
+              <a:t>That call is tied to a fixed user.</a:t>
             </a:r>
             <a:endParaRPr lang="en-US" sz="1400" dirty="0"/>
           </a:p>
@@ -4570,7 +4570,7 @@
                 <a:ea typeface="Courier New" pitchFamily="34" charset="-122"/>
                 <a:cs typeface="Courier New" pitchFamily="34" charset="-120"/>
               </a:rPr>
-              <a:t>promptAlert</a:t>
+              <a:t>soft alerts</a:t>
             </a:r>
             <a:endParaRPr lang="en-US" sz="1150" dirty="0"/>
           </a:p>
@@ -4587,7 +4587,7 @@
                 <a:ea typeface="Courier New" pitchFamily="34" charset="-122"/>
                 <a:cs typeface="Courier New" pitchFamily="34" charset="-120"/>
               </a:rPr>
-              <a:t>GcrSpecAckDataValidator</a:t>
+              <a:t>hard checks</a:t>
             </a:r>
             <a:endParaRPr lang="en-US" sz="1150" dirty="0"/>
           </a:p>
@@ -4604,7 +4604,7 @@
                 <a:ea typeface="Courier New" pitchFamily="34" charset="-122"/>
                 <a:cs typeface="Courier New" pitchFamily="34" charset="-120"/>
               </a:rPr>
-              <a:t>GcrSpecAckDataConvertor</a:t>
+              <a:t>register packing</a:t>
             </a:r>
             <a:endParaRPr lang="en-US" sz="1150" dirty="0"/>
           </a:p>
@@ -4646,7 +4646,7 @@
                 <a:ea typeface="Calibri" pitchFamily="34" charset="-122"/>
                 <a:cs typeface="Calibri" pitchFamily="34" charset="-120"/>
               </a:rPr>
-              <a:t>·  Staff click send-out or register with that packing</a:t>
+              <a:t>·  Staff click after the screen packs the payload</a:t>
             </a:r>
             <a:endParaRPr lang="en-US" sz="1300" dirty="0"/>
           </a:p>
@@ -4686,7 +4686,7 @@
                 <a:ea typeface="Calibri" pitchFamily="34" charset="-122"/>
                 <a:cs typeface="Calibri" pitchFamily="34" charset="-120"/>
               </a:rPr>
-              <a:t>·  GET retrieve hard-codes ltc611</a:t>
+              <a:t>·  Staff retrieve is tied to a fixed user</a:t>
             </a:r>
             <a:endParaRPr lang="en-US" sz="1300" dirty="0"/>
           </a:p>
@@ -4878,7 +4878,7 @@
                 <a:ea typeface="Calibri" pitchFamily="34" charset="-122"/>
                 <a:cs typeface="Calibri" pitchFamily="34" charset="-120"/>
               </a:rPr>
-              <a:t>·  Convertor, validator, and ALS alerts run on the server</a:t>
+              <a:t>·  Alerts, hard checks, and packing run on the server</a:t>
             </a:r>
             <a:endParaRPr lang="en-US" sz="1300" dirty="0"/>
           </a:p>
@@ -4898,7 +4898,7 @@
                 <a:ea typeface="Calibri" pitchFamily="34" charset="-122"/>
                 <a:cs typeface="Calibri" pitchFamily="34" charset="-120"/>
               </a:rPr>
-              <a:t>·  Reuse retrieve, sendOutSpecimen, register, worksheet, PHLC</a:t>
+              <a:t>·  Reuse retrieve, send-out, register, worksheet, and PHLC</a:t>
             </a:r>
             <a:endParaRPr lang="en-US" sz="1300" dirty="0"/>
           </a:p>
@@ -4918,7 +4918,7 @@
                 <a:ea typeface="Calibri" pitchFamily="34" charset="-122"/>
                 <a:cs typeface="Calibri" pitchFamily="34" charset="-120"/>
               </a:rPr>
-              <a:t>·  Staff APIs stay as they are</a:t>
+              <a:t>·  Staff screen stays as it is</a:t>
             </a:r>
             <a:endParaRPr lang="en-US" sz="1300" dirty="0"/>
           </a:p>
@@ -4987,7 +4987,7 @@
                 <a:ea typeface="Calibri" pitchFamily="34" charset="-122"/>
                 <a:cs typeface="Calibri" pitchFamily="34" charset="-120"/>
               </a:rPr>
-              <a:t>Do not overload /gcrSpecAckRegister or the ECPath5 register. Both keep the wrong caller contract.</a:t>
+              <a:t>Do not reuse staff register or ECPath5 register. Both expect a different caller.</a:t>
             </a:r>
             <a:endParaRPr lang="en-US" sz="1400" dirty="0"/>
           </a:p>
@@ -5132,7 +5132,7 @@
                 <a:ea typeface="Cambria" pitchFamily="34" charset="-122"/>
                 <a:cs typeface="Cambria" pitchFamily="34" charset="-120"/>
               </a:rPr>
-              <a:t>A new POST orchestrates retrieve, convert, then write</a:t>
+              <a:t>A new POST looks up, packs, then writes</a:t>
             </a:r>
             <a:endParaRPr lang="en-US" sz="3000" dirty="0"/>
           </a:p>
@@ -5643,7 +5643,7 @@
                 <a:ea typeface="Calibri" pitchFamily="34" charset="-122"/>
                 <a:cs typeface="Calibri" pitchFamily="34" charset="-120"/>
               </a:rPr>
-              <a:t>SEND_OUT if all tests</a:t>
+              <a:t>SEND_OUT if every test</a:t>
             </a:r>
             <a:endParaRPr lang="en-US" sz="1150" dirty="0"/>
           </a:p>
@@ -5660,7 +5660,7 @@
                 <a:ea typeface="Calibri" pitchFamily="34" charset="-122"/>
                 <a:cs typeface="Calibri" pitchFamily="34" charset="-120"/>
               </a:rPr>
-              <a:t>in LOE_SENDOUT_TEST</a:t>
+              <a:t>is a send-out test</a:t>
             </a:r>
             <a:endParaRPr lang="en-US" sz="1150" dirty="0"/>
           </a:p>
@@ -5741,7 +5741,7 @@
                 <a:ea typeface="Calibri" pitchFamily="34" charset="-122"/>
                 <a:cs typeface="Calibri" pitchFamily="34" charset="-120"/>
               </a:rPr>
-              <a:t>Unknown sorter, APS/BBS/MBS, mixed tests, STAR 4422</a:t>
+              <a:t>Unknown sorter, APS/BBS/MBS, mixed tests, STAR with no location</a:t>
             </a:r>
             <a:endParaRPr lang="en-US" sz="1200" dirty="0"/>
           </a:p>
@@ -5913,7 +5913,7 @@
                 <a:ea typeface="Courier New" pitchFamily="34" charset="-122"/>
                 <a:cs typeface="Courier New" pitchFamily="34" charset="-120"/>
               </a:rPr>
-              <a:t>DFT -&gt; Spec Ack register(), not /api/dftreg</a:t>
+              <a:t>DFT uses ordinary Spec Ack register</a:t>
             </a:r>
             <a:endParaRPr lang="en-US" sz="1300" dirty="0"/>
           </a:p>
@@ -6100,7 +6100,7 @@
                 <a:ea typeface="Cambria" pitchFamily="34" charset="-122"/>
                 <a:cs typeface="Cambria" pitchFamily="34" charset="-120"/>
               </a:rPr>
-              <a:t>The Flex convertor moves behind the API</a:t>
+              <a:t>What the screen packs today moves behind the API</a:t>
             </a:r>
             <a:endParaRPr lang="en-US" sz="3000" dirty="0"/>
           </a:p>
@@ -6114,12 +6114,480 @@
         </p:nvSpPr>
         <p:spPr>
           <a:xfrm>
-            <a:off x="548640" y="1691640"/>
-            <a:ext cx="5532120" cy="3200400"/>
+            <a:off x="548640" y="1737360"/>
+            <a:ext cx="7635240" cy="1097280"/>
           </a:xfrm>
           <a:prstGeom prst="roundRect">
             <a:avLst>
-              <a:gd name="adj" fmla="val 1143"/>
+              <a:gd name="adj" fmla="val 3333"/>
+            </a:avLst>
+          </a:prstGeom>
+          <a:solidFill>
+            <a:srgbClr val="F1F3F3"/>
+          </a:solidFill>
+          <a:ln w="12700">
+            <a:solidFill>
+              <a:srgbClr val="F1F3F3"/>
+            </a:solidFill>
+            <a:prstDash val="solid"/>
+          </a:ln>
+        </p:spPr>
+      </p:sp>
+      <p:sp>
+        <p:nvSpPr>
+          <p:cNvPr id="5" name="Text 3"/>
+          <p:cNvSpPr/>
+          <p:nvPr/>
+        </p:nvSpPr>
+        <p:spPr>
+          <a:xfrm>
+            <a:off x="841248" y="2093976"/>
+            <a:ext cx="384048" cy="384048"/>
+          </a:xfrm>
+          <a:prstGeom prst="ellipse">
+            <a:avLst/>
+          </a:prstGeom>
+          <a:solidFill>
+            <a:srgbClr val="0B6E7F"/>
+          </a:solidFill>
+          <a:ln>
+            <a:solidFill>
+              <a:srgbClr val="0B6E7F"/>
+            </a:solidFill>
+          </a:ln>
+        </p:spPr>
+        <p:txBody>
+          <a:bodyPr wrap="square" rtlCol="0" anchor="ctr"/>
+          <a:lstStyle/>
+          <a:p>
+            <a:pPr algn="ctr" indent="0" marL="0">
+              <a:buNone/>
+            </a:pPr>
+            <a:r>
+              <a:rPr lang="en-US" sz="1300" b="1" dirty="0">
+                <a:solidFill>
+                  <a:srgbClr val="FFFFFF"/>
+                </a:solidFill>
+                <a:latin typeface="Calibri" pitchFamily="34" charset="0"/>
+                <a:ea typeface="Calibri" pitchFamily="34" charset="-122"/>
+                <a:cs typeface="Calibri" pitchFamily="34" charset="-120"/>
+              </a:rPr>
+              <a:t>1</a:t>
+            </a:r>
+            <a:endParaRPr lang="en-US" sz="1300" dirty="0"/>
+          </a:p>
+        </p:txBody>
+      </p:sp>
+      <p:sp>
+        <p:nvSpPr>
+          <p:cNvPr id="6" name="Text 4"/>
+          <p:cNvSpPr/>
+          <p:nvPr/>
+        </p:nvSpPr>
+        <p:spPr>
+          <a:xfrm>
+            <a:off x="1389888" y="1920240"/>
+            <a:ext cx="4754880" cy="310896"/>
+          </a:xfrm>
+          <a:prstGeom prst="rect">
+            <a:avLst/>
+          </a:prstGeom>
+          <a:noFill/>
+          <a:ln/>
+        </p:spPr>
+        <p:txBody>
+          <a:bodyPr wrap="square" rtlCol="0" anchor="t"/>
+          <a:lstStyle/>
+          <a:p>
+            <a:pPr algn="l" indent="0" marL="0">
+              <a:lnSpc>
+                <a:spcPct val="115000"/>
+              </a:lnSpc>
+              <a:buNone/>
+            </a:pPr>
+            <a:r>
+              <a:rPr lang="en-US" sz="1600" dirty="0">
+                <a:solidFill>
+                  <a:srgbClr val="08323B"/>
+                </a:solidFill>
+                <a:latin typeface="Calibri" pitchFamily="34" charset="0"/>
+                <a:ea typeface="Calibri" pitchFamily="34" charset="-122"/>
+                <a:cs typeface="Calibri" pitchFamily="34" charset="-120"/>
+              </a:rPr>
+              <a:t>Group tests and assign the request number</a:t>
+            </a:r>
+            <a:endParaRPr lang="en-US" sz="1600" dirty="0"/>
+          </a:p>
+        </p:txBody>
+      </p:sp>
+      <p:sp>
+        <p:nvSpPr>
+          <p:cNvPr id="7" name="Text 5"/>
+          <p:cNvSpPr/>
+          <p:nvPr/>
+        </p:nvSpPr>
+        <p:spPr>
+          <a:xfrm>
+            <a:off x="1389888" y="2249424"/>
+            <a:ext cx="5852160" cy="566928"/>
+          </a:xfrm>
+          <a:prstGeom prst="rect">
+            <a:avLst/>
+          </a:prstGeom>
+          <a:noFill/>
+          <a:ln/>
+        </p:spPr>
+        <p:txBody>
+          <a:bodyPr wrap="square" rtlCol="0" anchor="t"/>
+          <a:lstStyle/>
+          <a:p>
+            <a:pPr algn="l" indent="0" marL="0">
+              <a:lnSpc>
+                <a:spcPct val="115000"/>
+              </a:lnSpc>
+              <a:buNone/>
+            </a:pPr>
+            <a:r>
+              <a:rPr lang="en-US" sz="1250" dirty="0">
+                <a:solidFill>
+                  <a:srgbClr val="56676C"/>
+                </a:solidFill>
+                <a:latin typeface="Calibri" pitchFamily="34" charset="0"/>
+                <a:ea typeface="Calibri" pitchFamily="34" charset="-122"/>
+                <a:cs typeface="Calibri" pitchFamily="34" charset="-120"/>
+              </a:rPr>
+              <a:t>Tests for this specimen are grouped. The USID is the request number when eligible.</a:t>
+            </a:r>
+            <a:endParaRPr lang="en-US" sz="1250" dirty="0"/>
+          </a:p>
+        </p:txBody>
+      </p:sp>
+      <p:sp>
+        <p:nvSpPr>
+          <p:cNvPr id="8" name="Shape 6"/>
+          <p:cNvSpPr/>
+          <p:nvPr/>
+        </p:nvSpPr>
+        <p:spPr>
+          <a:xfrm>
+            <a:off x="548640" y="3035808"/>
+            <a:ext cx="7635240" cy="1097280"/>
+          </a:xfrm>
+          <a:prstGeom prst="roundRect">
+            <a:avLst>
+              <a:gd name="adj" fmla="val 3333"/>
+            </a:avLst>
+          </a:prstGeom>
+          <a:solidFill>
+            <a:srgbClr val="F1F3F3"/>
+          </a:solidFill>
+          <a:ln w="12700">
+            <a:solidFill>
+              <a:srgbClr val="F1F3F3"/>
+            </a:solidFill>
+            <a:prstDash val="solid"/>
+          </a:ln>
+        </p:spPr>
+      </p:sp>
+      <p:sp>
+        <p:nvSpPr>
+          <p:cNvPr id="9" name="Text 7"/>
+          <p:cNvSpPr/>
+          <p:nvPr/>
+        </p:nvSpPr>
+        <p:spPr>
+          <a:xfrm>
+            <a:off x="841248" y="3392424"/>
+            <a:ext cx="384048" cy="384048"/>
+          </a:xfrm>
+          <a:prstGeom prst="ellipse">
+            <a:avLst/>
+          </a:prstGeom>
+          <a:solidFill>
+            <a:srgbClr val="0B6E7F"/>
+          </a:solidFill>
+          <a:ln>
+            <a:solidFill>
+              <a:srgbClr val="0B6E7F"/>
+            </a:solidFill>
+          </a:ln>
+        </p:spPr>
+        <p:txBody>
+          <a:bodyPr wrap="square" rtlCol="0" anchor="ctr"/>
+          <a:lstStyle/>
+          <a:p>
+            <a:pPr algn="ctr" indent="0" marL="0">
+              <a:buNone/>
+            </a:pPr>
+            <a:r>
+              <a:rPr lang="en-US" sz="1300" b="1" dirty="0">
+                <a:solidFill>
+                  <a:srgbClr val="FFFFFF"/>
+                </a:solidFill>
+                <a:latin typeface="Calibri" pitchFamily="34" charset="0"/>
+                <a:ea typeface="Calibri" pitchFamily="34" charset="-122"/>
+                <a:cs typeface="Calibri" pitchFamily="34" charset="-120"/>
+              </a:rPr>
+              <a:t>2</a:t>
+            </a:r>
+            <a:endParaRPr lang="en-US" sz="1300" dirty="0"/>
+          </a:p>
+        </p:txBody>
+      </p:sp>
+      <p:sp>
+        <p:nvSpPr>
+          <p:cNvPr id="10" name="Text 8"/>
+          <p:cNvSpPr/>
+          <p:nvPr/>
+        </p:nvSpPr>
+        <p:spPr>
+          <a:xfrm>
+            <a:off x="1389888" y="3218688"/>
+            <a:ext cx="4754880" cy="310896"/>
+          </a:xfrm>
+          <a:prstGeom prst="rect">
+            <a:avLst/>
+          </a:prstGeom>
+          <a:noFill/>
+          <a:ln/>
+        </p:spPr>
+        <p:txBody>
+          <a:bodyPr wrap="square" rtlCol="0" anchor="t"/>
+          <a:lstStyle/>
+          <a:p>
+            <a:pPr algn="l" indent="0" marL="0">
+              <a:lnSpc>
+                <a:spcPct val="115000"/>
+              </a:lnSpc>
+              <a:buNone/>
+            </a:pPr>
+            <a:r>
+              <a:rPr lang="en-US" sz="1600" dirty="0">
+                <a:solidFill>
+                  <a:srgbClr val="08323B"/>
+                </a:solidFill>
+                <a:latin typeface="Calibri" pitchFamily="34" charset="0"/>
+                <a:ea typeface="Calibri" pitchFamily="34" charset="-122"/>
+                <a:cs typeface="Calibri" pitchFamily="34" charset="-120"/>
+              </a:rPr>
+              <a:t>Map ward and doctor</a:t>
+            </a:r>
+            <a:endParaRPr lang="en-US" sz="1600" dirty="0"/>
+          </a:p>
+        </p:txBody>
+      </p:sp>
+      <p:sp>
+        <p:nvSpPr>
+          <p:cNvPr id="11" name="Text 9"/>
+          <p:cNvSpPr/>
+          <p:nvPr/>
+        </p:nvSpPr>
+        <p:spPr>
+          <a:xfrm>
+            <a:off x="1389888" y="3547872"/>
+            <a:ext cx="5852160" cy="566928"/>
+          </a:xfrm>
+          <a:prstGeom prst="rect">
+            <a:avLst/>
+          </a:prstGeom>
+          <a:noFill/>
+          <a:ln/>
+        </p:spPr>
+        <p:txBody>
+          <a:bodyPr wrap="square" rtlCol="0" anchor="t"/>
+          <a:lstStyle/>
+          <a:p>
+            <a:pPr algn="l" indent="0" marL="0">
+              <a:lnSpc>
+                <a:spcPct val="115000"/>
+              </a:lnSpc>
+              <a:buNone/>
+            </a:pPr>
+            <a:r>
+              <a:rPr lang="en-US" sz="1250" dirty="0">
+                <a:solidFill>
+                  <a:srgbClr val="56676C"/>
+                </a:solidFill>
+                <a:latin typeface="Calibri" pitchFamily="34" charset="0"/>
+                <a:ea typeface="Calibri" pitchFamily="34" charset="-122"/>
+                <a:cs typeface="Calibri" pitchFamily="34" charset="-120"/>
+              </a:rPr>
+              <a:t>Office dictionary mapping the screen does today is done on the server.</a:t>
+            </a:r>
+            <a:endParaRPr lang="en-US" sz="1250" dirty="0"/>
+          </a:p>
+        </p:txBody>
+      </p:sp>
+      <p:sp>
+        <p:nvSpPr>
+          <p:cNvPr id="12" name="Shape 10"/>
+          <p:cNvSpPr/>
+          <p:nvPr/>
+        </p:nvSpPr>
+        <p:spPr>
+          <a:xfrm>
+            <a:off x="548640" y="4334256"/>
+            <a:ext cx="7635240" cy="1097280"/>
+          </a:xfrm>
+          <a:prstGeom prst="roundRect">
+            <a:avLst>
+              <a:gd name="adj" fmla="val 3333"/>
+            </a:avLst>
+          </a:prstGeom>
+          <a:solidFill>
+            <a:srgbClr val="F1F3F3"/>
+          </a:solidFill>
+          <a:ln w="12700">
+            <a:solidFill>
+              <a:srgbClr val="F1F3F3"/>
+            </a:solidFill>
+            <a:prstDash val="solid"/>
+          </a:ln>
+        </p:spPr>
+      </p:sp>
+      <p:sp>
+        <p:nvSpPr>
+          <p:cNvPr id="13" name="Text 11"/>
+          <p:cNvSpPr/>
+          <p:nvPr/>
+        </p:nvSpPr>
+        <p:spPr>
+          <a:xfrm>
+            <a:off x="841248" y="4690872"/>
+            <a:ext cx="384048" cy="384048"/>
+          </a:xfrm>
+          <a:prstGeom prst="ellipse">
+            <a:avLst/>
+          </a:prstGeom>
+          <a:solidFill>
+            <a:srgbClr val="0B6E7F"/>
+          </a:solidFill>
+          <a:ln>
+            <a:solidFill>
+              <a:srgbClr val="0B6E7F"/>
+            </a:solidFill>
+          </a:ln>
+        </p:spPr>
+        <p:txBody>
+          <a:bodyPr wrap="square" rtlCol="0" anchor="ctr"/>
+          <a:lstStyle/>
+          <a:p>
+            <a:pPr algn="ctr" indent="0" marL="0">
+              <a:buNone/>
+            </a:pPr>
+            <a:r>
+              <a:rPr lang="en-US" sz="1300" b="1" dirty="0">
+                <a:solidFill>
+                  <a:srgbClr val="FFFFFF"/>
+                </a:solidFill>
+                <a:latin typeface="Calibri" pitchFamily="34" charset="0"/>
+                <a:ea typeface="Calibri" pitchFamily="34" charset="-122"/>
+                <a:cs typeface="Calibri" pitchFamily="34" charset="-120"/>
+              </a:rPr>
+              <a:t>3</a:t>
+            </a:r>
+            <a:endParaRPr lang="en-US" sz="1300" dirty="0"/>
+          </a:p>
+        </p:txBody>
+      </p:sp>
+      <p:sp>
+        <p:nvSpPr>
+          <p:cNvPr id="14" name="Text 12"/>
+          <p:cNvSpPr/>
+          <p:nvPr/>
+        </p:nvSpPr>
+        <p:spPr>
+          <a:xfrm>
+            <a:off x="1389888" y="4517136"/>
+            <a:ext cx="4754880" cy="310896"/>
+          </a:xfrm>
+          <a:prstGeom prst="rect">
+            <a:avLst/>
+          </a:prstGeom>
+          <a:noFill/>
+          <a:ln/>
+        </p:spPr>
+        <p:txBody>
+          <a:bodyPr wrap="square" rtlCol="0" anchor="t"/>
+          <a:lstStyle/>
+          <a:p>
+            <a:pPr algn="l" indent="0" marL="0">
+              <a:lnSpc>
+                <a:spcPct val="115000"/>
+              </a:lnSpc>
+              <a:buNone/>
+            </a:pPr>
+            <a:r>
+              <a:rPr lang="en-US" sz="1600" dirty="0">
+                <a:solidFill>
+                  <a:srgbClr val="08323B"/>
+                </a:solidFill>
+                <a:latin typeface="Calibri" pitchFamily="34" charset="0"/>
+                <a:ea typeface="Calibri" pitchFamily="34" charset="-122"/>
+                <a:cs typeface="Calibri" pitchFamily="34" charset="-120"/>
+              </a:rPr>
+              <a:t>Replace ticks with defaults</a:t>
+            </a:r>
+            <a:endParaRPr lang="en-US" sz="1600" dirty="0"/>
+          </a:p>
+        </p:txBody>
+      </p:sp>
+      <p:sp>
+        <p:nvSpPr>
+          <p:cNvPr id="15" name="Text 13"/>
+          <p:cNvSpPr/>
+          <p:nvPr/>
+        </p:nvSpPr>
+        <p:spPr>
+          <a:xfrm>
+            <a:off x="1389888" y="4846320"/>
+            <a:ext cx="5852160" cy="566928"/>
+          </a:xfrm>
+          <a:prstGeom prst="rect">
+            <a:avLst/>
+          </a:prstGeom>
+          <a:noFill/>
+          <a:ln/>
+        </p:spPr>
+        <p:txBody>
+          <a:bodyPr wrap="square" rtlCol="0" anchor="t"/>
+          <a:lstStyle/>
+          <a:p>
+            <a:pPr algn="l" indent="0" marL="0">
+              <a:lnSpc>
+                <a:spcPct val="115000"/>
+              </a:lnSpc>
+              <a:buNone/>
+            </a:pPr>
+            <a:r>
+              <a:rPr lang="en-US" sz="1250" dirty="0">
+                <a:solidFill>
+                  <a:srgbClr val="56676C"/>
+                </a:solidFill>
+                <a:latin typeface="Calibri" pitchFamily="34" charset="0"/>
+                <a:ea typeface="Calibri" pitchFamily="34" charset="-122"/>
+                <a:cs typeface="Calibri" pitchFamily="34" charset="-120"/>
+              </a:rPr>
+              <a:t>Ack time is now. AAR off. Urgent workstation off. Labels off. No relabel tick.</a:t>
+            </a:r>
+            <a:endParaRPr lang="en-US" sz="1250" dirty="0"/>
+          </a:p>
+        </p:txBody>
+      </p:sp>
+      <p:sp>
+        <p:nvSpPr>
+          <p:cNvPr id="16" name="Shape 14"/>
+          <p:cNvSpPr/>
+          <p:nvPr/>
+        </p:nvSpPr>
+        <p:spPr>
+          <a:xfrm>
+            <a:off x="8458200" y="1737360"/>
+            <a:ext cx="3182112" cy="4114800"/>
+          </a:xfrm>
+          <a:prstGeom prst="roundRect">
+            <a:avLst>
+              <a:gd name="adj" fmla="val 1149"/>
             </a:avLst>
           </a:prstGeom>
           <a:solidFill>
@@ -6135,212 +6603,14 @@
       </p:sp>
       <p:sp>
         <p:nvSpPr>
-          <p:cNvPr id="5" name="Text 3"/>
-          <p:cNvSpPr/>
-          <p:nvPr/>
-        </p:nvSpPr>
-        <p:spPr>
-          <a:xfrm>
-            <a:off x="822960" y="1874520"/>
-            <a:ext cx="4937760" cy="274320"/>
-          </a:xfrm>
-          <a:prstGeom prst="rect">
-            <a:avLst/>
-          </a:prstGeom>
-          <a:noFill/>
-          <a:ln/>
-        </p:spPr>
-        <p:txBody>
-          <a:bodyPr wrap="square" rtlCol="0" anchor="ctr"/>
-          <a:lstStyle/>
-          <a:p>
-            <a:pPr algn="l" indent="0" marL="0">
-              <a:buNone/>
-            </a:pPr>
-            <a:r>
-              <a:rPr lang="en-US" sz="1100" dirty="0">
-                <a:solidFill>
-                  <a:srgbClr val="8FBAC3"/>
-                </a:solidFill>
-                <a:latin typeface="Courier New" pitchFamily="34" charset="0"/>
-                <a:ea typeface="Courier New" pitchFamily="34" charset="-122"/>
-                <a:cs typeface="Courier New" pitchFamily="34" charset="-120"/>
-              </a:rPr>
-              <a:t>GcrSpecAckDataConvertor.as</a:t>
-            </a:r>
-            <a:endParaRPr lang="en-US" sz="1100" dirty="0"/>
-          </a:p>
-        </p:txBody>
-      </p:sp>
-      <p:sp>
-        <p:nvSpPr>
-          <p:cNvPr id="6" name="Text 4"/>
-          <p:cNvSpPr/>
-          <p:nvPr/>
-        </p:nvSpPr>
-        <p:spPr>
-          <a:xfrm>
-            <a:off x="822960" y="2286000"/>
-            <a:ext cx="4983480" cy="2029968"/>
-          </a:xfrm>
-          <a:prstGeom prst="rect">
-            <a:avLst/>
-          </a:prstGeom>
-          <a:noFill/>
-          <a:ln/>
-        </p:spPr>
-        <p:txBody>
-          <a:bodyPr wrap="square" rtlCol="0" anchor="t"/>
-          <a:lstStyle/>
-          <a:p>
-            <a:pPr indent="0" marL="0">
-              <a:lnSpc>
-                <a:spcPct val="130000"/>
-              </a:lnSpc>
-              <a:buNone/>
-            </a:pPr>
-            <a:r>
-              <a:rPr lang="en-US" sz="1400" dirty="0">
-                <a:solidFill>
-                  <a:srgbClr val="C87F22"/>
-                </a:solidFill>
-                <a:latin typeface="Courier New" pitchFamily="34" charset="0"/>
-                <a:ea typeface="Courier New" pitchFamily="34" charset="-122"/>
-                <a:cs typeface="Courier New" pitchFamily="34" charset="-120"/>
-              </a:rPr>
-              <a:t>convertRequestTestGroupDataFromGcrTest</a:t>
-            </a:r>
-            <a:endParaRPr lang="en-US" sz="1400" dirty="0"/>
-          </a:p>
-          <a:p>
-            <a:pPr indent="0" marL="0">
-              <a:lnSpc>
-                <a:spcPct val="130000"/>
-              </a:lnSpc>
-              <a:buNone/>
-            </a:pPr>
-            <a:r>
-              <a:rPr lang="en-US" sz="1400" dirty="0">
-                <a:solidFill>
-                  <a:srgbClr val="C87F22"/>
-                </a:solidFill>
-                <a:latin typeface="Courier New" pitchFamily="34" charset="0"/>
-                <a:ea typeface="Courier New" pitchFamily="34" charset="-122"/>
-                <a:cs typeface="Courier New" pitchFamily="34" charset="-120"/>
-              </a:rPr>
-              <a:t>convertRequestTestGroupDataToParam</a:t>
-            </a:r>
-            <a:endParaRPr lang="en-US" sz="1400" dirty="0"/>
-          </a:p>
-          <a:p>
-            <a:pPr indent="0" marL="0">
-              <a:lnSpc>
-                <a:spcPct val="130000"/>
-              </a:lnSpc>
-              <a:buNone/>
-            </a:pPr>
-            <a:r>
-              <a:rPr lang="en-US" sz="1400" dirty="0">
-                <a:solidFill>
-                  <a:srgbClr val="FFFFFF"/>
-                </a:solidFill>
-                <a:latin typeface="Courier New" pitchFamily="34" charset="0"/>
-                <a:ea typeface="Courier New" pitchFamily="34" charset="-122"/>
-                <a:cs typeface="Courier New" pitchFamily="34" charset="-120"/>
-              </a:rPr>
-              <a:t>convertRequestNoDataToParam</a:t>
-            </a:r>
-            <a:endParaRPr lang="en-US" sz="1400" dirty="0"/>
-          </a:p>
-          <a:p>
-            <a:pPr indent="0" marL="0">
-              <a:lnSpc>
-                <a:spcPct val="130000"/>
-              </a:lnSpc>
-              <a:buNone/>
-            </a:pPr>
-            <a:r>
-              <a:rPr lang="en-US" sz="1400" dirty="0">
-                <a:solidFill>
-                  <a:srgbClr val="FFFFFF"/>
-                </a:solidFill>
-                <a:latin typeface="Courier New" pitchFamily="34" charset="0"/>
-                <a:ea typeface="Courier New" pitchFamily="34" charset="-122"/>
-                <a:cs typeface="Courier New" pitchFamily="34" charset="-120"/>
-              </a:rPr>
-              <a:t>convertWardDataToParam</a:t>
-            </a:r>
-            <a:endParaRPr lang="en-US" sz="1400" dirty="0"/>
-          </a:p>
-          <a:p>
-            <a:pPr indent="0" marL="0">
-              <a:lnSpc>
-                <a:spcPct val="130000"/>
-              </a:lnSpc>
-              <a:buNone/>
-            </a:pPr>
-            <a:r>
-              <a:rPr lang="en-US" sz="1400" dirty="0">
-                <a:solidFill>
-                  <a:srgbClr val="FFFFFF"/>
-                </a:solidFill>
-                <a:latin typeface="Courier New" pitchFamily="34" charset="0"/>
-                <a:ea typeface="Courier New" pitchFamily="34" charset="-122"/>
-                <a:cs typeface="Courier New" pitchFamily="34" charset="-120"/>
-              </a:rPr>
-              <a:t>convertDoctorDataToParam</a:t>
-            </a:r>
-            <a:endParaRPr lang="en-US" sz="1400" dirty="0"/>
-          </a:p>
-          <a:p>
-            <a:pPr indent="0" marL="0">
-              <a:lnSpc>
-                <a:spcPct val="130000"/>
-              </a:lnSpc>
-              <a:buNone/>
-            </a:pPr>
-            <a:r>
-              <a:rPr lang="en-US" sz="1400" dirty="0">
-                <a:solidFill>
-                  <a:srgbClr val="7F9AA1"/>
-                </a:solidFill>
-                <a:latin typeface="Courier New" pitchFamily="34" charset="0"/>
-                <a:ea typeface="Courier New" pitchFamily="34" charset="-122"/>
-                <a:cs typeface="Courier New" pitchFamily="34" charset="-120"/>
-              </a:rPr>
-              <a:t>convertUserInputDataToParam</a:t>
-            </a:r>
-            <a:pPr indent="0" marL="0">
-              <a:lnSpc>
-                <a:spcPct val="130000"/>
-              </a:lnSpc>
-              <a:buNone/>
-            </a:pPr>
-            <a:r>
-              <a:rPr lang="en-US" sz="1400" dirty="0">
-                <a:solidFill>
-                  <a:srgbClr val="7F9AA1"/>
-                </a:solidFill>
-                <a:latin typeface="Courier New" pitchFamily="34" charset="0"/>
-                <a:ea typeface="Courier New" pitchFamily="34" charset="-122"/>
-                <a:cs typeface="Courier New" pitchFamily="34" charset="-120"/>
-              </a:rPr>
-              <a:t>  // defaults, not screen</a:t>
-            </a:r>
-            <a:endParaRPr lang="en-US" sz="1400" dirty="0"/>
-          </a:p>
-        </p:txBody>
-      </p:sp>
-      <p:sp>
-        <p:nvSpPr>
-          <p:cNvPr id="7" name="Text 5"/>
-          <p:cNvSpPr/>
-          <p:nvPr/>
-        </p:nvSpPr>
-        <p:spPr>
-          <a:xfrm>
-            <a:off x="822960" y="4315968"/>
-            <a:ext cx="4983480" cy="411480"/>
+          <p:cNvPr id="17" name="Text 15"/>
+          <p:cNvSpPr/>
+          <p:nvPr/>
+        </p:nvSpPr>
+        <p:spPr>
+          <a:xfrm>
+            <a:off x="8732520" y="1965960"/>
+            <a:ext cx="2651760" cy="256032"/>
           </a:xfrm>
           <a:prstGeom prst="rect">
             <a:avLst/>
@@ -6359,7 +6629,7 @@
               <a:buNone/>
             </a:pPr>
             <a:r>
-              <a:rPr lang="en-US" sz="1200" dirty="0">
+              <a:rPr lang="en-US" sz="1000" dirty="0">
                 <a:solidFill>
                   <a:srgbClr val="8FBAC3"/>
                 </a:solidFill>
@@ -6367,67 +6637,22 @@
                 <a:ea typeface="Calibri" pitchFamily="34" charset="-122"/>
                 <a:cs typeface="Calibri" pitchFamily="34" charset="-120"/>
               </a:rPr>
-              <a:t>Grouping, USID as request no., and ward/doctor mapping must exist before register().</a:t>
-            </a:r>
-            <a:endParaRPr lang="en-US" sz="1200" dirty="0"/>
-          </a:p>
-        </p:txBody>
-      </p:sp>
-      <p:sp>
-        <p:nvSpPr>
-          <p:cNvPr id="8" name="Text 6"/>
-          <p:cNvSpPr/>
-          <p:nvPr/>
-        </p:nvSpPr>
-        <p:spPr>
-          <a:xfrm>
-            <a:off x="6446520" y="1819656"/>
-            <a:ext cx="274320" cy="274320"/>
-          </a:xfrm>
-          <a:prstGeom prst="ellipse">
-            <a:avLst/>
-          </a:prstGeom>
-          <a:solidFill>
-            <a:srgbClr val="0B6E7F"/>
-          </a:solidFill>
-          <a:ln>
-            <a:solidFill>
-              <a:srgbClr val="0B6E7F"/>
-            </a:solidFill>
-          </a:ln>
-        </p:spPr>
-        <p:txBody>
-          <a:bodyPr wrap="square" rtlCol="0" anchor="ctr"/>
-          <a:lstStyle/>
-          <a:p>
-            <a:pPr algn="ctr" indent="0" marL="0">
-              <a:buNone/>
-            </a:pPr>
-            <a:r>
-              <a:rPr lang="en-US" sz="1300" b="1" dirty="0">
-                <a:solidFill>
-                  <a:srgbClr val="FFFFFF"/>
-                </a:solidFill>
-                <a:latin typeface="Calibri" pitchFamily="34" charset="0"/>
-                <a:ea typeface="Calibri" pitchFamily="34" charset="-122"/>
-                <a:cs typeface="Calibri" pitchFamily="34" charset="-120"/>
-              </a:rPr>
-              <a:t>!</a:t>
-            </a:r>
-            <a:endParaRPr lang="en-US" sz="1300" dirty="0"/>
-          </a:p>
-        </p:txBody>
-      </p:sp>
-      <p:sp>
-        <p:nvSpPr>
-          <p:cNvPr id="9" name="Text 7"/>
-          <p:cNvSpPr/>
-          <p:nvPr/>
-        </p:nvSpPr>
-        <p:spPr>
-          <a:xfrm>
-            <a:off x="6903720" y="1783080"/>
-            <a:ext cx="4736592" cy="329184"/>
+              <a:t>WHY IT HAS TO MOVE</a:t>
+            </a:r>
+            <a:endParaRPr lang="en-US" sz="1000" dirty="0"/>
+          </a:p>
+        </p:txBody>
+      </p:sp>
+      <p:sp>
+        <p:nvSpPr>
+          <p:cNvPr id="18" name="Text 16"/>
+          <p:cNvSpPr/>
+          <p:nvPr/>
+        </p:nvSpPr>
+        <p:spPr>
+          <a:xfrm>
+            <a:off x="8732520" y="2267712"/>
+            <a:ext cx="2651760" cy="384048"/>
           </a:xfrm>
           <a:prstGeom prst="rect">
             <a:avLst/>
@@ -6446,30 +6671,30 @@
               <a:buNone/>
             </a:pPr>
             <a:r>
-              <a:rPr lang="en-US" sz="1500" dirty="0">
-                <a:solidFill>
-                  <a:srgbClr val="08323B"/>
-                </a:solidFill>
-                <a:latin typeface="Calibri" pitchFamily="34" charset="0"/>
-                <a:ea typeface="Calibri" pitchFamily="34" charset="-122"/>
-                <a:cs typeface="Calibri" pitchFamily="34" charset="-120"/>
-              </a:rPr>
-              <a:t>Defaults replace checkboxes</a:t>
-            </a:r>
-            <a:endParaRPr lang="en-US" sz="1500" dirty="0"/>
-          </a:p>
-        </p:txBody>
-      </p:sp>
-      <p:sp>
-        <p:nvSpPr>
-          <p:cNvPr id="10" name="Text 8"/>
-          <p:cNvSpPr/>
-          <p:nvPr/>
-        </p:nvSpPr>
-        <p:spPr>
-          <a:xfrm>
-            <a:off x="6903720" y="2130552"/>
-            <a:ext cx="4736592" cy="640080"/>
+              <a:rPr lang="en-US" sz="2200" dirty="0">
+                <a:solidFill>
+                  <a:srgbClr val="FFFFFF"/>
+                </a:solidFill>
+                <a:latin typeface="Cambria" pitchFamily="34" charset="0"/>
+                <a:ea typeface="Cambria" pitchFamily="34" charset="-122"/>
+                <a:cs typeface="Cambria" pitchFamily="34" charset="-120"/>
+              </a:rPr>
+              <a:t>Pack first</a:t>
+            </a:r>
+            <a:endParaRPr lang="en-US" sz="2200" dirty="0"/>
+          </a:p>
+        </p:txBody>
+      </p:sp>
+      <p:sp>
+        <p:nvSpPr>
+          <p:cNvPr id="19" name="Text 17"/>
+          <p:cNvSpPr/>
+          <p:nvPr/>
+        </p:nvSpPr>
+        <p:spPr>
+          <a:xfrm>
+            <a:off x="8732520" y="2743200"/>
+            <a:ext cx="2651760" cy="1645920"/>
           </a:xfrm>
           <a:prstGeom prst="rect">
             <a:avLst/>
@@ -6488,75 +6713,30 @@
               <a:buNone/>
             </a:pPr>
             <a:r>
-              <a:rPr lang="en-US" sz="1300" dirty="0">
-                <a:solidFill>
-                  <a:srgbClr val="56676C"/>
-                </a:solidFill>
-                <a:latin typeface="Calibri" pitchFamily="34" charset="0"/>
-                <a:ea typeface="Calibri" pitchFamily="34" charset="-122"/>
-                <a:cs typeface="Calibri" pitchFamily="34" charset="-120"/>
-              </a:rPr>
-              <a:t>Ack time is server now. AAR off. Urgent workstation off. Labels off. No relabel checkbox.</a:t>
-            </a:r>
-            <a:endParaRPr lang="en-US" sz="1300" dirty="0"/>
-          </a:p>
-        </p:txBody>
-      </p:sp>
-      <p:sp>
-        <p:nvSpPr>
-          <p:cNvPr id="11" name="Text 9"/>
-          <p:cNvSpPr/>
-          <p:nvPr/>
-        </p:nvSpPr>
-        <p:spPr>
-          <a:xfrm>
-            <a:off x="6446520" y="2880360"/>
-            <a:ext cx="274320" cy="274320"/>
-          </a:xfrm>
-          <a:prstGeom prst="ellipse">
-            <a:avLst/>
-          </a:prstGeom>
-          <a:solidFill>
-            <a:srgbClr val="0B6E7F"/>
-          </a:solidFill>
-          <a:ln>
-            <a:solidFill>
-              <a:srgbClr val="0B6E7F"/>
-            </a:solidFill>
-          </a:ln>
-        </p:spPr>
-        <p:txBody>
-          <a:bodyPr wrap="square" rtlCol="0" anchor="ctr"/>
-          <a:lstStyle/>
-          <a:p>
-            <a:pPr algn="ctr" indent="0" marL="0">
-              <a:buNone/>
-            </a:pPr>
-            <a:r>
-              <a:rPr lang="en-US" sz="1300" b="1" dirty="0">
-                <a:solidFill>
-                  <a:srgbClr val="FFFFFF"/>
-                </a:solidFill>
-                <a:latin typeface="Calibri" pitchFamily="34" charset="0"/>
-                <a:ea typeface="Calibri" pitchFamily="34" charset="-122"/>
-                <a:cs typeface="Calibri" pitchFamily="34" charset="-120"/>
-              </a:rPr>
-              <a:t>!</a:t>
-            </a:r>
-            <a:endParaRPr lang="en-US" sz="1300" dirty="0"/>
-          </a:p>
-        </p:txBody>
-      </p:sp>
-      <p:sp>
-        <p:nvSpPr>
-          <p:cNvPr id="12" name="Text 10"/>
-          <p:cNvSpPr/>
-          <p:nvPr/>
-        </p:nvSpPr>
-        <p:spPr>
-          <a:xfrm>
-            <a:off x="6903720" y="2843784"/>
-            <a:ext cx="4736592" cy="329184"/>
+              <a:rPr lang="en-US" sz="1250" dirty="0">
+                <a:solidFill>
+                  <a:srgbClr val="8FBAC3"/>
+                </a:solidFill>
+                <a:latin typeface="Calibri" pitchFamily="34" charset="0"/>
+                <a:ea typeface="Calibri" pitchFamily="34" charset="-122"/>
+                <a:cs typeface="Calibri" pitchFamily="34" charset="-120"/>
+              </a:rPr>
+              <a:t>If we only move the hard checks, the write has no test groups.</a:t>
+            </a:r>
+            <a:endParaRPr lang="en-US" sz="1250" dirty="0"/>
+          </a:p>
+        </p:txBody>
+      </p:sp>
+      <p:sp>
+        <p:nvSpPr>
+          <p:cNvPr id="20" name="Text 18"/>
+          <p:cNvSpPr/>
+          <p:nvPr/>
+        </p:nvSpPr>
+        <p:spPr>
+          <a:xfrm>
+            <a:off x="8732520" y="4526280"/>
+            <a:ext cx="2651760" cy="1097280"/>
           </a:xfrm>
           <a:prstGeom prst="rect">
             <a:avLst/>
@@ -6570,62 +6750,20 @@
           <a:p>
             <a:pPr algn="l" indent="0" marL="0">
               <a:lnSpc>
-                <a:spcPct val="115000"/>
+                <a:spcPct val="140000"/>
               </a:lnSpc>
               <a:buNone/>
             </a:pPr>
             <a:r>
-              <a:rPr lang="en-US" sz="1500" dirty="0">
-                <a:solidFill>
-                  <a:srgbClr val="08323B"/>
-                </a:solidFill>
-                <a:latin typeface="Calibri" pitchFamily="34" charset="0"/>
-                <a:ea typeface="Calibri" pitchFamily="34" charset="-122"/>
-                <a:cs typeface="Calibri" pitchFamily="34" charset="-120"/>
-              </a:rPr>
-              <a:t>register() already expects this</a:t>
-            </a:r>
-            <a:endParaRPr lang="en-US" sz="1500" dirty="0"/>
-          </a:p>
-        </p:txBody>
-      </p:sp>
-      <p:sp>
-        <p:nvSpPr>
-          <p:cNvPr id="13" name="Text 11"/>
-          <p:cNvSpPr/>
-          <p:nvPr/>
-        </p:nvSpPr>
-        <p:spPr>
-          <a:xfrm>
-            <a:off x="6903720" y="3191256"/>
-            <a:ext cx="4736592" cy="640080"/>
-          </a:xfrm>
-          <a:prstGeom prst="rect">
-            <a:avLst/>
-          </a:prstGeom>
-          <a:noFill/>
-          <a:ln/>
-        </p:spPr>
-        <p:txBody>
-          <a:bodyPr wrap="square" rtlCol="0" anchor="t"/>
-          <a:lstStyle/>
-          <a:p>
-            <a:pPr algn="l" indent="0" marL="0">
-              <a:lnSpc>
-                <a:spcPct val="115000"/>
-              </a:lnSpc>
-              <a:buNone/>
-            </a:pPr>
-            <a:r>
               <a:rPr lang="en-US" sz="1300" dirty="0">
                 <a:solidFill>
-                  <a:srgbClr val="56676C"/>
-                </a:solidFill>
-                <a:latin typeface="Calibri" pitchFamily="34" charset="0"/>
-                <a:ea typeface="Calibri" pitchFamily="34" charset="-122"/>
-                <a:cs typeface="Calibri" pitchFamily="34" charset="-120"/>
-              </a:rPr>
-              <a:t>Porting only the validator still leaves an empty test-group list.</a:t>
+                  <a:srgbClr val="FFFFFF"/>
+                </a:solidFill>
+                <a:latin typeface="Calibri" pitchFamily="34" charset="0"/>
+                <a:ea typeface="Calibri" pitchFamily="34" charset="-122"/>
+                <a:cs typeface="Calibri" pitchFamily="34" charset="-120"/>
+              </a:rPr>
+              <a:t>Soft alerts go to ALS only</a:t>
             </a:r>
             <a:endParaRPr lang="en-US" sz="1300" dirty="0"/>
           </a:p>
@@ -6633,136 +6771,7 @@
       </p:sp>
       <p:sp>
         <p:nvSpPr>
-          <p:cNvPr id="14" name="Text 12"/>
-          <p:cNvSpPr/>
-          <p:nvPr/>
-        </p:nvSpPr>
-        <p:spPr>
-          <a:xfrm>
-            <a:off x="6446520" y="3941064"/>
-            <a:ext cx="274320" cy="274320"/>
-          </a:xfrm>
-          <a:prstGeom prst="ellipse">
-            <a:avLst/>
-          </a:prstGeom>
-          <a:solidFill>
-            <a:srgbClr val="0B6E7F"/>
-          </a:solidFill>
-          <a:ln>
-            <a:solidFill>
-              <a:srgbClr val="0B6E7F"/>
-            </a:solidFill>
-          </a:ln>
-        </p:spPr>
-        <p:txBody>
-          <a:bodyPr wrap="square" rtlCol="0" anchor="ctr"/>
-          <a:lstStyle/>
-          <a:p>
-            <a:pPr algn="ctr" indent="0" marL="0">
-              <a:buNone/>
-            </a:pPr>
-            <a:r>
-              <a:rPr lang="en-US" sz="1300" b="1" dirty="0">
-                <a:solidFill>
-                  <a:srgbClr val="FFFFFF"/>
-                </a:solidFill>
-                <a:latin typeface="Calibri" pitchFamily="34" charset="0"/>
-                <a:ea typeface="Calibri" pitchFamily="34" charset="-122"/>
-                <a:cs typeface="Calibri" pitchFamily="34" charset="-120"/>
-              </a:rPr>
-              <a:t>!</a:t>
-            </a:r>
-            <a:endParaRPr lang="en-US" sz="1300" dirty="0"/>
-          </a:p>
-        </p:txBody>
-      </p:sp>
-      <p:sp>
-        <p:nvSpPr>
-          <p:cNvPr id="15" name="Text 13"/>
-          <p:cNvSpPr/>
-          <p:nvPr/>
-        </p:nvSpPr>
-        <p:spPr>
-          <a:xfrm>
-            <a:off x="6903720" y="3904488"/>
-            <a:ext cx="4736592" cy="329184"/>
-          </a:xfrm>
-          <a:prstGeom prst="rect">
-            <a:avLst/>
-          </a:prstGeom>
-          <a:noFill/>
-          <a:ln/>
-        </p:spPr>
-        <p:txBody>
-          <a:bodyPr wrap="square" rtlCol="0" anchor="t"/>
-          <a:lstStyle/>
-          <a:p>
-            <a:pPr algn="l" indent="0" marL="0">
-              <a:lnSpc>
-                <a:spcPct val="115000"/>
-              </a:lnSpc>
-              <a:buNone/>
-            </a:pPr>
-            <a:r>
-              <a:rPr lang="en-US" sz="1500" dirty="0">
-                <a:solidFill>
-                  <a:srgbClr val="08323B"/>
-                </a:solidFill>
-                <a:latin typeface="Calibri" pitchFamily="34" charset="0"/>
-                <a:ea typeface="Calibri" pitchFamily="34" charset="-122"/>
-                <a:cs typeface="Calibri" pitchFamily="34" charset="-120"/>
-              </a:rPr>
-              <a:t>Ro builders stay with print</a:t>
-            </a:r>
-            <a:endParaRPr lang="en-US" sz="1500" dirty="0"/>
-          </a:p>
-        </p:txBody>
-      </p:sp>
-      <p:sp>
-        <p:nvSpPr>
-          <p:cNvPr id="16" name="Text 14"/>
-          <p:cNvSpPr/>
-          <p:nvPr/>
-        </p:nvSpPr>
-        <p:spPr>
-          <a:xfrm>
-            <a:off x="6903720" y="4251960"/>
-            <a:ext cx="4736592" cy="640080"/>
-          </a:xfrm>
-          <a:prstGeom prst="rect">
-            <a:avLst/>
-          </a:prstGeom>
-          <a:noFill/>
-          <a:ln/>
-        </p:spPr>
-        <p:txBody>
-          <a:bodyPr wrap="square" rtlCol="0" anchor="t"/>
-          <a:lstStyle/>
-          <a:p>
-            <a:pPr algn="l" indent="0" marL="0">
-              <a:lnSpc>
-                <a:spcPct val="115000"/>
-              </a:lnSpc>
-              <a:buNone/>
-            </a:pPr>
-            <a:r>
-              <a:rPr lang="en-US" sz="1300" dirty="0">
-                <a:solidFill>
-                  <a:srgbClr val="56676C"/>
-                </a:solidFill>
-                <a:latin typeface="Calibri" pitchFamily="34" charset="0"/>
-                <a:ea typeface="Calibri" pitchFamily="34" charset="-122"/>
-                <a:cs typeface="Calibri" pitchFamily="34" charset="-120"/>
-              </a:rPr>
-              <a:t>Worksheet, send-out form, and SH Ro are built here, printed only after Registered.</a:t>
-            </a:r>
-            <a:endParaRPr lang="en-US" sz="1300" dirty="0"/>
-          </a:p>
-        </p:txBody>
-      </p:sp>
-      <p:sp>
-        <p:nvSpPr>
-          <p:cNvPr id="17" name="Text 15"/>
+          <p:cNvPr id="21" name="Text 19"/>
           <p:cNvSpPr/>
           <p:nvPr/>
         </p:nvSpPr>
@@ -7224,7 +7233,7 @@
                           <a:ea typeface="Calibri" pitchFamily="34" charset="-122"/>
                           <a:cs typeface="Calibri" pitchFamily="34" charset="-120"/>
                         </a:rPr>
-                        <a:t>Converted packing via register()</a:t>
+                        <a:t>Creates the lab request</a:t>
                       </a:r>
                       <a:endParaRPr lang="en-US" sz="1300" dirty="0">
                         <a:latin typeface="Calibri" charset="0"/>
@@ -7430,7 +7439,7 @@
                           <a:ea typeface="Calibri" pitchFamily="34" charset="-122"/>
                           <a:cs typeface="Calibri" pitchFamily="34" charset="-120"/>
                         </a:rPr>
-                        <a:t>sendOutSpecimen</a:t>
+                        <a:t>Send-out write</a:t>
                       </a:r>
                       <a:endParaRPr lang="en-US" sz="1300" dirty="0">
                         <a:latin typeface="Calibri" charset="0"/>
@@ -7842,7 +7851,7 @@
                           <a:ea typeface="Calibri" pitchFamily="34" charset="-122"/>
                           <a:cs typeface="Calibri" pitchFamily="34" charset="-120"/>
                         </a:rPr>
-                        <a:t>SORT_FAIL audit only</a:t>
+                        <a:t>Failure audit only</a:t>
                       </a:r>
                       <a:endParaRPr lang="en-US" sz="1300" dirty="0">
                         <a:latin typeface="Calibri" charset="0"/>
@@ -8182,7 +8191,7 @@
                 <a:ea typeface="Calibri" pitchFamily="34" charset="-122"/>
                 <a:cs typeface="Calibri" pitchFamily="34" charset="-120"/>
               </a:rPr>
-              <a:t>Staff worksheet picker is gone. Every Ro from the convertor prints.</a:t>
+              <a:t>Staff worksheet picker is gone. Every worksheet the packing produced is printed.</a:t>
             </a:r>
             <a:endParaRPr lang="en-US" sz="1300" dirty="0"/>
           </a:p>
@@ -8483,7 +8492,7 @@
                 <a:ea typeface="Calibri" pitchFamily="34" charset="-122"/>
                 <a:cs typeface="Calibri" pitchFamily="34" charset="-120"/>
               </a:rPr>
-              <a:t>Dedicated LIS user on LOE_AUDIT_TRAIL. Not ltc611.</a:t>
+              <a:t>A dedicated LIS user on the audit trail. Not a shared staff login.</a:t>
             </a:r>
             <a:endParaRPr lang="en-US" sz="1300" dirty="0"/>
           </a:p>
@@ -9252,7 +9261,7 @@
                 <a:ea typeface="Calibri" pitchFamily="34" charset="-122"/>
                 <a:cs typeface="Calibri" pitchFamily="34" charset="-120"/>
               </a:rPr>
-              <a:t>Staff clicks still retrieve, send-out, and register. The staff APIs are untouched.</a:t>
+              <a:t>Staff clicks still retrieve, send-out, and register. The staff screen is untouched.</a:t>
             </a:r>
             <a:endParaRPr lang="en-US" sz="1300" dirty="0"/>
           </a:p>

</xml_diff>

<commit_message>
vault backup: 2026-09-10 12:11:04
</commit_message>
<xml_diff>
--- a/SDLC/Projects/TMP-specimen-sorter-api — Specimen Sorter API/assets/Specimen Sorter API.pptx
+++ b/SDLC/Projects/TMP-specimen-sorter-api — Specimen Sorter API/assets/Specimen Sorter API.pptx
@@ -864,7 +864,7 @@
           <a:p>
             <a:r>
               <a:rPr lang="en-US" dirty="0"/>
-              <a:t>Retrieve and send-out already hit the service. Register and worksheet cannot, until packing moves behind the new API.</a:t>
+              <a:t>Amber rows are the gap. Retrieve, send-out, and PHLC already hit the service. Register and worksheet cannot leave the screen until packing moves.</a:t>
             </a:r>
             <a:endParaRPr lang="en-US" dirty="0"/>
           </a:p>
@@ -4426,828 +4426,1276 @@
           </a:p>
         </p:txBody>
       </p:sp>
-      <p:sp>
-        <p:nvSpPr>
-          <p:cNvPr id="4" name="Shape 2"/>
-          <p:cNvSpPr/>
-          <p:nvPr/>
-        </p:nvSpPr>
-        <p:spPr>
-          <a:xfrm>
-            <a:off x="548640" y="1737360"/>
-            <a:ext cx="7635240" cy="891540"/>
-          </a:xfrm>
-          <a:prstGeom prst="roundRect">
-            <a:avLst>
-              <a:gd name="adj" fmla="val 4103"/>
-            </a:avLst>
-          </a:prstGeom>
-          <a:solidFill>
-            <a:srgbClr val="F1F3F3"/>
-          </a:solidFill>
-          <a:ln w="12700">
-            <a:solidFill>
-              <a:srgbClr val="F1F3F3"/>
-            </a:solidFill>
-            <a:prstDash val="solid"/>
-          </a:ln>
-        </p:spPr>
-      </p:sp>
-      <p:sp>
-        <p:nvSpPr>
-          <p:cNvPr id="5" name="Text 3"/>
-          <p:cNvSpPr/>
-          <p:nvPr/>
-        </p:nvSpPr>
-        <p:spPr>
-          <a:xfrm>
-            <a:off x="841248" y="1991106"/>
-            <a:ext cx="384048" cy="384048"/>
-          </a:xfrm>
-          <a:prstGeom prst="ellipse">
-            <a:avLst/>
-          </a:prstGeom>
-          <a:solidFill>
-            <a:srgbClr val="0B6E7F"/>
-          </a:solidFill>
-          <a:ln>
-            <a:solidFill>
-              <a:srgbClr val="0B6E7F"/>
-            </a:solidFill>
-          </a:ln>
-        </p:spPr>
-        <p:txBody>
-          <a:bodyPr wrap="square" rtlCol="0" anchor="ctr"/>
-          <a:lstStyle/>
-          <a:p>
-            <a:pPr algn="ctr" indent="0" marL="0">
-              <a:buNone/>
-            </a:pPr>
-            <a:r>
-              <a:rPr lang="en-US" sz="1300" b="1" dirty="0">
-                <a:solidFill>
-                  <a:srgbClr val="FFFFFF"/>
-                </a:solidFill>
-                <a:latin typeface="Calibri" pitchFamily="34" charset="0"/>
-                <a:ea typeface="Calibri" pitchFamily="34" charset="-122"/>
-                <a:cs typeface="Calibri" pitchFamily="34" charset="-120"/>
-              </a:rPr>
-              <a:t>1</a:t>
-            </a:r>
-            <a:endParaRPr lang="en-US" sz="1300" dirty="0"/>
-          </a:p>
-        </p:txBody>
-      </p:sp>
-      <p:sp>
-        <p:nvSpPr>
-          <p:cNvPr id="6" name="Text 4"/>
-          <p:cNvSpPr/>
-          <p:nvPr/>
-        </p:nvSpPr>
-        <p:spPr>
-          <a:xfrm>
-            <a:off x="1389888" y="1856232"/>
-            <a:ext cx="4754880" cy="310896"/>
-          </a:xfrm>
-          <a:prstGeom prst="rect">
-            <a:avLst/>
-          </a:prstGeom>
-          <a:noFill/>
-          <a:ln/>
-        </p:spPr>
-        <p:txBody>
-          <a:bodyPr wrap="square" rtlCol="0" anchor="t"/>
-          <a:lstStyle/>
-          <a:p>
-            <a:pPr algn="l" indent="0" marL="0">
-              <a:lnSpc>
-                <a:spcPct val="115000"/>
-              </a:lnSpc>
-              <a:buNone/>
-            </a:pPr>
-            <a:r>
-              <a:rPr lang="en-US" sz="1500" dirty="0">
-                <a:solidFill>
-                  <a:srgbClr val="08323B"/>
-                </a:solidFill>
-                <a:latin typeface="Calibri" pitchFamily="34" charset="0"/>
-                <a:ea typeface="Calibri" pitchFamily="34" charset="-122"/>
-                <a:cs typeface="Calibri" pitchFamily="34" charset="-120"/>
-              </a:rPr>
-              <a:t>Retrieve GCRS order</a:t>
-            </a:r>
-            <a:endParaRPr lang="en-US" sz="1500" dirty="0"/>
-          </a:p>
-        </p:txBody>
-      </p:sp>
-      <p:sp>
-        <p:nvSpPr>
-          <p:cNvPr id="7" name="Text 5"/>
-          <p:cNvSpPr/>
-          <p:nvPr/>
-        </p:nvSpPr>
-        <p:spPr>
-          <a:xfrm>
-            <a:off x="1389888" y="2157984"/>
-            <a:ext cx="5852160" cy="397764"/>
-          </a:xfrm>
-          <a:prstGeom prst="rect">
-            <a:avLst/>
-          </a:prstGeom>
-          <a:noFill/>
-          <a:ln/>
-        </p:spPr>
-        <p:txBody>
-          <a:bodyPr wrap="square" rtlCol="0" anchor="t"/>
-          <a:lstStyle/>
-          <a:p>
-            <a:pPr algn="l" indent="0" marL="0">
-              <a:lnSpc>
-                <a:spcPct val="115000"/>
-              </a:lnSpc>
-              <a:buNone/>
-            </a:pPr>
-            <a:r>
-              <a:rPr lang="en-US" sz="1200" dirty="0">
-                <a:solidFill>
-                  <a:srgbClr val="56676C"/>
-                </a:solidFill>
-                <a:latin typeface="Calibri" pitchFamily="34" charset="0"/>
-                <a:ea typeface="Calibri" pitchFamily="34" charset="-122"/>
-                <a:cs typeface="Calibri" pitchFamily="34" charset="-120"/>
-              </a:rPr>
-              <a:t>The screen looks up the order, then calls backend.</a:t>
-            </a:r>
-            <a:endParaRPr lang="en-US" sz="1200" dirty="0"/>
-          </a:p>
-        </p:txBody>
-      </p:sp>
-      <p:sp>
-        <p:nvSpPr>
-          <p:cNvPr id="8" name="Shape 6"/>
-          <p:cNvSpPr/>
-          <p:nvPr/>
-        </p:nvSpPr>
-        <p:spPr>
-          <a:xfrm>
-            <a:off x="548640" y="2830068"/>
-            <a:ext cx="7635240" cy="891540"/>
-          </a:xfrm>
-          <a:prstGeom prst="roundRect">
-            <a:avLst>
-              <a:gd name="adj" fmla="val 4103"/>
-            </a:avLst>
-          </a:prstGeom>
-          <a:solidFill>
-            <a:srgbClr val="F1F3F3"/>
-          </a:solidFill>
-          <a:ln w="12700">
-            <a:solidFill>
-              <a:srgbClr val="F1F3F3"/>
-            </a:solidFill>
-            <a:prstDash val="solid"/>
-          </a:ln>
-        </p:spPr>
-      </p:sp>
-      <p:sp>
-        <p:nvSpPr>
-          <p:cNvPr id="9" name="Text 7"/>
-          <p:cNvSpPr/>
-          <p:nvPr/>
-        </p:nvSpPr>
-        <p:spPr>
-          <a:xfrm>
-            <a:off x="841248" y="3083814"/>
-            <a:ext cx="384048" cy="384048"/>
-          </a:xfrm>
-          <a:prstGeom prst="ellipse">
-            <a:avLst/>
-          </a:prstGeom>
-          <a:solidFill>
-            <a:srgbClr val="0B6E7F"/>
-          </a:solidFill>
-          <a:ln>
-            <a:solidFill>
-              <a:srgbClr val="0B6E7F"/>
-            </a:solidFill>
-          </a:ln>
-        </p:spPr>
-        <p:txBody>
-          <a:bodyPr wrap="square" rtlCol="0" anchor="ctr"/>
-          <a:lstStyle/>
-          <a:p>
-            <a:pPr algn="ctr" indent="0" marL="0">
-              <a:buNone/>
-            </a:pPr>
-            <a:r>
-              <a:rPr lang="en-US" sz="1300" b="1" dirty="0">
-                <a:solidFill>
-                  <a:srgbClr val="FFFFFF"/>
-                </a:solidFill>
-                <a:latin typeface="Calibri" pitchFamily="34" charset="0"/>
-                <a:ea typeface="Calibri" pitchFamily="34" charset="-122"/>
-                <a:cs typeface="Calibri" pitchFamily="34" charset="-120"/>
-              </a:rPr>
-              <a:t>2</a:t>
-            </a:r>
-            <a:endParaRPr lang="en-US" sz="1300" dirty="0"/>
-          </a:p>
-        </p:txBody>
-      </p:sp>
-      <p:sp>
-        <p:nvSpPr>
-          <p:cNvPr id="10" name="Text 8"/>
-          <p:cNvSpPr/>
-          <p:nvPr/>
-        </p:nvSpPr>
-        <p:spPr>
-          <a:xfrm>
-            <a:off x="1389888" y="2948940"/>
-            <a:ext cx="4754880" cy="310896"/>
-          </a:xfrm>
-          <a:prstGeom prst="rect">
-            <a:avLst/>
-          </a:prstGeom>
-          <a:noFill/>
-          <a:ln/>
-        </p:spPr>
-        <p:txBody>
-          <a:bodyPr wrap="square" rtlCol="0" anchor="t"/>
-          <a:lstStyle/>
-          <a:p>
-            <a:pPr algn="l" indent="0" marL="0">
-              <a:lnSpc>
-                <a:spcPct val="115000"/>
-              </a:lnSpc>
-              <a:buNone/>
-            </a:pPr>
-            <a:r>
-              <a:rPr lang="en-US" sz="1500" dirty="0">
-                <a:solidFill>
-                  <a:srgbClr val="08323B"/>
-                </a:solidFill>
-                <a:latin typeface="Calibri" pitchFamily="34" charset="0"/>
-                <a:ea typeface="Calibri" pitchFamily="34" charset="-122"/>
-                <a:cs typeface="Calibri" pitchFamily="34" charset="-120"/>
-              </a:rPr>
-              <a:t>Send-out</a:t>
-            </a:r>
-            <a:endParaRPr lang="en-US" sz="1500" dirty="0"/>
-          </a:p>
-        </p:txBody>
-      </p:sp>
-      <p:sp>
-        <p:nvSpPr>
-          <p:cNvPr id="11" name="Text 9"/>
-          <p:cNvSpPr/>
-          <p:nvPr/>
-        </p:nvSpPr>
-        <p:spPr>
-          <a:xfrm>
-            <a:off x="1389888" y="3250692"/>
-            <a:ext cx="5852160" cy="397764"/>
-          </a:xfrm>
-          <a:prstGeom prst="rect">
-            <a:avLst/>
-          </a:prstGeom>
-          <a:noFill/>
-          <a:ln/>
-        </p:spPr>
-        <p:txBody>
-          <a:bodyPr wrap="square" rtlCol="0" anchor="t"/>
-          <a:lstStyle/>
-          <a:p>
-            <a:pPr algn="l" indent="0" marL="0">
-              <a:lnSpc>
-                <a:spcPct val="115000"/>
-              </a:lnSpc>
-              <a:buNone/>
-            </a:pPr>
-            <a:r>
-              <a:rPr lang="en-US" sz="1200" dirty="0">
-                <a:solidFill>
-                  <a:srgbClr val="56676C"/>
-                </a:solidFill>
-                <a:latin typeface="Calibri" pitchFamily="34" charset="0"/>
-                <a:ea typeface="Calibri" pitchFamily="34" charset="-122"/>
-                <a:cs typeface="Calibri" pitchFamily="34" charset="-120"/>
-              </a:rPr>
-              <a:t>The screen calls backend. No packing on the screen.</a:t>
-            </a:r>
-            <a:endParaRPr lang="en-US" sz="1200" dirty="0"/>
-          </a:p>
-        </p:txBody>
-      </p:sp>
-      <p:sp>
-        <p:nvSpPr>
-          <p:cNvPr id="12" name="Shape 10"/>
-          <p:cNvSpPr/>
-          <p:nvPr/>
-        </p:nvSpPr>
-        <p:spPr>
-          <a:xfrm>
-            <a:off x="548640" y="3922776"/>
-            <a:ext cx="7635240" cy="891540"/>
-          </a:xfrm>
-          <a:prstGeom prst="roundRect">
-            <a:avLst>
-              <a:gd name="adj" fmla="val 4103"/>
-            </a:avLst>
-          </a:prstGeom>
-          <a:solidFill>
-            <a:srgbClr val="F1F3F3"/>
-          </a:solidFill>
-          <a:ln w="12700">
-            <a:solidFill>
-              <a:srgbClr val="F1F3F3"/>
-            </a:solidFill>
-            <a:prstDash val="solid"/>
-          </a:ln>
-        </p:spPr>
-      </p:sp>
-      <p:sp>
-        <p:nvSpPr>
-          <p:cNvPr id="13" name="Text 11"/>
-          <p:cNvSpPr/>
-          <p:nvPr/>
-        </p:nvSpPr>
-        <p:spPr>
-          <a:xfrm>
-            <a:off x="841248" y="4176522"/>
-            <a:ext cx="384048" cy="384048"/>
-          </a:xfrm>
-          <a:prstGeom prst="ellipse">
-            <a:avLst/>
-          </a:prstGeom>
-          <a:solidFill>
-            <a:srgbClr val="0B6E7F"/>
-          </a:solidFill>
-          <a:ln>
-            <a:solidFill>
-              <a:srgbClr val="0B6E7F"/>
-            </a:solidFill>
-          </a:ln>
-        </p:spPr>
-        <p:txBody>
-          <a:bodyPr wrap="square" rtlCol="0" anchor="ctr"/>
-          <a:lstStyle/>
-          <a:p>
-            <a:pPr algn="ctr" indent="0" marL="0">
-              <a:buNone/>
-            </a:pPr>
-            <a:r>
-              <a:rPr lang="en-US" sz="1300" b="1" dirty="0">
-                <a:solidFill>
-                  <a:srgbClr val="FFFFFF"/>
-                </a:solidFill>
-                <a:latin typeface="Calibri" pitchFamily="34" charset="0"/>
-                <a:ea typeface="Calibri" pitchFamily="34" charset="-122"/>
-                <a:cs typeface="Calibri" pitchFamily="34" charset="-120"/>
-              </a:rPr>
-              <a:t>3</a:t>
-            </a:r>
-            <a:endParaRPr lang="en-US" sz="1300" dirty="0"/>
-          </a:p>
-        </p:txBody>
-      </p:sp>
-      <p:sp>
-        <p:nvSpPr>
-          <p:cNvPr id="14" name="Text 12"/>
-          <p:cNvSpPr/>
-          <p:nvPr/>
-        </p:nvSpPr>
-        <p:spPr>
-          <a:xfrm>
-            <a:off x="1389888" y="4041648"/>
-            <a:ext cx="4754880" cy="310896"/>
-          </a:xfrm>
-          <a:prstGeom prst="rect">
-            <a:avLst/>
-          </a:prstGeom>
-          <a:noFill/>
-          <a:ln/>
-        </p:spPr>
-        <p:txBody>
-          <a:bodyPr wrap="square" rtlCol="0" anchor="t"/>
-          <a:lstStyle/>
-          <a:p>
-            <a:pPr algn="l" indent="0" marL="0">
-              <a:lnSpc>
-                <a:spcPct val="115000"/>
-              </a:lnSpc>
-              <a:buNone/>
-            </a:pPr>
-            <a:r>
-              <a:rPr lang="en-US" sz="1500" dirty="0">
-                <a:solidFill>
-                  <a:srgbClr val="08323B"/>
-                </a:solidFill>
-                <a:latin typeface="Calibri" pitchFamily="34" charset="0"/>
-                <a:ea typeface="Calibri" pitchFamily="34" charset="-122"/>
-                <a:cs typeface="Calibri" pitchFamily="34" charset="-120"/>
-              </a:rPr>
-              <a:t>Registration</a:t>
-            </a:r>
-            <a:endParaRPr lang="en-US" sz="1500" dirty="0"/>
-          </a:p>
-        </p:txBody>
-      </p:sp>
-      <p:sp>
-        <p:nvSpPr>
-          <p:cNvPr id="15" name="Text 13"/>
-          <p:cNvSpPr/>
-          <p:nvPr/>
-        </p:nvSpPr>
-        <p:spPr>
-          <a:xfrm>
-            <a:off x="1389888" y="4343400"/>
-            <a:ext cx="5852160" cy="397764"/>
-          </a:xfrm>
-          <a:prstGeom prst="rect">
-            <a:avLst/>
-          </a:prstGeom>
-          <a:noFill/>
-          <a:ln/>
-        </p:spPr>
-        <p:txBody>
-          <a:bodyPr wrap="square" rtlCol="0" anchor="t"/>
-          <a:lstStyle/>
-          <a:p>
-            <a:pPr algn="l" indent="0" marL="0">
-              <a:lnSpc>
-                <a:spcPct val="115000"/>
-              </a:lnSpc>
-              <a:buNone/>
-            </a:pPr>
-            <a:r>
-              <a:rPr lang="en-US" sz="1200" dirty="0">
-                <a:solidFill>
-                  <a:srgbClr val="56676C"/>
-                </a:solidFill>
-                <a:latin typeface="Calibri" pitchFamily="34" charset="0"/>
-                <a:ea typeface="Calibri" pitchFamily="34" charset="-122"/>
-                <a:cs typeface="Calibri" pitchFamily="34" charset="-120"/>
-              </a:rPr>
-              <a:t>Validation and data conversion run on the screen, then backend writes.</a:t>
-            </a:r>
-            <a:endParaRPr lang="en-US" sz="1200" dirty="0"/>
-          </a:p>
-        </p:txBody>
-      </p:sp>
-      <p:sp>
-        <p:nvSpPr>
-          <p:cNvPr id="16" name="Shape 14"/>
-          <p:cNvSpPr/>
-          <p:nvPr/>
-        </p:nvSpPr>
-        <p:spPr>
-          <a:xfrm>
-            <a:off x="548640" y="5015484"/>
-            <a:ext cx="7635240" cy="891540"/>
-          </a:xfrm>
-          <a:prstGeom prst="roundRect">
-            <a:avLst>
-              <a:gd name="adj" fmla="val 4103"/>
-            </a:avLst>
-          </a:prstGeom>
-          <a:solidFill>
-            <a:srgbClr val="F1F3F3"/>
-          </a:solidFill>
-          <a:ln w="12700">
-            <a:solidFill>
-              <a:srgbClr val="F1F3F3"/>
-            </a:solidFill>
-            <a:prstDash val="solid"/>
-          </a:ln>
-        </p:spPr>
-      </p:sp>
-      <p:sp>
-        <p:nvSpPr>
-          <p:cNvPr id="17" name="Text 15"/>
-          <p:cNvSpPr/>
-          <p:nvPr/>
-        </p:nvSpPr>
-        <p:spPr>
-          <a:xfrm>
-            <a:off x="841248" y="5269230"/>
-            <a:ext cx="384048" cy="384048"/>
-          </a:xfrm>
-          <a:prstGeom prst="ellipse">
-            <a:avLst/>
-          </a:prstGeom>
-          <a:solidFill>
-            <a:srgbClr val="0B6E7F"/>
-          </a:solidFill>
-          <a:ln>
-            <a:solidFill>
-              <a:srgbClr val="0B6E7F"/>
-            </a:solidFill>
-          </a:ln>
-        </p:spPr>
-        <p:txBody>
-          <a:bodyPr wrap="square" rtlCol="0" anchor="ctr"/>
-          <a:lstStyle/>
-          <a:p>
-            <a:pPr algn="ctr" indent="0" marL="0">
-              <a:buNone/>
-            </a:pPr>
-            <a:r>
-              <a:rPr lang="en-US" sz="1300" b="1" dirty="0">
-                <a:solidFill>
-                  <a:srgbClr val="FFFFFF"/>
-                </a:solidFill>
-                <a:latin typeface="Calibri" pitchFamily="34" charset="0"/>
-                <a:ea typeface="Calibri" pitchFamily="34" charset="-122"/>
-                <a:cs typeface="Calibri" pitchFamily="34" charset="-120"/>
-              </a:rPr>
-              <a:t>4</a:t>
-            </a:r>
-            <a:endParaRPr lang="en-US" sz="1300" dirty="0"/>
-          </a:p>
-        </p:txBody>
-      </p:sp>
-      <p:sp>
-        <p:nvSpPr>
-          <p:cNvPr id="18" name="Text 16"/>
-          <p:cNvSpPr/>
-          <p:nvPr/>
-        </p:nvSpPr>
-        <p:spPr>
-          <a:xfrm>
-            <a:off x="1389888" y="5134356"/>
-            <a:ext cx="4754880" cy="310896"/>
-          </a:xfrm>
-          <a:prstGeom prst="rect">
-            <a:avLst/>
-          </a:prstGeom>
-          <a:noFill/>
-          <a:ln/>
-        </p:spPr>
-        <p:txBody>
-          <a:bodyPr wrap="square" rtlCol="0" anchor="t"/>
-          <a:lstStyle/>
-          <a:p>
-            <a:pPr algn="l" indent="0" marL="0">
-              <a:lnSpc>
-                <a:spcPct val="115000"/>
-              </a:lnSpc>
-              <a:buNone/>
-            </a:pPr>
-            <a:r>
-              <a:rPr lang="en-US" sz="1500" dirty="0">
-                <a:solidFill>
-                  <a:srgbClr val="08323B"/>
-                </a:solidFill>
-                <a:latin typeface="Calibri" pitchFamily="34" charset="0"/>
-                <a:ea typeface="Calibri" pitchFamily="34" charset="-122"/>
-                <a:cs typeface="Calibri" pitchFamily="34" charset="-120"/>
-              </a:rPr>
-              <a:t>Worksheet printing</a:t>
-            </a:r>
-            <a:endParaRPr lang="en-US" sz="1500" dirty="0"/>
-          </a:p>
-        </p:txBody>
-      </p:sp>
-      <p:sp>
-        <p:nvSpPr>
-          <p:cNvPr id="19" name="Text 17"/>
-          <p:cNvSpPr/>
-          <p:nvPr/>
-        </p:nvSpPr>
-        <p:spPr>
-          <a:xfrm>
-            <a:off x="1389888" y="5436108"/>
-            <a:ext cx="5852160" cy="397764"/>
-          </a:xfrm>
-          <a:prstGeom prst="rect">
-            <a:avLst/>
-          </a:prstGeom>
-          <a:noFill/>
-          <a:ln/>
-        </p:spPr>
-        <p:txBody>
-          <a:bodyPr wrap="square" rtlCol="0" anchor="t"/>
-          <a:lstStyle/>
-          <a:p>
-            <a:pPr algn="l" indent="0" marL="0">
-              <a:lnSpc>
-                <a:spcPct val="115000"/>
-              </a:lnSpc>
-              <a:buNone/>
-            </a:pPr>
-            <a:r>
-              <a:rPr lang="en-US" sz="1200" dirty="0">
-                <a:solidFill>
-                  <a:srgbClr val="56676C"/>
-                </a:solidFill>
-                <a:latin typeface="Calibri" pitchFamily="34" charset="0"/>
-                <a:ea typeface="Calibri" pitchFamily="34" charset="-122"/>
-                <a:cs typeface="Calibri" pitchFamily="34" charset="-120"/>
-              </a:rPr>
-              <a:t>The screen groups tests, assigns request no., and maps ward and doctor, then backend prints.</a:t>
-            </a:r>
-            <a:endParaRPr lang="en-US" sz="1200" dirty="0"/>
-          </a:p>
-        </p:txBody>
-      </p:sp>
-      <p:sp>
-        <p:nvSpPr>
-          <p:cNvPr id="20" name="Shape 18"/>
-          <p:cNvSpPr/>
-          <p:nvPr/>
-        </p:nvSpPr>
-        <p:spPr>
-          <a:xfrm>
-            <a:off x="8458200" y="1737360"/>
-            <a:ext cx="3182112" cy="4590288"/>
-          </a:xfrm>
-          <a:prstGeom prst="roundRect">
-            <a:avLst>
-              <a:gd name="adj" fmla="val 1149"/>
-            </a:avLst>
-          </a:prstGeom>
-          <a:solidFill>
-            <a:srgbClr val="08323B"/>
-          </a:solidFill>
-          <a:ln w="12700">
-            <a:solidFill>
-              <a:srgbClr val="08323B"/>
-            </a:solidFill>
-            <a:prstDash val="solid"/>
-          </a:ln>
-        </p:spPr>
-      </p:sp>
-      <p:sp>
-        <p:nvSpPr>
-          <p:cNvPr id="21" name="Text 19"/>
-          <p:cNvSpPr/>
-          <p:nvPr/>
-        </p:nvSpPr>
-        <p:spPr>
-          <a:xfrm>
-            <a:off x="8732520" y="1965960"/>
-            <a:ext cx="2651760" cy="256032"/>
-          </a:xfrm>
-          <a:prstGeom prst="rect">
-            <a:avLst/>
-          </a:prstGeom>
-          <a:noFill/>
-          <a:ln/>
-        </p:spPr>
-        <p:txBody>
-          <a:bodyPr wrap="square" rtlCol="0" anchor="t"/>
-          <a:lstStyle/>
-          <a:p>
-            <a:pPr algn="l" indent="0" marL="0">
-              <a:lnSpc>
-                <a:spcPct val="115000"/>
-              </a:lnSpc>
-              <a:buNone/>
-            </a:pPr>
-            <a:r>
-              <a:rPr lang="en-US" sz="1000" dirty="0">
-                <a:solidFill>
-                  <a:srgbClr val="8FBAC3"/>
-                </a:solidFill>
-                <a:latin typeface="Calibri" pitchFamily="34" charset="0"/>
-                <a:ea typeface="Calibri" pitchFamily="34" charset="-122"/>
-                <a:cs typeface="Calibri" pitchFamily="34" charset="-120"/>
-              </a:rPr>
-              <a:t>PHLC</a:t>
-            </a:r>
-            <a:endParaRPr lang="en-US" sz="1000" dirty="0"/>
-          </a:p>
-        </p:txBody>
-      </p:sp>
-      <p:sp>
-        <p:nvSpPr>
-          <p:cNvPr id="22" name="Text 20"/>
-          <p:cNvSpPr/>
-          <p:nvPr/>
-        </p:nvSpPr>
-        <p:spPr>
-          <a:xfrm>
-            <a:off x="8732520" y="2267712"/>
-            <a:ext cx="2651760" cy="384048"/>
-          </a:xfrm>
-          <a:prstGeom prst="rect">
-            <a:avLst/>
-          </a:prstGeom>
-          <a:noFill/>
-          <a:ln/>
-        </p:spPr>
-        <p:txBody>
-          <a:bodyPr wrap="square" rtlCol="0" anchor="t"/>
-          <a:lstStyle/>
-          <a:p>
-            <a:pPr algn="l" indent="0" marL="0">
-              <a:lnSpc>
-                <a:spcPct val="115000"/>
-              </a:lnSpc>
-              <a:buNone/>
-            </a:pPr>
-            <a:r>
-              <a:rPr lang="en-US" sz="2200" dirty="0">
-                <a:solidFill>
-                  <a:srgbClr val="FFFFFF"/>
-                </a:solidFill>
-                <a:latin typeface="Cambria" pitchFamily="34" charset="0"/>
-                <a:ea typeface="Cambria" pitchFamily="34" charset="-122"/>
-                <a:cs typeface="Cambria" pitchFamily="34" charset="-120"/>
-              </a:rPr>
-              <a:t>Backend only</a:t>
-            </a:r>
-            <a:endParaRPr lang="en-US" sz="2200" dirty="0"/>
-          </a:p>
-        </p:txBody>
-      </p:sp>
-      <p:sp>
-        <p:nvSpPr>
-          <p:cNvPr id="23" name="Text 21"/>
-          <p:cNvSpPr/>
-          <p:nvPr/>
-        </p:nvSpPr>
-        <p:spPr>
-          <a:xfrm>
-            <a:off x="8732520" y="2743200"/>
-            <a:ext cx="2651760" cy="1645920"/>
-          </a:xfrm>
-          <a:prstGeom prst="rect">
-            <a:avLst/>
-          </a:prstGeom>
-          <a:noFill/>
-          <a:ln/>
-        </p:spPr>
-        <p:txBody>
-          <a:bodyPr wrap="square" rtlCol="0" anchor="t"/>
-          <a:lstStyle/>
-          <a:p>
-            <a:pPr algn="l" indent="0" marL="0">
-              <a:lnSpc>
-                <a:spcPct val="115000"/>
-              </a:lnSpc>
-              <a:buNone/>
-            </a:pPr>
-            <a:r>
-              <a:rPr lang="en-US" sz="1250" dirty="0">
-                <a:solidFill>
-                  <a:srgbClr val="8FBAC3"/>
-                </a:solidFill>
-                <a:latin typeface="Calibri" pitchFamily="34" charset="0"/>
-                <a:ea typeface="Calibri" pitchFamily="34" charset="-122"/>
-                <a:cs typeface="Calibri" pitchFamily="34" charset="-120"/>
-              </a:rPr>
-              <a:t>PHLC electronic order is a backend call after register. The screen does not convert it.</a:t>
-            </a:r>
-            <a:endParaRPr lang="en-US" sz="1250" dirty="0"/>
-          </a:p>
-        </p:txBody>
-      </p:sp>
-      <p:sp>
-        <p:nvSpPr>
-          <p:cNvPr id="24" name="Text 22"/>
-          <p:cNvSpPr/>
-          <p:nvPr/>
-        </p:nvSpPr>
-        <p:spPr>
-          <a:xfrm>
-            <a:off x="8732520" y="5001768"/>
-            <a:ext cx="2651760" cy="1097280"/>
-          </a:xfrm>
-          <a:prstGeom prst="rect">
-            <a:avLst/>
-          </a:prstGeom>
-          <a:noFill/>
-          <a:ln/>
-        </p:spPr>
-        <p:txBody>
-          <a:bodyPr wrap="square" rtlCol="0" anchor="t"/>
-          <a:lstStyle/>
-          <a:p>
-            <a:pPr algn="l" indent="0" marL="0">
-              <a:lnSpc>
-                <a:spcPct val="140000"/>
-              </a:lnSpc>
-              <a:buNone/>
-            </a:pPr>
-            <a:r>
-              <a:rPr lang="en-US" sz="1300" dirty="0">
-                <a:solidFill>
-                  <a:srgbClr val="FFFFFF"/>
-                </a:solidFill>
-                <a:latin typeface="Calibri" pitchFamily="34" charset="0"/>
-                <a:ea typeface="Calibri" pitchFamily="34" charset="-122"/>
-                <a:cs typeface="Calibri" pitchFamily="34" charset="-120"/>
-              </a:rPr>
-              <a:t>Same path after Registered on the sorter</a:t>
-            </a:r>
-            <a:endParaRPr lang="en-US" sz="1300" dirty="0"/>
-          </a:p>
-        </p:txBody>
-      </p:sp>
-      <p:sp>
-        <p:nvSpPr>
-          <p:cNvPr id="25" name="Text 23"/>
+      <p:graphicFrame>
+        <p:nvGraphicFramePr>
+          <p:cNvPr id="4" name="Table 0"/>
+          <p:cNvGraphicFramePr>
+            <a:graphicFrameLocks noGrp="1"/>
+          </p:cNvGraphicFramePr>
+          <p:nvPr>
+            <p:extLst>
+              <p:ext uri="{D42A27DB-BD31-4B8C-83A1-F6EECF244321}">
+                <p14:modId xmlns:p14="http://schemas.microsoft.com/office/powerpoint/2010/main" val="1579011935"/>
+              </p:ext>
+            </p:extLst>
+          </p:nvPr>
+        </p:nvGraphicFramePr>
+        <p:xfrm>
+          <a:off x="548640" y="1783080"/>
+          <a:ext cx="11091672" cy="914400"/>
+        </p:xfrm>
+        <a:graphic>
+          <a:graphicData uri="http://schemas.openxmlformats.org/drawingml/2006/table">
+            <a:tbl>
+              <a:tblPr/>
+              <a:tblGrid>
+                <a:gridCol w="2468880"/>
+                <a:gridCol w="5120640"/>
+                <a:gridCol w="3502152"/>
+              </a:tblGrid>
+              <a:tr h="475488">
+                <a:tc>
+                  <a:txBody>
+                    <a:bodyPr/>
+                    <a:lstStyle/>
+                    <a:p>
+                      <a:pPr algn="l" indent="0" marL="0">
+                        <a:buNone/>
+                      </a:pPr>
+                      <a:r>
+                        <a:rPr lang="en-US" sz="1250" b="1" dirty="0">
+                          <a:solidFill>
+                            <a:srgbClr val="FFFFFF"/>
+                          </a:solidFill>
+                          <a:latin typeface="Calibri" pitchFamily="34" charset="0"/>
+                          <a:ea typeface="Calibri" pitchFamily="34" charset="-122"/>
+                          <a:cs typeface="Calibri" pitchFamily="34" charset="-120"/>
+                        </a:rPr>
+                        <a:t>Action</a:t>
+                      </a:r>
+                      <a:endParaRPr lang="en-US" sz="1250" dirty="0">
+                        <a:latin typeface="Calibri" charset="0"/>
+                        <a:ea typeface="Calibri" charset="0"/>
+                        <a:cs typeface="Calibri" charset="0"/>
+                      </a:endParaRPr>
+                    </a:p>
+                  </a:txBody>
+                  <a:tcPr marL="127000" marR="127000" marT="50800" marB="50800" anchor="ctr">
+                    <a:lnL w="12700" cap="flat" cmpd="sng" algn="ctr">
+                      <a:solidFill>
+                        <a:srgbClr val="D5DEE0"/>
+                      </a:solidFill>
+                      <a:prstDash val="solid"/>
+                      <a:round/>
+                      <a:headEnd type="none" w="med" len="med"/>
+                      <a:tailEnd type="none" w="med" len="med"/>
+                    </a:lnL>
+                    <a:lnR w="12700" cap="flat" cmpd="sng" algn="ctr">
+                      <a:solidFill>
+                        <a:srgbClr val="D5DEE0"/>
+                      </a:solidFill>
+                      <a:prstDash val="solid"/>
+                      <a:round/>
+                      <a:headEnd type="none" w="med" len="med"/>
+                      <a:tailEnd type="none" w="med" len="med"/>
+                    </a:lnR>
+                    <a:lnT w="12700" cap="flat" cmpd="sng" algn="ctr">
+                      <a:solidFill>
+                        <a:srgbClr val="D5DEE0"/>
+                      </a:solidFill>
+                      <a:prstDash val="solid"/>
+                      <a:round/>
+                      <a:headEnd type="none" w="med" len="med"/>
+                      <a:tailEnd type="none" w="med" len="med"/>
+                    </a:lnT>
+                    <a:lnB w="12700" cap="flat" cmpd="sng" algn="ctr">
+                      <a:solidFill>
+                        <a:srgbClr val="D5DEE0"/>
+                      </a:solidFill>
+                      <a:prstDash val="solid"/>
+                      <a:round/>
+                      <a:headEnd type="none" w="med" len="med"/>
+                      <a:tailEnd type="none" w="med" len="med"/>
+                    </a:lnB>
+                    <a:solidFill>
+                      <a:srgbClr val="08323B"/>
+                    </a:solidFill>
+                  </a:tcPr>
+                </a:tc>
+                <a:tc>
+                  <a:txBody>
+                    <a:bodyPr/>
+                    <a:lstStyle/>
+                    <a:p>
+                      <a:pPr algn="l" indent="0" marL="0">
+                        <a:buNone/>
+                      </a:pPr>
+                      <a:r>
+                        <a:rPr lang="en-US" sz="1250" b="1" dirty="0">
+                          <a:solidFill>
+                            <a:srgbClr val="FFFFFF"/>
+                          </a:solidFill>
+                          <a:latin typeface="Calibri" pitchFamily="34" charset="0"/>
+                          <a:ea typeface="Calibri" pitchFamily="34" charset="-122"/>
+                          <a:cs typeface="Calibri" pitchFamily="34" charset="-120"/>
+                        </a:rPr>
+                        <a:t>On the screen</a:t>
+                      </a:r>
+                      <a:endParaRPr lang="en-US" sz="1250" dirty="0">
+                        <a:latin typeface="Calibri" charset="0"/>
+                        <a:ea typeface="Calibri" charset="0"/>
+                        <a:cs typeface="Calibri" charset="0"/>
+                      </a:endParaRPr>
+                    </a:p>
+                  </a:txBody>
+                  <a:tcPr marL="127000" marR="127000" marT="50800" marB="50800" anchor="ctr">
+                    <a:lnL w="12700" cap="flat" cmpd="sng" algn="ctr">
+                      <a:solidFill>
+                        <a:srgbClr val="D5DEE0"/>
+                      </a:solidFill>
+                      <a:prstDash val="solid"/>
+                      <a:round/>
+                      <a:headEnd type="none" w="med" len="med"/>
+                      <a:tailEnd type="none" w="med" len="med"/>
+                    </a:lnL>
+                    <a:lnR w="12700" cap="flat" cmpd="sng" algn="ctr">
+                      <a:solidFill>
+                        <a:srgbClr val="D5DEE0"/>
+                      </a:solidFill>
+                      <a:prstDash val="solid"/>
+                      <a:round/>
+                      <a:headEnd type="none" w="med" len="med"/>
+                      <a:tailEnd type="none" w="med" len="med"/>
+                    </a:lnR>
+                    <a:lnT w="12700" cap="flat" cmpd="sng" algn="ctr">
+                      <a:solidFill>
+                        <a:srgbClr val="D5DEE0"/>
+                      </a:solidFill>
+                      <a:prstDash val="solid"/>
+                      <a:round/>
+                      <a:headEnd type="none" w="med" len="med"/>
+                      <a:tailEnd type="none" w="med" len="med"/>
+                    </a:lnT>
+                    <a:lnB w="12700" cap="flat" cmpd="sng" algn="ctr">
+                      <a:solidFill>
+                        <a:srgbClr val="D5DEE0"/>
+                      </a:solidFill>
+                      <a:prstDash val="solid"/>
+                      <a:round/>
+                      <a:headEnd type="none" w="med" len="med"/>
+                      <a:tailEnd type="none" w="med" len="med"/>
+                    </a:lnB>
+                    <a:solidFill>
+                      <a:srgbClr val="08323B"/>
+                    </a:solidFill>
+                  </a:tcPr>
+                </a:tc>
+                <a:tc>
+                  <a:txBody>
+                    <a:bodyPr/>
+                    <a:lstStyle/>
+                    <a:p>
+                      <a:pPr algn="l" indent="0" marL="0">
+                        <a:buNone/>
+                      </a:pPr>
+                      <a:r>
+                        <a:rPr lang="en-US" sz="1250" b="1" dirty="0">
+                          <a:solidFill>
+                            <a:srgbClr val="FFFFFF"/>
+                          </a:solidFill>
+                          <a:latin typeface="Calibri" pitchFamily="34" charset="0"/>
+                          <a:ea typeface="Calibri" pitchFamily="34" charset="-122"/>
+                          <a:cs typeface="Calibri" pitchFamily="34" charset="-120"/>
+                        </a:rPr>
+                        <a:t>Backend</a:t>
+                      </a:r>
+                      <a:endParaRPr lang="en-US" sz="1250" dirty="0">
+                        <a:latin typeface="Calibri" charset="0"/>
+                        <a:ea typeface="Calibri" charset="0"/>
+                        <a:cs typeface="Calibri" charset="0"/>
+                      </a:endParaRPr>
+                    </a:p>
+                  </a:txBody>
+                  <a:tcPr marL="127000" marR="127000" marT="50800" marB="50800" anchor="ctr">
+                    <a:lnL w="12700" cap="flat" cmpd="sng" algn="ctr">
+                      <a:solidFill>
+                        <a:srgbClr val="D5DEE0"/>
+                      </a:solidFill>
+                      <a:prstDash val="solid"/>
+                      <a:round/>
+                      <a:headEnd type="none" w="med" len="med"/>
+                      <a:tailEnd type="none" w="med" len="med"/>
+                    </a:lnL>
+                    <a:lnR w="12700" cap="flat" cmpd="sng" algn="ctr">
+                      <a:solidFill>
+                        <a:srgbClr val="D5DEE0"/>
+                      </a:solidFill>
+                      <a:prstDash val="solid"/>
+                      <a:round/>
+                      <a:headEnd type="none" w="med" len="med"/>
+                      <a:tailEnd type="none" w="med" len="med"/>
+                    </a:lnR>
+                    <a:lnT w="12700" cap="flat" cmpd="sng" algn="ctr">
+                      <a:solidFill>
+                        <a:srgbClr val="D5DEE0"/>
+                      </a:solidFill>
+                      <a:prstDash val="solid"/>
+                      <a:round/>
+                      <a:headEnd type="none" w="med" len="med"/>
+                      <a:tailEnd type="none" w="med" len="med"/>
+                    </a:lnT>
+                    <a:lnB w="12700" cap="flat" cmpd="sng" algn="ctr">
+                      <a:solidFill>
+                        <a:srgbClr val="D5DEE0"/>
+                      </a:solidFill>
+                      <a:prstDash val="solid"/>
+                      <a:round/>
+                      <a:headEnd type="none" w="med" len="med"/>
+                      <a:tailEnd type="none" w="med" len="med"/>
+                    </a:lnB>
+                    <a:solidFill>
+                      <a:srgbClr val="08323B"/>
+                    </a:solidFill>
+                  </a:tcPr>
+                </a:tc>
+              </a:tr>
+              <a:tr h="502920">
+                <a:tc>
+                  <a:txBody>
+                    <a:bodyPr/>
+                    <a:lstStyle/>
+                    <a:p>
+                      <a:pPr algn="l" indent="0" marL="0">
+                        <a:buNone/>
+                      </a:pPr>
+                      <a:r>
+                        <a:rPr lang="en-US" sz="1300" b="1" dirty="0">
+                          <a:solidFill>
+                            <a:srgbClr val="08323B"/>
+                          </a:solidFill>
+                          <a:latin typeface="Calibri" pitchFamily="34" charset="0"/>
+                          <a:ea typeface="Calibri" pitchFamily="34" charset="-122"/>
+                          <a:cs typeface="Calibri" pitchFamily="34" charset="-120"/>
+                        </a:rPr>
+                        <a:t>Retrieve GCRS</a:t>
+                      </a:r>
+                      <a:endParaRPr lang="en-US" sz="1300" dirty="0">
+                        <a:latin typeface="Calibri" charset="0"/>
+                        <a:ea typeface="Calibri" charset="0"/>
+                        <a:cs typeface="Calibri" charset="0"/>
+                      </a:endParaRPr>
+                    </a:p>
+                  </a:txBody>
+                  <a:tcPr marL="127000" marR="127000" marT="50800" marB="50800" anchor="ctr">
+                    <a:lnL w="12700" cap="flat" cmpd="sng" algn="ctr">
+                      <a:solidFill>
+                        <a:srgbClr val="D5DEE0"/>
+                      </a:solidFill>
+                      <a:prstDash val="solid"/>
+                      <a:round/>
+                      <a:headEnd type="none" w="med" len="med"/>
+                      <a:tailEnd type="none" w="med" len="med"/>
+                    </a:lnL>
+                    <a:lnR w="12700" cap="flat" cmpd="sng" algn="ctr">
+                      <a:solidFill>
+                        <a:srgbClr val="D5DEE0"/>
+                      </a:solidFill>
+                      <a:prstDash val="solid"/>
+                      <a:round/>
+                      <a:headEnd type="none" w="med" len="med"/>
+                      <a:tailEnd type="none" w="med" len="med"/>
+                    </a:lnR>
+                    <a:lnT w="12700" cap="flat" cmpd="sng" algn="ctr">
+                      <a:solidFill>
+                        <a:srgbClr val="D5DEE0"/>
+                      </a:solidFill>
+                      <a:prstDash val="solid"/>
+                      <a:round/>
+                      <a:headEnd type="none" w="med" len="med"/>
+                      <a:tailEnd type="none" w="med" len="med"/>
+                    </a:lnT>
+                    <a:lnB w="12700" cap="flat" cmpd="sng" algn="ctr">
+                      <a:solidFill>
+                        <a:srgbClr val="D5DEE0"/>
+                      </a:solidFill>
+                      <a:prstDash val="solid"/>
+                      <a:round/>
+                      <a:headEnd type="none" w="med" len="med"/>
+                      <a:tailEnd type="none" w="med" len="med"/>
+                    </a:lnB>
+                    <a:solidFill>
+                      <a:srgbClr val="FFFFFF"/>
+                    </a:solidFill>
+                  </a:tcPr>
+                </a:tc>
+                <a:tc>
+                  <a:txBody>
+                    <a:bodyPr/>
+                    <a:lstStyle/>
+                    <a:p>
+                      <a:pPr algn="l" indent="0" marL="0">
+                        <a:buNone/>
+                      </a:pPr>
+                      <a:r>
+                        <a:rPr lang="en-US" sz="1300" dirty="0">
+                          <a:solidFill>
+                            <a:srgbClr val="08323B"/>
+                          </a:solidFill>
+                          <a:latin typeface="Calibri" pitchFamily="34" charset="0"/>
+                          <a:ea typeface="Calibri" pitchFamily="34" charset="-122"/>
+                          <a:cs typeface="Calibri" pitchFamily="34" charset="-120"/>
+                        </a:rPr>
+                        <a:t>Looks up the order</a:t>
+                      </a:r>
+                      <a:endParaRPr lang="en-US" sz="1300" dirty="0">
+                        <a:latin typeface="Calibri" charset="0"/>
+                        <a:ea typeface="Calibri" charset="0"/>
+                        <a:cs typeface="Calibri" charset="0"/>
+                      </a:endParaRPr>
+                    </a:p>
+                  </a:txBody>
+                  <a:tcPr marL="127000" marR="127000" marT="50800" marB="50800" anchor="ctr">
+                    <a:lnL w="12700" cap="flat" cmpd="sng" algn="ctr">
+                      <a:solidFill>
+                        <a:srgbClr val="D5DEE0"/>
+                      </a:solidFill>
+                      <a:prstDash val="solid"/>
+                      <a:round/>
+                      <a:headEnd type="none" w="med" len="med"/>
+                      <a:tailEnd type="none" w="med" len="med"/>
+                    </a:lnL>
+                    <a:lnR w="12700" cap="flat" cmpd="sng" algn="ctr">
+                      <a:solidFill>
+                        <a:srgbClr val="D5DEE0"/>
+                      </a:solidFill>
+                      <a:prstDash val="solid"/>
+                      <a:round/>
+                      <a:headEnd type="none" w="med" len="med"/>
+                      <a:tailEnd type="none" w="med" len="med"/>
+                    </a:lnR>
+                    <a:lnT w="12700" cap="flat" cmpd="sng" algn="ctr">
+                      <a:solidFill>
+                        <a:srgbClr val="D5DEE0"/>
+                      </a:solidFill>
+                      <a:prstDash val="solid"/>
+                      <a:round/>
+                      <a:headEnd type="none" w="med" len="med"/>
+                      <a:tailEnd type="none" w="med" len="med"/>
+                    </a:lnT>
+                    <a:lnB w="12700" cap="flat" cmpd="sng" algn="ctr">
+                      <a:solidFill>
+                        <a:srgbClr val="D5DEE0"/>
+                      </a:solidFill>
+                      <a:prstDash val="solid"/>
+                      <a:round/>
+                      <a:headEnd type="none" w="med" len="med"/>
+                      <a:tailEnd type="none" w="med" len="med"/>
+                    </a:lnB>
+                    <a:solidFill>
+                      <a:srgbClr val="FFFFFF"/>
+                    </a:solidFill>
+                  </a:tcPr>
+                </a:tc>
+                <a:tc>
+                  <a:txBody>
+                    <a:bodyPr/>
+                    <a:lstStyle/>
+                    <a:p>
+                      <a:pPr algn="l" indent="0" marL="0">
+                        <a:buNone/>
+                      </a:pPr>
+                      <a:r>
+                        <a:rPr lang="en-US" sz="1300" dirty="0">
+                          <a:solidFill>
+                            <a:srgbClr val="08323B"/>
+                          </a:solidFill>
+                          <a:latin typeface="Calibri" pitchFamily="34" charset="0"/>
+                          <a:ea typeface="Calibri" pitchFamily="34" charset="-122"/>
+                          <a:cs typeface="Calibri" pitchFamily="34" charset="-120"/>
+                        </a:rPr>
+                        <a:t>Calls backend</a:t>
+                      </a:r>
+                      <a:endParaRPr lang="en-US" sz="1300" dirty="0">
+                        <a:latin typeface="Calibri" charset="0"/>
+                        <a:ea typeface="Calibri" charset="0"/>
+                        <a:cs typeface="Calibri" charset="0"/>
+                      </a:endParaRPr>
+                    </a:p>
+                  </a:txBody>
+                  <a:tcPr marL="127000" marR="127000" marT="50800" marB="50800" anchor="ctr">
+                    <a:lnL w="12700" cap="flat" cmpd="sng" algn="ctr">
+                      <a:solidFill>
+                        <a:srgbClr val="D5DEE0"/>
+                      </a:solidFill>
+                      <a:prstDash val="solid"/>
+                      <a:round/>
+                      <a:headEnd type="none" w="med" len="med"/>
+                      <a:tailEnd type="none" w="med" len="med"/>
+                    </a:lnL>
+                    <a:lnR w="12700" cap="flat" cmpd="sng" algn="ctr">
+                      <a:solidFill>
+                        <a:srgbClr val="D5DEE0"/>
+                      </a:solidFill>
+                      <a:prstDash val="solid"/>
+                      <a:round/>
+                      <a:headEnd type="none" w="med" len="med"/>
+                      <a:tailEnd type="none" w="med" len="med"/>
+                    </a:lnR>
+                    <a:lnT w="12700" cap="flat" cmpd="sng" algn="ctr">
+                      <a:solidFill>
+                        <a:srgbClr val="D5DEE0"/>
+                      </a:solidFill>
+                      <a:prstDash val="solid"/>
+                      <a:round/>
+                      <a:headEnd type="none" w="med" len="med"/>
+                      <a:tailEnd type="none" w="med" len="med"/>
+                    </a:lnT>
+                    <a:lnB w="12700" cap="flat" cmpd="sng" algn="ctr">
+                      <a:solidFill>
+                        <a:srgbClr val="D5DEE0"/>
+                      </a:solidFill>
+                      <a:prstDash val="solid"/>
+                      <a:round/>
+                      <a:headEnd type="none" w="med" len="med"/>
+                      <a:tailEnd type="none" w="med" len="med"/>
+                    </a:lnB>
+                    <a:solidFill>
+                      <a:srgbClr val="FFFFFF"/>
+                    </a:solidFill>
+                  </a:tcPr>
+                </a:tc>
+              </a:tr>
+              <a:tr h="502920">
+                <a:tc>
+                  <a:txBody>
+                    <a:bodyPr/>
+                    <a:lstStyle/>
+                    <a:p>
+                      <a:pPr algn="l" indent="0" marL="0">
+                        <a:buNone/>
+                      </a:pPr>
+                      <a:r>
+                        <a:rPr lang="en-US" sz="1300" b="1" dirty="0">
+                          <a:solidFill>
+                            <a:srgbClr val="08323B"/>
+                          </a:solidFill>
+                          <a:latin typeface="Calibri" pitchFamily="34" charset="0"/>
+                          <a:ea typeface="Calibri" pitchFamily="34" charset="-122"/>
+                          <a:cs typeface="Calibri" pitchFamily="34" charset="-120"/>
+                        </a:rPr>
+                        <a:t>Send-out</a:t>
+                      </a:r>
+                      <a:endParaRPr lang="en-US" sz="1300" dirty="0">
+                        <a:latin typeface="Calibri" charset="0"/>
+                        <a:ea typeface="Calibri" charset="0"/>
+                        <a:cs typeface="Calibri" charset="0"/>
+                      </a:endParaRPr>
+                    </a:p>
+                  </a:txBody>
+                  <a:tcPr marL="127000" marR="127000" marT="50800" marB="50800" anchor="ctr">
+                    <a:lnL w="12700" cap="flat" cmpd="sng" algn="ctr">
+                      <a:solidFill>
+                        <a:srgbClr val="D5DEE0"/>
+                      </a:solidFill>
+                      <a:prstDash val="solid"/>
+                      <a:round/>
+                      <a:headEnd type="none" w="med" len="med"/>
+                      <a:tailEnd type="none" w="med" len="med"/>
+                    </a:lnL>
+                    <a:lnR w="12700" cap="flat" cmpd="sng" algn="ctr">
+                      <a:solidFill>
+                        <a:srgbClr val="D5DEE0"/>
+                      </a:solidFill>
+                      <a:prstDash val="solid"/>
+                      <a:round/>
+                      <a:headEnd type="none" w="med" len="med"/>
+                      <a:tailEnd type="none" w="med" len="med"/>
+                    </a:lnR>
+                    <a:lnT w="12700" cap="flat" cmpd="sng" algn="ctr">
+                      <a:solidFill>
+                        <a:srgbClr val="D5DEE0"/>
+                      </a:solidFill>
+                      <a:prstDash val="solid"/>
+                      <a:round/>
+                      <a:headEnd type="none" w="med" len="med"/>
+                      <a:tailEnd type="none" w="med" len="med"/>
+                    </a:lnT>
+                    <a:lnB w="12700" cap="flat" cmpd="sng" algn="ctr">
+                      <a:solidFill>
+                        <a:srgbClr val="D5DEE0"/>
+                      </a:solidFill>
+                      <a:prstDash val="solid"/>
+                      <a:round/>
+                      <a:headEnd type="none" w="med" len="med"/>
+                      <a:tailEnd type="none" w="med" len="med"/>
+                    </a:lnB>
+                    <a:solidFill>
+                      <a:srgbClr val="FFFFFF"/>
+                    </a:solidFill>
+                  </a:tcPr>
+                </a:tc>
+                <a:tc>
+                  <a:txBody>
+                    <a:bodyPr/>
+                    <a:lstStyle/>
+                    <a:p>
+                      <a:pPr algn="l" indent="0" marL="0">
+                        <a:buNone/>
+                      </a:pPr>
+                      <a:r>
+                        <a:rPr lang="en-US" sz="1300" dirty="0">
+                          <a:solidFill>
+                            <a:srgbClr val="08323B"/>
+                          </a:solidFill>
+                          <a:latin typeface="Calibri" pitchFamily="34" charset="0"/>
+                          <a:ea typeface="Calibri" pitchFamily="34" charset="-122"/>
+                          <a:cs typeface="Calibri" pitchFamily="34" charset="-120"/>
+                        </a:rPr>
+                        <a:t>Presses Send-out</a:t>
+                      </a:r>
+                      <a:endParaRPr lang="en-US" sz="1300" dirty="0">
+                        <a:latin typeface="Calibri" charset="0"/>
+                        <a:ea typeface="Calibri" charset="0"/>
+                        <a:cs typeface="Calibri" charset="0"/>
+                      </a:endParaRPr>
+                    </a:p>
+                  </a:txBody>
+                  <a:tcPr marL="127000" marR="127000" marT="50800" marB="50800" anchor="ctr">
+                    <a:lnL w="12700" cap="flat" cmpd="sng" algn="ctr">
+                      <a:solidFill>
+                        <a:srgbClr val="D5DEE0"/>
+                      </a:solidFill>
+                      <a:prstDash val="solid"/>
+                      <a:round/>
+                      <a:headEnd type="none" w="med" len="med"/>
+                      <a:tailEnd type="none" w="med" len="med"/>
+                    </a:lnL>
+                    <a:lnR w="12700" cap="flat" cmpd="sng" algn="ctr">
+                      <a:solidFill>
+                        <a:srgbClr val="D5DEE0"/>
+                      </a:solidFill>
+                      <a:prstDash val="solid"/>
+                      <a:round/>
+                      <a:headEnd type="none" w="med" len="med"/>
+                      <a:tailEnd type="none" w="med" len="med"/>
+                    </a:lnR>
+                    <a:lnT w="12700" cap="flat" cmpd="sng" algn="ctr">
+                      <a:solidFill>
+                        <a:srgbClr val="D5DEE0"/>
+                      </a:solidFill>
+                      <a:prstDash val="solid"/>
+                      <a:round/>
+                      <a:headEnd type="none" w="med" len="med"/>
+                      <a:tailEnd type="none" w="med" len="med"/>
+                    </a:lnT>
+                    <a:lnB w="12700" cap="flat" cmpd="sng" algn="ctr">
+                      <a:solidFill>
+                        <a:srgbClr val="D5DEE0"/>
+                      </a:solidFill>
+                      <a:prstDash val="solid"/>
+                      <a:round/>
+                      <a:headEnd type="none" w="med" len="med"/>
+                      <a:tailEnd type="none" w="med" len="med"/>
+                    </a:lnB>
+                    <a:solidFill>
+                      <a:srgbClr val="FFFFFF"/>
+                    </a:solidFill>
+                  </a:tcPr>
+                </a:tc>
+                <a:tc>
+                  <a:txBody>
+                    <a:bodyPr/>
+                    <a:lstStyle/>
+                    <a:p>
+                      <a:pPr algn="l" indent="0" marL="0">
+                        <a:buNone/>
+                      </a:pPr>
+                      <a:r>
+                        <a:rPr lang="en-US" sz="1300" dirty="0">
+                          <a:solidFill>
+                            <a:srgbClr val="08323B"/>
+                          </a:solidFill>
+                          <a:latin typeface="Calibri" pitchFamily="34" charset="0"/>
+                          <a:ea typeface="Calibri" pitchFamily="34" charset="-122"/>
+                          <a:cs typeface="Calibri" pitchFamily="34" charset="-120"/>
+                        </a:rPr>
+                        <a:t>Calls backend</a:t>
+                      </a:r>
+                      <a:endParaRPr lang="en-US" sz="1300" dirty="0">
+                        <a:latin typeface="Calibri" charset="0"/>
+                        <a:ea typeface="Calibri" charset="0"/>
+                        <a:cs typeface="Calibri" charset="0"/>
+                      </a:endParaRPr>
+                    </a:p>
+                  </a:txBody>
+                  <a:tcPr marL="127000" marR="127000" marT="50800" marB="50800" anchor="ctr">
+                    <a:lnL w="12700" cap="flat" cmpd="sng" algn="ctr">
+                      <a:solidFill>
+                        <a:srgbClr val="D5DEE0"/>
+                      </a:solidFill>
+                      <a:prstDash val="solid"/>
+                      <a:round/>
+                      <a:headEnd type="none" w="med" len="med"/>
+                      <a:tailEnd type="none" w="med" len="med"/>
+                    </a:lnL>
+                    <a:lnR w="12700" cap="flat" cmpd="sng" algn="ctr">
+                      <a:solidFill>
+                        <a:srgbClr val="D5DEE0"/>
+                      </a:solidFill>
+                      <a:prstDash val="solid"/>
+                      <a:round/>
+                      <a:headEnd type="none" w="med" len="med"/>
+                      <a:tailEnd type="none" w="med" len="med"/>
+                    </a:lnR>
+                    <a:lnT w="12700" cap="flat" cmpd="sng" algn="ctr">
+                      <a:solidFill>
+                        <a:srgbClr val="D5DEE0"/>
+                      </a:solidFill>
+                      <a:prstDash val="solid"/>
+                      <a:round/>
+                      <a:headEnd type="none" w="med" len="med"/>
+                      <a:tailEnd type="none" w="med" len="med"/>
+                    </a:lnT>
+                    <a:lnB w="12700" cap="flat" cmpd="sng" algn="ctr">
+                      <a:solidFill>
+                        <a:srgbClr val="D5DEE0"/>
+                      </a:solidFill>
+                      <a:prstDash val="solid"/>
+                      <a:round/>
+                      <a:headEnd type="none" w="med" len="med"/>
+                      <a:tailEnd type="none" w="med" len="med"/>
+                    </a:lnB>
+                    <a:solidFill>
+                      <a:srgbClr val="FFFFFF"/>
+                    </a:solidFill>
+                  </a:tcPr>
+                </a:tc>
+              </a:tr>
+              <a:tr h="502920">
+                <a:tc>
+                  <a:txBody>
+                    <a:bodyPr/>
+                    <a:lstStyle/>
+                    <a:p>
+                      <a:pPr algn="l" indent="0" marL="0">
+                        <a:buNone/>
+                      </a:pPr>
+                      <a:r>
+                        <a:rPr lang="en-US" sz="1300" b="1" dirty="0">
+                          <a:solidFill>
+                            <a:srgbClr val="08323B"/>
+                          </a:solidFill>
+                          <a:latin typeface="Calibri" pitchFamily="34" charset="0"/>
+                          <a:ea typeface="Calibri" pitchFamily="34" charset="-122"/>
+                          <a:cs typeface="Calibri" pitchFamily="34" charset="-120"/>
+                        </a:rPr>
+                        <a:t>Registration</a:t>
+                      </a:r>
+                      <a:endParaRPr lang="en-US" sz="1300" dirty="0">
+                        <a:latin typeface="Calibri" charset="0"/>
+                        <a:ea typeface="Calibri" charset="0"/>
+                        <a:cs typeface="Calibri" charset="0"/>
+                      </a:endParaRPr>
+                    </a:p>
+                  </a:txBody>
+                  <a:tcPr marL="127000" marR="127000" marT="50800" marB="50800" anchor="ctr">
+                    <a:lnL w="12700" cap="flat" cmpd="sng" algn="ctr">
+                      <a:solidFill>
+                        <a:srgbClr val="D5DEE0"/>
+                      </a:solidFill>
+                      <a:prstDash val="solid"/>
+                      <a:round/>
+                      <a:headEnd type="none" w="med" len="med"/>
+                      <a:tailEnd type="none" w="med" len="med"/>
+                    </a:lnL>
+                    <a:lnR w="12700" cap="flat" cmpd="sng" algn="ctr">
+                      <a:solidFill>
+                        <a:srgbClr val="D5DEE0"/>
+                      </a:solidFill>
+                      <a:prstDash val="solid"/>
+                      <a:round/>
+                      <a:headEnd type="none" w="med" len="med"/>
+                      <a:tailEnd type="none" w="med" len="med"/>
+                    </a:lnR>
+                    <a:lnT w="12700" cap="flat" cmpd="sng" algn="ctr">
+                      <a:solidFill>
+                        <a:srgbClr val="D5DEE0"/>
+                      </a:solidFill>
+                      <a:prstDash val="solid"/>
+                      <a:round/>
+                      <a:headEnd type="none" w="med" len="med"/>
+                      <a:tailEnd type="none" w="med" len="med"/>
+                    </a:lnT>
+                    <a:lnB w="12700" cap="flat" cmpd="sng" algn="ctr">
+                      <a:solidFill>
+                        <a:srgbClr val="D5DEE0"/>
+                      </a:solidFill>
+                      <a:prstDash val="solid"/>
+                      <a:round/>
+                      <a:headEnd type="none" w="med" len="med"/>
+                      <a:tailEnd type="none" w="med" len="med"/>
+                    </a:lnB>
+                    <a:solidFill>
+                      <a:srgbClr val="FFFFFF"/>
+                    </a:solidFill>
+                  </a:tcPr>
+                </a:tc>
+                <a:tc>
+                  <a:txBody>
+                    <a:bodyPr/>
+                    <a:lstStyle/>
+                    <a:p>
+                      <a:pPr algn="l" indent="0" marL="0">
+                        <a:buNone/>
+                      </a:pPr>
+                      <a:r>
+                        <a:rPr lang="en-US" sz="1300" b="1" dirty="0">
+                          <a:solidFill>
+                            <a:srgbClr val="9A5C15"/>
+                          </a:solidFill>
+                          <a:latin typeface="Calibri" pitchFamily="34" charset="0"/>
+                          <a:ea typeface="Calibri" pitchFamily="34" charset="-122"/>
+                          <a:cs typeface="Calibri" pitchFamily="34" charset="-120"/>
+                        </a:rPr>
+                        <a:t>Validates and converts</a:t>
+                      </a:r>
+                      <a:endParaRPr lang="en-US" sz="1300" dirty="0">
+                        <a:latin typeface="Calibri" charset="0"/>
+                        <a:ea typeface="Calibri" charset="0"/>
+                        <a:cs typeface="Calibri" charset="0"/>
+                      </a:endParaRPr>
+                    </a:p>
+                  </a:txBody>
+                  <a:tcPr marL="127000" marR="127000" marT="50800" marB="50800" anchor="ctr">
+                    <a:lnL w="12700" cap="flat" cmpd="sng" algn="ctr">
+                      <a:solidFill>
+                        <a:srgbClr val="D5DEE0"/>
+                      </a:solidFill>
+                      <a:prstDash val="solid"/>
+                      <a:round/>
+                      <a:headEnd type="none" w="med" len="med"/>
+                      <a:tailEnd type="none" w="med" len="med"/>
+                    </a:lnL>
+                    <a:lnR w="12700" cap="flat" cmpd="sng" algn="ctr">
+                      <a:solidFill>
+                        <a:srgbClr val="D5DEE0"/>
+                      </a:solidFill>
+                      <a:prstDash val="solid"/>
+                      <a:round/>
+                      <a:headEnd type="none" w="med" len="med"/>
+                      <a:tailEnd type="none" w="med" len="med"/>
+                    </a:lnR>
+                    <a:lnT w="12700" cap="flat" cmpd="sng" algn="ctr">
+                      <a:solidFill>
+                        <a:srgbClr val="D5DEE0"/>
+                      </a:solidFill>
+                      <a:prstDash val="solid"/>
+                      <a:round/>
+                      <a:headEnd type="none" w="med" len="med"/>
+                      <a:tailEnd type="none" w="med" len="med"/>
+                    </a:lnT>
+                    <a:lnB w="12700" cap="flat" cmpd="sng" algn="ctr">
+                      <a:solidFill>
+                        <a:srgbClr val="D5DEE0"/>
+                      </a:solidFill>
+                      <a:prstDash val="solid"/>
+                      <a:round/>
+                      <a:headEnd type="none" w="med" len="med"/>
+                      <a:tailEnd type="none" w="med" len="med"/>
+                    </a:lnB>
+                    <a:solidFill>
+                      <a:srgbClr val="FAEEDB"/>
+                    </a:solidFill>
+                  </a:tcPr>
+                </a:tc>
+                <a:tc>
+                  <a:txBody>
+                    <a:bodyPr/>
+                    <a:lstStyle/>
+                    <a:p>
+                      <a:pPr algn="l" indent="0" marL="0">
+                        <a:buNone/>
+                      </a:pPr>
+                      <a:r>
+                        <a:rPr lang="en-US" sz="1300" dirty="0">
+                          <a:solidFill>
+                            <a:srgbClr val="08323B"/>
+                          </a:solidFill>
+                          <a:latin typeface="Calibri" pitchFamily="34" charset="0"/>
+                          <a:ea typeface="Calibri" pitchFamily="34" charset="-122"/>
+                          <a:cs typeface="Calibri" pitchFamily="34" charset="-120"/>
+                        </a:rPr>
+                        <a:t>Writes</a:t>
+                      </a:r>
+                      <a:endParaRPr lang="en-US" sz="1300" dirty="0">
+                        <a:latin typeface="Calibri" charset="0"/>
+                        <a:ea typeface="Calibri" charset="0"/>
+                        <a:cs typeface="Calibri" charset="0"/>
+                      </a:endParaRPr>
+                    </a:p>
+                  </a:txBody>
+                  <a:tcPr marL="127000" marR="127000" marT="50800" marB="50800" anchor="ctr">
+                    <a:lnL w="12700" cap="flat" cmpd="sng" algn="ctr">
+                      <a:solidFill>
+                        <a:srgbClr val="D5DEE0"/>
+                      </a:solidFill>
+                      <a:prstDash val="solid"/>
+                      <a:round/>
+                      <a:headEnd type="none" w="med" len="med"/>
+                      <a:tailEnd type="none" w="med" len="med"/>
+                    </a:lnL>
+                    <a:lnR w="12700" cap="flat" cmpd="sng" algn="ctr">
+                      <a:solidFill>
+                        <a:srgbClr val="D5DEE0"/>
+                      </a:solidFill>
+                      <a:prstDash val="solid"/>
+                      <a:round/>
+                      <a:headEnd type="none" w="med" len="med"/>
+                      <a:tailEnd type="none" w="med" len="med"/>
+                    </a:lnR>
+                    <a:lnT w="12700" cap="flat" cmpd="sng" algn="ctr">
+                      <a:solidFill>
+                        <a:srgbClr val="D5DEE0"/>
+                      </a:solidFill>
+                      <a:prstDash val="solid"/>
+                      <a:round/>
+                      <a:headEnd type="none" w="med" len="med"/>
+                      <a:tailEnd type="none" w="med" len="med"/>
+                    </a:lnT>
+                    <a:lnB w="12700" cap="flat" cmpd="sng" algn="ctr">
+                      <a:solidFill>
+                        <a:srgbClr val="D5DEE0"/>
+                      </a:solidFill>
+                      <a:prstDash val="solid"/>
+                      <a:round/>
+                      <a:headEnd type="none" w="med" len="med"/>
+                      <a:tailEnd type="none" w="med" len="med"/>
+                    </a:lnB>
+                    <a:solidFill>
+                      <a:srgbClr val="FFFFFF"/>
+                    </a:solidFill>
+                  </a:tcPr>
+                </a:tc>
+              </a:tr>
+              <a:tr h="502920">
+                <a:tc>
+                  <a:txBody>
+                    <a:bodyPr/>
+                    <a:lstStyle/>
+                    <a:p>
+                      <a:pPr algn="l" indent="0" marL="0">
+                        <a:buNone/>
+                      </a:pPr>
+                      <a:r>
+                        <a:rPr lang="en-US" sz="1300" b="1" dirty="0">
+                          <a:solidFill>
+                            <a:srgbClr val="08323B"/>
+                          </a:solidFill>
+                          <a:latin typeface="Calibri" pitchFamily="34" charset="0"/>
+                          <a:ea typeface="Calibri" pitchFamily="34" charset="-122"/>
+                          <a:cs typeface="Calibri" pitchFamily="34" charset="-120"/>
+                        </a:rPr>
+                        <a:t>Worksheet</a:t>
+                      </a:r>
+                      <a:endParaRPr lang="en-US" sz="1300" dirty="0">
+                        <a:latin typeface="Calibri" charset="0"/>
+                        <a:ea typeface="Calibri" charset="0"/>
+                        <a:cs typeface="Calibri" charset="0"/>
+                      </a:endParaRPr>
+                    </a:p>
+                  </a:txBody>
+                  <a:tcPr marL="127000" marR="127000" marT="50800" marB="50800" anchor="ctr">
+                    <a:lnL w="12700" cap="flat" cmpd="sng" algn="ctr">
+                      <a:solidFill>
+                        <a:srgbClr val="D5DEE0"/>
+                      </a:solidFill>
+                      <a:prstDash val="solid"/>
+                      <a:round/>
+                      <a:headEnd type="none" w="med" len="med"/>
+                      <a:tailEnd type="none" w="med" len="med"/>
+                    </a:lnL>
+                    <a:lnR w="12700" cap="flat" cmpd="sng" algn="ctr">
+                      <a:solidFill>
+                        <a:srgbClr val="D5DEE0"/>
+                      </a:solidFill>
+                      <a:prstDash val="solid"/>
+                      <a:round/>
+                      <a:headEnd type="none" w="med" len="med"/>
+                      <a:tailEnd type="none" w="med" len="med"/>
+                    </a:lnR>
+                    <a:lnT w="12700" cap="flat" cmpd="sng" algn="ctr">
+                      <a:solidFill>
+                        <a:srgbClr val="D5DEE0"/>
+                      </a:solidFill>
+                      <a:prstDash val="solid"/>
+                      <a:round/>
+                      <a:headEnd type="none" w="med" len="med"/>
+                      <a:tailEnd type="none" w="med" len="med"/>
+                    </a:lnT>
+                    <a:lnB w="12700" cap="flat" cmpd="sng" algn="ctr">
+                      <a:solidFill>
+                        <a:srgbClr val="D5DEE0"/>
+                      </a:solidFill>
+                      <a:prstDash val="solid"/>
+                      <a:round/>
+                      <a:headEnd type="none" w="med" len="med"/>
+                      <a:tailEnd type="none" w="med" len="med"/>
+                    </a:lnB>
+                    <a:solidFill>
+                      <a:srgbClr val="FFFFFF"/>
+                    </a:solidFill>
+                  </a:tcPr>
+                </a:tc>
+                <a:tc>
+                  <a:txBody>
+                    <a:bodyPr/>
+                    <a:lstStyle/>
+                    <a:p>
+                      <a:pPr algn="l" indent="0" marL="0">
+                        <a:buNone/>
+                      </a:pPr>
+                      <a:r>
+                        <a:rPr lang="en-US" sz="1300" b="1" dirty="0">
+                          <a:solidFill>
+                            <a:srgbClr val="9A5C15"/>
+                          </a:solidFill>
+                          <a:latin typeface="Calibri" pitchFamily="34" charset="0"/>
+                          <a:ea typeface="Calibri" pitchFamily="34" charset="-122"/>
+                          <a:cs typeface="Calibri" pitchFamily="34" charset="-120"/>
+                        </a:rPr>
+                        <a:t>Groups tests, request no., ward, doctor</a:t>
+                      </a:r>
+                      <a:endParaRPr lang="en-US" sz="1300" dirty="0">
+                        <a:latin typeface="Calibri" charset="0"/>
+                        <a:ea typeface="Calibri" charset="0"/>
+                        <a:cs typeface="Calibri" charset="0"/>
+                      </a:endParaRPr>
+                    </a:p>
+                  </a:txBody>
+                  <a:tcPr marL="127000" marR="127000" marT="50800" marB="50800" anchor="ctr">
+                    <a:lnL w="12700" cap="flat" cmpd="sng" algn="ctr">
+                      <a:solidFill>
+                        <a:srgbClr val="D5DEE0"/>
+                      </a:solidFill>
+                      <a:prstDash val="solid"/>
+                      <a:round/>
+                      <a:headEnd type="none" w="med" len="med"/>
+                      <a:tailEnd type="none" w="med" len="med"/>
+                    </a:lnL>
+                    <a:lnR w="12700" cap="flat" cmpd="sng" algn="ctr">
+                      <a:solidFill>
+                        <a:srgbClr val="D5DEE0"/>
+                      </a:solidFill>
+                      <a:prstDash val="solid"/>
+                      <a:round/>
+                      <a:headEnd type="none" w="med" len="med"/>
+                      <a:tailEnd type="none" w="med" len="med"/>
+                    </a:lnR>
+                    <a:lnT w="12700" cap="flat" cmpd="sng" algn="ctr">
+                      <a:solidFill>
+                        <a:srgbClr val="D5DEE0"/>
+                      </a:solidFill>
+                      <a:prstDash val="solid"/>
+                      <a:round/>
+                      <a:headEnd type="none" w="med" len="med"/>
+                      <a:tailEnd type="none" w="med" len="med"/>
+                    </a:lnT>
+                    <a:lnB w="12700" cap="flat" cmpd="sng" algn="ctr">
+                      <a:solidFill>
+                        <a:srgbClr val="D5DEE0"/>
+                      </a:solidFill>
+                      <a:prstDash val="solid"/>
+                      <a:round/>
+                      <a:headEnd type="none" w="med" len="med"/>
+                      <a:tailEnd type="none" w="med" len="med"/>
+                    </a:lnB>
+                    <a:solidFill>
+                      <a:srgbClr val="FAEEDB"/>
+                    </a:solidFill>
+                  </a:tcPr>
+                </a:tc>
+                <a:tc>
+                  <a:txBody>
+                    <a:bodyPr/>
+                    <a:lstStyle/>
+                    <a:p>
+                      <a:pPr algn="l" indent="0" marL="0">
+                        <a:buNone/>
+                      </a:pPr>
+                      <a:r>
+                        <a:rPr lang="en-US" sz="1300" dirty="0">
+                          <a:solidFill>
+                            <a:srgbClr val="08323B"/>
+                          </a:solidFill>
+                          <a:latin typeface="Calibri" pitchFamily="34" charset="0"/>
+                          <a:ea typeface="Calibri" pitchFamily="34" charset="-122"/>
+                          <a:cs typeface="Calibri" pitchFamily="34" charset="-120"/>
+                        </a:rPr>
+                        <a:t>Prints</a:t>
+                      </a:r>
+                      <a:endParaRPr lang="en-US" sz="1300" dirty="0">
+                        <a:latin typeface="Calibri" charset="0"/>
+                        <a:ea typeface="Calibri" charset="0"/>
+                        <a:cs typeface="Calibri" charset="0"/>
+                      </a:endParaRPr>
+                    </a:p>
+                  </a:txBody>
+                  <a:tcPr marL="127000" marR="127000" marT="50800" marB="50800" anchor="ctr">
+                    <a:lnL w="12700" cap="flat" cmpd="sng" algn="ctr">
+                      <a:solidFill>
+                        <a:srgbClr val="D5DEE0"/>
+                      </a:solidFill>
+                      <a:prstDash val="solid"/>
+                      <a:round/>
+                      <a:headEnd type="none" w="med" len="med"/>
+                      <a:tailEnd type="none" w="med" len="med"/>
+                    </a:lnL>
+                    <a:lnR w="12700" cap="flat" cmpd="sng" algn="ctr">
+                      <a:solidFill>
+                        <a:srgbClr val="D5DEE0"/>
+                      </a:solidFill>
+                      <a:prstDash val="solid"/>
+                      <a:round/>
+                      <a:headEnd type="none" w="med" len="med"/>
+                      <a:tailEnd type="none" w="med" len="med"/>
+                    </a:lnR>
+                    <a:lnT w="12700" cap="flat" cmpd="sng" algn="ctr">
+                      <a:solidFill>
+                        <a:srgbClr val="D5DEE0"/>
+                      </a:solidFill>
+                      <a:prstDash val="solid"/>
+                      <a:round/>
+                      <a:headEnd type="none" w="med" len="med"/>
+                      <a:tailEnd type="none" w="med" len="med"/>
+                    </a:lnT>
+                    <a:lnB w="12700" cap="flat" cmpd="sng" algn="ctr">
+                      <a:solidFill>
+                        <a:srgbClr val="D5DEE0"/>
+                      </a:solidFill>
+                      <a:prstDash val="solid"/>
+                      <a:round/>
+                      <a:headEnd type="none" w="med" len="med"/>
+                      <a:tailEnd type="none" w="med" len="med"/>
+                    </a:lnB>
+                    <a:solidFill>
+                      <a:srgbClr val="FFFFFF"/>
+                    </a:solidFill>
+                  </a:tcPr>
+                </a:tc>
+              </a:tr>
+              <a:tr h="502920">
+                <a:tc>
+                  <a:txBody>
+                    <a:bodyPr/>
+                    <a:lstStyle/>
+                    <a:p>
+                      <a:pPr algn="l" indent="0" marL="0">
+                        <a:buNone/>
+                      </a:pPr>
+                      <a:r>
+                        <a:rPr lang="en-US" sz="1300" b="1" dirty="0">
+                          <a:solidFill>
+                            <a:srgbClr val="08323B"/>
+                          </a:solidFill>
+                          <a:latin typeface="Calibri" pitchFamily="34" charset="0"/>
+                          <a:ea typeface="Calibri" pitchFamily="34" charset="-122"/>
+                          <a:cs typeface="Calibri" pitchFamily="34" charset="-120"/>
+                        </a:rPr>
+                        <a:t>PHLC order</a:t>
+                      </a:r>
+                      <a:endParaRPr lang="en-US" sz="1300" dirty="0">
+                        <a:latin typeface="Calibri" charset="0"/>
+                        <a:ea typeface="Calibri" charset="0"/>
+                        <a:cs typeface="Calibri" charset="0"/>
+                      </a:endParaRPr>
+                    </a:p>
+                  </a:txBody>
+                  <a:tcPr marL="127000" marR="127000" marT="50800" marB="50800" anchor="ctr">
+                    <a:lnL w="12700" cap="flat" cmpd="sng" algn="ctr">
+                      <a:solidFill>
+                        <a:srgbClr val="D5DEE0"/>
+                      </a:solidFill>
+                      <a:prstDash val="solid"/>
+                      <a:round/>
+                      <a:headEnd type="none" w="med" len="med"/>
+                      <a:tailEnd type="none" w="med" len="med"/>
+                    </a:lnL>
+                    <a:lnR w="12700" cap="flat" cmpd="sng" algn="ctr">
+                      <a:solidFill>
+                        <a:srgbClr val="D5DEE0"/>
+                      </a:solidFill>
+                      <a:prstDash val="solid"/>
+                      <a:round/>
+                      <a:headEnd type="none" w="med" len="med"/>
+                      <a:tailEnd type="none" w="med" len="med"/>
+                    </a:lnR>
+                    <a:lnT w="12700" cap="flat" cmpd="sng" algn="ctr">
+                      <a:solidFill>
+                        <a:srgbClr val="D5DEE0"/>
+                      </a:solidFill>
+                      <a:prstDash val="solid"/>
+                      <a:round/>
+                      <a:headEnd type="none" w="med" len="med"/>
+                      <a:tailEnd type="none" w="med" len="med"/>
+                    </a:lnT>
+                    <a:lnB w="12700" cap="flat" cmpd="sng" algn="ctr">
+                      <a:solidFill>
+                        <a:srgbClr val="D5DEE0"/>
+                      </a:solidFill>
+                      <a:prstDash val="solid"/>
+                      <a:round/>
+                      <a:headEnd type="none" w="med" len="med"/>
+                      <a:tailEnd type="none" w="med" len="med"/>
+                    </a:lnB>
+                    <a:solidFill>
+                      <a:srgbClr val="FFFFFF"/>
+                    </a:solidFill>
+                  </a:tcPr>
+                </a:tc>
+                <a:tc>
+                  <a:txBody>
+                    <a:bodyPr/>
+                    <a:lstStyle/>
+                    <a:p>
+                      <a:pPr algn="l" indent="0" marL="0">
+                        <a:buNone/>
+                      </a:pPr>
+                      <a:r>
+                        <a:rPr lang="en-US" sz="1300" dirty="0">
+                          <a:solidFill>
+                            <a:srgbClr val="08323B"/>
+                          </a:solidFill>
+                          <a:latin typeface="Calibri" pitchFamily="34" charset="0"/>
+                          <a:ea typeface="Calibri" pitchFamily="34" charset="-122"/>
+                          <a:cs typeface="Calibri" pitchFamily="34" charset="-120"/>
+                        </a:rPr>
+                        <a:t>None</a:t>
+                      </a:r>
+                      <a:endParaRPr lang="en-US" sz="1300" dirty="0">
+                        <a:latin typeface="Calibri" charset="0"/>
+                        <a:ea typeface="Calibri" charset="0"/>
+                        <a:cs typeface="Calibri" charset="0"/>
+                      </a:endParaRPr>
+                    </a:p>
+                  </a:txBody>
+                  <a:tcPr marL="127000" marR="127000" marT="50800" marB="50800" anchor="ctr">
+                    <a:lnL w="12700" cap="flat" cmpd="sng" algn="ctr">
+                      <a:solidFill>
+                        <a:srgbClr val="D5DEE0"/>
+                      </a:solidFill>
+                      <a:prstDash val="solid"/>
+                      <a:round/>
+                      <a:headEnd type="none" w="med" len="med"/>
+                      <a:tailEnd type="none" w="med" len="med"/>
+                    </a:lnL>
+                    <a:lnR w="12700" cap="flat" cmpd="sng" algn="ctr">
+                      <a:solidFill>
+                        <a:srgbClr val="D5DEE0"/>
+                      </a:solidFill>
+                      <a:prstDash val="solid"/>
+                      <a:round/>
+                      <a:headEnd type="none" w="med" len="med"/>
+                      <a:tailEnd type="none" w="med" len="med"/>
+                    </a:lnR>
+                    <a:lnT w="12700" cap="flat" cmpd="sng" algn="ctr">
+                      <a:solidFill>
+                        <a:srgbClr val="D5DEE0"/>
+                      </a:solidFill>
+                      <a:prstDash val="solid"/>
+                      <a:round/>
+                      <a:headEnd type="none" w="med" len="med"/>
+                      <a:tailEnd type="none" w="med" len="med"/>
+                    </a:lnT>
+                    <a:lnB w="12700" cap="flat" cmpd="sng" algn="ctr">
+                      <a:solidFill>
+                        <a:srgbClr val="D5DEE0"/>
+                      </a:solidFill>
+                      <a:prstDash val="solid"/>
+                      <a:round/>
+                      <a:headEnd type="none" w="med" len="med"/>
+                      <a:tailEnd type="none" w="med" len="med"/>
+                    </a:lnB>
+                    <a:solidFill>
+                      <a:srgbClr val="FFFFFF"/>
+                    </a:solidFill>
+                  </a:tcPr>
+                </a:tc>
+                <a:tc>
+                  <a:txBody>
+                    <a:bodyPr/>
+                    <a:lstStyle/>
+                    <a:p>
+                      <a:pPr algn="l" indent="0" marL="0">
+                        <a:buNone/>
+                      </a:pPr>
+                      <a:r>
+                        <a:rPr lang="en-US" sz="1300" dirty="0">
+                          <a:solidFill>
+                            <a:srgbClr val="08323B"/>
+                          </a:solidFill>
+                          <a:latin typeface="Calibri" pitchFamily="34" charset="0"/>
+                          <a:ea typeface="Calibri" pitchFamily="34" charset="-122"/>
+                          <a:cs typeface="Calibri" pitchFamily="34" charset="-120"/>
+                        </a:rPr>
+                        <a:t>Calls backend</a:t>
+                      </a:r>
+                      <a:endParaRPr lang="en-US" sz="1300" dirty="0">
+                        <a:latin typeface="Calibri" charset="0"/>
+                        <a:ea typeface="Calibri" charset="0"/>
+                        <a:cs typeface="Calibri" charset="0"/>
+                      </a:endParaRPr>
+                    </a:p>
+                  </a:txBody>
+                  <a:tcPr marL="127000" marR="127000" marT="50800" marB="50800" anchor="ctr">
+                    <a:lnL w="12700" cap="flat" cmpd="sng" algn="ctr">
+                      <a:solidFill>
+                        <a:srgbClr val="D5DEE0"/>
+                      </a:solidFill>
+                      <a:prstDash val="solid"/>
+                      <a:round/>
+                      <a:headEnd type="none" w="med" len="med"/>
+                      <a:tailEnd type="none" w="med" len="med"/>
+                    </a:lnL>
+                    <a:lnR w="12700" cap="flat" cmpd="sng" algn="ctr">
+                      <a:solidFill>
+                        <a:srgbClr val="D5DEE0"/>
+                      </a:solidFill>
+                      <a:prstDash val="solid"/>
+                      <a:round/>
+                      <a:headEnd type="none" w="med" len="med"/>
+                      <a:tailEnd type="none" w="med" len="med"/>
+                    </a:lnR>
+                    <a:lnT w="12700" cap="flat" cmpd="sng" algn="ctr">
+                      <a:solidFill>
+                        <a:srgbClr val="D5DEE0"/>
+                      </a:solidFill>
+                      <a:prstDash val="solid"/>
+                      <a:round/>
+                      <a:headEnd type="none" w="med" len="med"/>
+                      <a:tailEnd type="none" w="med" len="med"/>
+                    </a:lnT>
+                    <a:lnB w="12700" cap="flat" cmpd="sng" algn="ctr">
+                      <a:solidFill>
+                        <a:srgbClr val="D5DEE0"/>
+                      </a:solidFill>
+                      <a:prstDash val="solid"/>
+                      <a:round/>
+                      <a:headEnd type="none" w="med" len="med"/>
+                      <a:tailEnd type="none" w="med" len="med"/>
+                    </a:lnB>
+                    <a:solidFill>
+                      <a:srgbClr val="FFFFFF"/>
+                    </a:solidFill>
+                  </a:tcPr>
+                </a:tc>
+              </a:tr>
+            </a:tbl>
+          </a:graphicData>
+        </a:graphic>
+      </p:graphicFrame>
+      <p:sp>
+        <p:nvSpPr>
+          <p:cNvPr id="5" name="Text 2"/>
           <p:cNvSpPr/>
           <p:nvPr/>
         </p:nvSpPr>
@@ -5783,7 +6231,7 @@
                 <a:ea typeface="Calibri" pitchFamily="34" charset="-122"/>
                 <a:cs typeface="Calibri" pitchFamily="34" charset="-120"/>
               </a:rPr>
-              <a:t>REGISTERED, SEND_OUT, RELABEL, or FAILURE. HTTP 200 for those. Soft alerts stay off the body.</a:t>
+              <a:t>REGISTERED, SEND_OUT, RELABEL, or FAILURE. Soft alerts stay off the body.</a:t>
             </a:r>
             <a:endParaRPr lang="en-US" sz="1300" dirty="0"/>
           </a:p>
@@ -5912,7 +6360,7 @@
                 <a:ea typeface="Calibri" pitchFamily="34" charset="-122"/>
                 <a:cs typeface="Calibri" pitchFamily="34" charset="-120"/>
               </a:rPr>
-              <a:t>hkid and patientName are optional. If sent and they mismatch the GCRS patient, Failure.</a:t>
+              <a:t>hkid and patientName. If sent and they mismatch, Failure.</a:t>
             </a:r>
             <a:endParaRPr lang="en-US" sz="1300" dirty="0"/>
           </a:p>
@@ -6041,7 +6489,7 @@
                 <a:ea typeface="Calibri" pitchFamily="34" charset="-122"/>
                 <a:cs typeface="Calibri" pitchFamily="34" charset="-120"/>
               </a:rPr>
-              <a:t>Do not reuse the staff register endpoint. No auth header in v1.</a:t>
+              <a:t>Do not reuse the staff register call. No auth header in v1.</a:t>
             </a:r>
             <a:endParaRPr lang="en-US" sz="1300" dirty="0"/>
           </a:p>
@@ -6432,7 +6880,7 @@
                 <a:ea typeface="Calibri" pitchFamily="34" charset="-122"/>
                 <a:cs typeface="Calibri" pitchFamily="34" charset="-120"/>
               </a:rPr>
-              <a:t>·  PHLC is already a backend call</a:t>
+              <a:t>·  PHLC is already backend</a:t>
             </a:r>
             <a:endParaRPr lang="en-US" sz="1300" dirty="0"/>
           </a:p>
@@ -8661,11 +9109,11 @@
             </a:avLst>
           </a:prstGeom>
           <a:solidFill>
-            <a:srgbClr val="08323B"/>
+            <a:srgbClr val="F1F3F3"/>
           </a:solidFill>
           <a:ln w="12700">
             <a:solidFill>
-              <a:srgbClr val="08323B"/>
+              <a:srgbClr val="F1F3F3"/>
             </a:solidFill>
             <a:prstDash val="solid"/>
           </a:ln>
@@ -8686,11 +9134,11 @@
             <a:avLst/>
           </a:prstGeom>
           <a:solidFill>
-            <a:srgbClr val="0B6E7F"/>
+            <a:srgbClr val="56676C"/>
           </a:solidFill>
           <a:ln>
             <a:solidFill>
-              <a:srgbClr val="0B6E7F"/>
+              <a:srgbClr val="56676C"/>
             </a:solidFill>
           </a:ln>
         </p:spPr>
@@ -8746,7 +9194,7 @@
             <a:r>
               <a:rPr lang="en-US" sz="1700" dirty="0">
                 <a:solidFill>
-                  <a:srgbClr val="FFFFFF"/>
+                  <a:srgbClr val="08323B"/>
                 </a:solidFill>
                 <a:latin typeface="Cambria" pitchFamily="34" charset="0"/>
                 <a:ea typeface="Cambria" pitchFamily="34" charset="-122"/>
@@ -8788,7 +9236,7 @@
             <a:r>
               <a:rPr lang="en-US" sz="1300" dirty="0">
                 <a:solidFill>
-                  <a:srgbClr val="8FBAC3"/>
+                  <a:srgbClr val="56676C"/>
                 </a:solidFill>
                 <a:latin typeface="Calibri" pitchFamily="34" charset="0"/>
                 <a:ea typeface="Calibri" pitchFamily="34" charset="-122"/>

</xml_diff>

<commit_message>
vault backup: 2026-09-10 14:20:57
</commit_message>
<xml_diff>
--- a/SDLC/Projects/TMP-specimen-sorter-api — Specimen Sorter API/assets/Specimen Sorter API.pptx
+++ b/SDLC/Projects/TMP-specimen-sorter-api — Specimen Sorter API/assets/Specimen Sorter API.pptx
@@ -864,7 +864,7 @@
           <a:p>
             <a:r>
               <a:rPr lang="en-US" dirty="0"/>
-              <a:t>Amber rows are the gap. Retrieve, send-out, and PHLC already hit the service. Register and worksheet cannot leave the screen until packing moves.</a:t>
+              <a:t>Amber is what moves. Group tests, request no., and ward/doctor mapping sit on registration, not on worksheet. Worksheet has its own convert, then print.</a:t>
             </a:r>
             <a:endParaRPr lang="en-US" dirty="0"/>
           </a:p>
@@ -1128,7 +1128,7 @@
           <a:p>
             <a:r>
               <a:rPr lang="en-US" dirty="0"/>
-              <a:t>Do not copy printer onto the map. Do not compare workbench lab to the retrieved test lab. Audit workstation is the workbench station name.</a:t>
+              <a:t>Do not copy printer onto the map as a second source of truth. Do not compare workbench lab to the retrieved test lab.</a:t>
             </a:r>
             <a:endParaRPr lang="en-US" dirty="0"/>
           </a:p>
@@ -3301,7 +3301,7 @@
                 <a:ea typeface="Calibri" pitchFamily="34" charset="-122"/>
                 <a:cs typeface="Calibri" pitchFamily="34" charset="-120"/>
               </a:rPr>
-              <a:t>Sorter user, workbench row, and loe_sorter_map before middleware is pointed at SIT.</a:t>
+              <a:t>Sorter user, workbench row, and loe_specimen_sorter_map before middleware is pointed at SIT.</a:t>
             </a:r>
             <a:endParaRPr lang="en-US" sz="1200" dirty="0"/>
           </a:p>
@@ -4450,8 +4450,8 @@
               <a:tblPr/>
               <a:tblGrid>
                 <a:gridCol w="2468880"/>
-                <a:gridCol w="5120640"/>
-                <a:gridCol w="3502152"/>
+                <a:gridCol w="5486400"/>
+                <a:gridCol w="3136392"/>
               </a:tblGrid>
               <a:tr h="475488">
                 <a:tc>
@@ -4539,7 +4539,7 @@
                           <a:ea typeface="Calibri" pitchFamily="34" charset="-122"/>
                           <a:cs typeface="Calibri" pitchFamily="34" charset="-120"/>
                         </a:rPr>
-                        <a:t>On the screen</a:t>
+                        <a:t>Front-end</a:t>
                       </a:r>
                       <a:endParaRPr lang="en-US" sz="1250" dirty="0">
                         <a:latin typeface="Calibri" charset="0"/>
@@ -4607,7 +4607,7 @@
                           <a:ea typeface="Calibri" pitchFamily="34" charset="-122"/>
                           <a:cs typeface="Calibri" pitchFamily="34" charset="-120"/>
                         </a:rPr>
-                        <a:t>Backend</a:t>
+                        <a:t>Back-end</a:t>
                       </a:r>
                       <a:endParaRPr lang="en-US" sz="1250" dirty="0">
                         <a:latin typeface="Calibri" charset="0"/>
@@ -5157,7 +5157,7 @@
                           <a:ea typeface="Calibri" pitchFamily="34" charset="-122"/>
                           <a:cs typeface="Calibri" pitchFamily="34" charset="-120"/>
                         </a:rPr>
-                        <a:t>Validates and converts</a:t>
+                        <a:t>Validates. Groups tests, request no., maps ward and doctor</a:t>
                       </a:r>
                       <a:endParaRPr lang="en-US" sz="1300" dirty="0">
                         <a:latin typeface="Calibri" charset="0"/>
@@ -5225,7 +5225,7 @@
                           <a:ea typeface="Calibri" pitchFamily="34" charset="-122"/>
                           <a:cs typeface="Calibri" pitchFamily="34" charset="-120"/>
                         </a:rPr>
-                        <a:t>Writes</a:t>
+                        <a:t>Calls backend</a:t>
                       </a:r>
                       <a:endParaRPr lang="en-US" sz="1300" dirty="0">
                         <a:latin typeface="Calibri" charset="0"/>
@@ -5363,7 +5363,7 @@
                           <a:ea typeface="Calibri" pitchFamily="34" charset="-122"/>
                           <a:cs typeface="Calibri" pitchFamily="34" charset="-120"/>
                         </a:rPr>
-                        <a:t>Groups tests, request no., ward, doctor</a:t>
+                        <a:t>Converts worksheet data</a:t>
                       </a:r>
                       <a:endParaRPr lang="en-US" sz="1300" dirty="0">
                         <a:latin typeface="Calibri" charset="0"/>
@@ -5431,7 +5431,7 @@
                           <a:ea typeface="Calibri" pitchFamily="34" charset="-122"/>
                           <a:cs typeface="Calibri" pitchFamily="34" charset="-120"/>
                         </a:rPr>
-                        <a:t>Prints</a:t>
+                        <a:t>Calls backend to print</a:t>
                       </a:r>
                       <a:endParaRPr lang="en-US" sz="1300" dirty="0">
                         <a:latin typeface="Calibri" charset="0"/>
@@ -6784,7 +6784,7 @@
                 <a:ea typeface="Courier New" pitchFamily="34" charset="-122"/>
                 <a:cs typeface="Courier New" pitchFamily="34" charset="-120"/>
               </a:rPr>
-              <a:t>validation</a:t>
+              <a:t>validate, then convert</a:t>
             </a:r>
             <a:endParaRPr lang="en-US" sz="1150" dirty="0"/>
           </a:p>
@@ -6860,7 +6860,7 @@
                 <a:ea typeface="Calibri" pitchFamily="34" charset="-122"/>
                 <a:cs typeface="Calibri" pitchFamily="34" charset="-120"/>
               </a:rPr>
-              <a:t>·  Then the screen calls register or print</a:t>
+              <a:t>·  Worksheet convert also runs here</a:t>
             </a:r>
             <a:endParaRPr lang="en-US" sz="1300" dirty="0"/>
           </a:p>
@@ -6880,7 +6880,7 @@
                 <a:ea typeface="Calibri" pitchFamily="34" charset="-122"/>
                 <a:cs typeface="Calibri" pitchFamily="34" charset="-120"/>
               </a:rPr>
-              <a:t>·  PHLC is already backend</a:t>
+              <a:t>·  Then the screen calls register or print</a:t>
             </a:r>
             <a:endParaRPr lang="en-US" sz="1300" dirty="0"/>
           </a:p>
@@ -7323,7 +7323,7 @@
                 <a:ea typeface="Cambria" pitchFamily="34" charset="-122"/>
                 <a:cs typeface="Cambria" pitchFamily="34" charset="-120"/>
               </a:rPr>
-              <a:t>A map table supplies user and workbench</a:t>
+              <a:t>The map supplies hospital, workstation, and user</a:t>
             </a:r>
             <a:endParaRPr lang="en-US" sz="3000" dirty="0"/>
           </a:p>
@@ -7437,7 +7437,7 @@
                 <a:ea typeface="Cambria" pitchFamily="34" charset="-122"/>
                 <a:cs typeface="Cambria" pitchFamily="34" charset="-120"/>
               </a:rPr>
-              <a:t>New table loe_sorter_map</a:t>
+              <a:t>New map table</a:t>
             </a:r>
             <a:endParaRPr lang="en-US" sz="1700" dirty="0"/>
           </a:p>
@@ -7479,7 +7479,7 @@
                 <a:ea typeface="Calibri" pitchFamily="34" charset="-122"/>
                 <a:cs typeface="Calibri" pitchFamily="34" charset="-120"/>
               </a:rPr>
-              <a:t>Sorter id maps to a dedicated LIS user and a workbench row.</a:t>
+              <a:t>loe_specimen_sorter_map. Sorter id maps to a dedicated LIS user and a workbench.</a:t>
             </a:r>
             <a:endParaRPr lang="en-US" sz="1300" dirty="0"/>
           </a:p>
@@ -7593,7 +7593,7 @@
                 <a:ea typeface="Cambria" pitchFamily="34" charset="-122"/>
                 <a:cs typeface="Cambria" pitchFamily="34" charset="-120"/>
               </a:rPr>
-              <a:t>Derive context</a:t>
+              <a:t>Derive from the map</a:t>
             </a:r>
             <a:endParaRPr lang="en-US" sz="1700" dirty="0"/>
           </a:p>
@@ -7635,7 +7635,7 @@
                 <a:ea typeface="Calibri" pitchFamily="34" charset="-122"/>
                 <a:cs typeface="Calibri" pitchFamily="34" charset="-120"/>
               </a:rPr>
-              <a:t>Hospital if omitted. Workstation, printer, and STAR location from workbench.</a:t>
+              <a:t>Hospital if the request omits it. Workstation and user from the same row.</a:t>
             </a:r>
             <a:endParaRPr lang="en-US" sz="1300" dirty="0"/>
           </a:p>
@@ -7791,7 +7791,7 @@
                 <a:ea typeface="Calibri" pitchFamily="34" charset="-122"/>
                 <a:cs typeface="Calibri" pitchFamily="34" charset="-120"/>
               </a:rPr>
-              <a:t>Write SORT_REG, SORT_SO, SORT_RELABEL, SORT_FAIL, plus REG and SEND_OUT.</a:t>
+              <a:t>Insert SORT_REG, SORT_SO, SORT_RELABEL, SORT_FAIL, plus REG and SEND_OUT.</a:t>
             </a:r>
             <a:endParaRPr lang="en-US" sz="1300" dirty="0"/>
           </a:p>
@@ -8473,7 +8473,7 @@
                 <a:ea typeface="Calibri" pitchFamily="34" charset="-122"/>
                 <a:cs typeface="Calibri" pitchFamily="34" charset="-120"/>
               </a:rPr>
-              <a:t>Sorter id, user, workbench id, lab, hosp, server name on loe_sorter_map.</a:t>
+              <a:t>Sorter id, user, and workbench id on loe_specimen_sorter_map.</a:t>
             </a:r>
             <a:endParaRPr lang="en-US" sz="1300" dirty="0"/>
           </a:p>
@@ -9086,7 +9086,7 @@
                 <a:ea typeface="Calibri" pitchFamily="34" charset="-122"/>
                 <a:cs typeface="Calibri" pitchFamily="34" charset="-120"/>
               </a:rPr>
-              <a:t>DROP TABLE loe_sorter_map on full rollback. Leave or disable the workbench and user.</a:t>
+              <a:t>DROP TABLE loe_specimen_sorter_map on full rollback. Leave or disable the workbench and user.</a:t>
             </a:r>
             <a:endParaRPr lang="en-US" sz="1300" dirty="0"/>
           </a:p>

</xml_diff>

<commit_message>
vault backup: 2026-09-10 15:34:47
</commit_message>
<xml_diff>
--- a/SDLC/Projects/TMP-specimen-sorter-api — Specimen Sorter API/assets/Specimen Sorter API.pptx
+++ b/SDLC/Projects/TMP-specimen-sorter-api — Specimen Sorter API/assets/Specimen Sorter API.pptx
@@ -776,7 +776,7 @@
           <a:p>
             <a:r>
               <a:rPr lang="en-US" dirty="0"/>
-              <a:t>The gap is not the writes. Validation and packing still sit on the screen, so middleware cannot reuse the staff register call.</a:t>
+              <a:t>As-is is the staff click path. To-be is the sorter calling LIS for the same send-out and registration actions. Checks and packing still sit on the screen today.</a:t>
             </a:r>
             <a:endParaRPr lang="en-US" dirty="0"/>
           </a:p>
@@ -1773,48 +1773,6 @@
         </p:nvSpPr>
         <p:spPr>
           <a:xfrm>
-            <a:off x="685800" y="1051560"/>
-            <a:ext cx="8229600" cy="274320"/>
-          </a:xfrm>
-          <a:prstGeom prst="rect">
-            <a:avLst/>
-          </a:prstGeom>
-          <a:noFill/>
-          <a:ln/>
-        </p:spPr>
-        <p:txBody>
-          <a:bodyPr wrap="square" rtlCol="0" anchor="t"/>
-          <a:lstStyle/>
-          <a:p>
-            <a:pPr algn="l" indent="0" marL="0">
-              <a:lnSpc>
-                <a:spcPct val="115000"/>
-              </a:lnSpc>
-              <a:buNone/>
-            </a:pPr>
-            <a:r>
-              <a:rPr lang="en-US" sz="1200" dirty="0">
-                <a:solidFill>
-                  <a:srgbClr val="8FBAC3"/>
-                </a:solidFill>
-                <a:latin typeface="Calibri" pitchFamily="34" charset="0"/>
-                <a:ea typeface="Calibri" pitchFamily="34" charset="-122"/>
-                <a:cs typeface="Calibri" pitchFamily="34" charset="-120"/>
-              </a:rPr>
-              <a:t>TMP-000   ·   CHANGE REQUEST   ·   CP3</a:t>
-            </a:r>
-            <a:endParaRPr lang="en-US" sz="1200" dirty="0"/>
-          </a:p>
-        </p:txBody>
-      </p:sp>
-      <p:sp>
-        <p:nvSpPr>
-          <p:cNvPr id="3" name="Text 1"/>
-          <p:cNvSpPr/>
-          <p:nvPr/>
-        </p:nvSpPr>
-        <p:spPr>
-          <a:xfrm>
             <a:off x="685800" y="1508760"/>
             <a:ext cx="8595360" cy="1737360"/>
           </a:xfrm>
@@ -1843,77 +1801,15 @@
                 <a:ea typeface="Cambria" pitchFamily="34" charset="-122"/>
                 <a:cs typeface="Cambria" pitchFamily="34" charset="-120"/>
               </a:rPr>
-              <a:t>One POST on Specimen Acknowledgement</a:t>
+              <a:t>Specimen Sorter API</a:t>
             </a:r>
             <a:endParaRPr lang="en-US" sz="4000" dirty="0"/>
           </a:p>
-          <a:p>
-            <a:pPr algn="l" indent="0" marL="0">
-              <a:lnSpc>
-                <a:spcPct val="110000"/>
-              </a:lnSpc>
-              <a:buNone/>
-            </a:pPr>
-            <a:r>
-              <a:rPr lang="en-US" sz="4000" dirty="0">
-                <a:solidFill>
-                  <a:srgbClr val="FFFFFF"/>
-                </a:solidFill>
-                <a:latin typeface="Cambria" pitchFamily="34" charset="0"/>
-                <a:ea typeface="Cambria" pitchFamily="34" charset="-122"/>
-                <a:cs typeface="Cambria" pitchFamily="34" charset="-120"/>
-              </a:rPr>
-              <a:t>registers or sends out a USID</a:t>
-            </a:r>
-            <a:endParaRPr lang="en-US" sz="4000" dirty="0"/>
-          </a:p>
-        </p:txBody>
-      </p:sp>
-      <p:sp>
-        <p:nvSpPr>
-          <p:cNvPr id="4" name="Text 2"/>
-          <p:cNvSpPr/>
-          <p:nvPr/>
-        </p:nvSpPr>
-        <p:spPr>
-          <a:xfrm>
-            <a:off x="685800" y="3429000"/>
-            <a:ext cx="7498080" cy="1005840"/>
-          </a:xfrm>
-          <a:prstGeom prst="rect">
-            <a:avLst/>
-          </a:prstGeom>
-          <a:noFill/>
-          <a:ln/>
-        </p:spPr>
-        <p:txBody>
-          <a:bodyPr wrap="square" rtlCol="0" anchor="t"/>
-          <a:lstStyle/>
-          <a:p>
-            <a:pPr algn="l" indent="0" marL="0">
-              <a:lnSpc>
-                <a:spcPct val="125000"/>
-              </a:lnSpc>
-              <a:buNone/>
-            </a:pPr>
-            <a:r>
-              <a:rPr lang="en-US" sz="1500" dirty="0">
-                <a:solidFill>
-                  <a:srgbClr val="8FBAC3"/>
-                </a:solidFill>
-                <a:latin typeface="Calibri" pitchFamily="34" charset="0"/>
-                <a:ea typeface="Calibri" pitchFamily="34" charset="-122"/>
-                <a:cs typeface="Calibri" pitchFamily="34" charset="-120"/>
-              </a:rPr>
-              <a:t>Today staff scan a label and click Send-out or Register. The sorter will scan the tube and call LIS for those same actions.</a:t>
-            </a:r>
-            <a:endParaRPr lang="en-US" sz="1500" dirty="0"/>
-          </a:p>
-        </p:txBody>
-      </p:sp>
-      <p:sp>
-        <p:nvSpPr>
-          <p:cNvPr id="5" name="Shape 3"/>
+        </p:txBody>
+      </p:sp>
+      <p:sp>
+        <p:nvSpPr>
+          <p:cNvPr id="3" name="Shape 1"/>
           <p:cNvSpPr/>
           <p:nvPr/>
         </p:nvSpPr>
@@ -1940,7 +1836,7 @@
       </p:sp>
       <p:sp>
         <p:nvSpPr>
-          <p:cNvPr id="6" name="Text 4"/>
+          <p:cNvPr id="4" name="Text 2"/>
           <p:cNvSpPr/>
           <p:nvPr/>
         </p:nvSpPr>
@@ -1982,7 +1878,7 @@
       </p:sp>
       <p:sp>
         <p:nvSpPr>
-          <p:cNvPr id="7" name="Text 5"/>
+          <p:cNvPr id="5" name="Text 3"/>
           <p:cNvSpPr/>
           <p:nvPr/>
         </p:nvSpPr>
@@ -2024,7 +1920,7 @@
       </p:sp>
       <p:sp>
         <p:nvSpPr>
-          <p:cNvPr id="8" name="Shape 6"/>
+          <p:cNvPr id="6" name="Shape 4"/>
           <p:cNvSpPr/>
           <p:nvPr/>
         </p:nvSpPr>
@@ -2051,7 +1947,7 @@
       </p:sp>
       <p:sp>
         <p:nvSpPr>
-          <p:cNvPr id="9" name="Text 7"/>
+          <p:cNvPr id="7" name="Text 5"/>
           <p:cNvSpPr/>
           <p:nvPr/>
         </p:nvSpPr>
@@ -2093,7 +1989,7 @@
       </p:sp>
       <p:sp>
         <p:nvSpPr>
-          <p:cNvPr id="10" name="Text 8"/>
+          <p:cNvPr id="8" name="Text 6"/>
           <p:cNvSpPr/>
           <p:nvPr/>
         </p:nvSpPr>
@@ -2135,7 +2031,7 @@
       </p:sp>
       <p:sp>
         <p:nvSpPr>
-          <p:cNvPr id="11" name="Shape 9"/>
+          <p:cNvPr id="9" name="Shape 7"/>
           <p:cNvSpPr/>
           <p:nvPr/>
         </p:nvSpPr>
@@ -2162,7 +2058,7 @@
       </p:sp>
       <p:sp>
         <p:nvSpPr>
-          <p:cNvPr id="12" name="Text 10"/>
+          <p:cNvPr id="10" name="Text 8"/>
           <p:cNvSpPr/>
           <p:nvPr/>
         </p:nvSpPr>
@@ -2204,7 +2100,7 @@
       </p:sp>
       <p:sp>
         <p:nvSpPr>
-          <p:cNvPr id="13" name="Text 11"/>
+          <p:cNvPr id="11" name="Text 9"/>
           <p:cNvSpPr/>
           <p:nvPr/>
         </p:nvSpPr>
@@ -2246,7 +2142,7 @@
       </p:sp>
       <p:sp>
         <p:nvSpPr>
-          <p:cNvPr id="14" name="Shape 12"/>
+          <p:cNvPr id="12" name="Shape 10"/>
           <p:cNvSpPr/>
           <p:nvPr/>
         </p:nvSpPr>
@@ -2273,7 +2169,7 @@
       </p:sp>
       <p:sp>
         <p:nvSpPr>
-          <p:cNvPr id="15" name="Text 13"/>
+          <p:cNvPr id="13" name="Text 11"/>
           <p:cNvSpPr/>
           <p:nvPr/>
         </p:nvSpPr>
@@ -2307,7 +2203,7 @@
                 <a:ea typeface="Calibri" pitchFamily="34" charset="-122"/>
                 <a:cs typeface="Calibri" pitchFamily="34" charset="-120"/>
               </a:rPr>
-              <a:t>FORUM</a:t>
+              <a:t>PRESENTER</a:t>
             </a:r>
             <a:endParaRPr lang="en-US" sz="900" dirty="0"/>
           </a:p>
@@ -2315,7 +2211,7 @@
       </p:sp>
       <p:sp>
         <p:nvSpPr>
-          <p:cNvPr id="16" name="Text 14"/>
+          <p:cNvPr id="14" name="Text 12"/>
           <p:cNvSpPr/>
           <p:nvPr/>
         </p:nvSpPr>
@@ -2357,91 +2253,7 @@
       </p:sp>
       <p:sp>
         <p:nvSpPr>
-          <p:cNvPr id="17" name="Text 15"/>
-          <p:cNvSpPr/>
-          <p:nvPr/>
-        </p:nvSpPr>
-        <p:spPr>
-          <a:xfrm>
-            <a:off x="685800" y="5806440"/>
-            <a:ext cx="10515600" cy="256032"/>
-          </a:xfrm>
-          <a:prstGeom prst="rect">
-            <a:avLst/>
-          </a:prstGeom>
-          <a:noFill/>
-          <a:ln/>
-        </p:spPr>
-        <p:txBody>
-          <a:bodyPr wrap="square" rtlCol="0" anchor="t"/>
-          <a:lstStyle/>
-          <a:p>
-            <a:pPr algn="l" indent="0" marL="0">
-              <a:lnSpc>
-                <a:spcPct val="115000"/>
-              </a:lnSpc>
-              <a:buNone/>
-            </a:pPr>
-            <a:r>
-              <a:rPr lang="en-US" sz="1200" dirty="0">
-                <a:solidFill>
-                  <a:srgbClr val="8FBAC3"/>
-                </a:solidFill>
-                <a:latin typeface="Calibri" pitchFamily="34" charset="0"/>
-                <a:ea typeface="Calibri" pitchFamily="34" charset="-122"/>
-                <a:cs typeface="Calibri" pitchFamily="34" charset="-120"/>
-              </a:rPr>
-              <a:t>Presenters: Ka   ·   Reviewers: Tony Chong, CP3 panel</a:t>
-            </a:r>
-            <a:endParaRPr lang="en-US" sz="1200" dirty="0"/>
-          </a:p>
-        </p:txBody>
-      </p:sp>
-      <p:sp>
-        <p:nvSpPr>
-          <p:cNvPr id="18" name="Text 16"/>
-          <p:cNvSpPr/>
-          <p:nvPr/>
-        </p:nvSpPr>
-        <p:spPr>
-          <a:xfrm>
-            <a:off x="685800" y="6080760"/>
-            <a:ext cx="5486400" cy="274320"/>
-          </a:xfrm>
-          <a:prstGeom prst="rect">
-            <a:avLst/>
-          </a:prstGeom>
-          <a:noFill/>
-          <a:ln/>
-        </p:spPr>
-        <p:txBody>
-          <a:bodyPr wrap="square" rtlCol="0" anchor="t"/>
-          <a:lstStyle/>
-          <a:p>
-            <a:pPr algn="l" indent="0" marL="0">
-              <a:lnSpc>
-                <a:spcPct val="115000"/>
-              </a:lnSpc>
-              <a:buNone/>
-            </a:pPr>
-            <a:r>
-              <a:rPr lang="en-US" sz="1100" dirty="0">
-                <a:solidFill>
-                  <a:srgbClr val="6E9199"/>
-                </a:solidFill>
-                <a:latin typeface="Calibri" pitchFamily="34" charset="0"/>
-                <a:ea typeface="Calibri" pitchFamily="34" charset="-122"/>
-                <a:cs typeface="Calibri" pitchFamily="34" charset="-120"/>
-              </a:rPr>
-              <a:t>Reviewed by Tony Chong  ·  SEM20260612  ·  JIRA not assigned</a:t>
-            </a:r>
-            <a:endParaRPr lang="en-US" sz="1100" dirty="0"/>
-          </a:p>
-        </p:txBody>
-      </p:sp>
-      <p:sp>
-        <p:nvSpPr>
-          <p:cNvPr id="19" name="Text 17"/>
+          <p:cNvPr id="15" name="Text 13"/>
           <p:cNvSpPr/>
           <p:nvPr/>
         </p:nvSpPr>
@@ -3568,20 +3380,20 @@
         </p:nvSpPr>
         <p:spPr>
           <a:xfrm>
-            <a:off x="548640" y="1828800"/>
-            <a:ext cx="3401568" cy="2788920"/>
+            <a:off x="548640" y="1737360"/>
+            <a:ext cx="5394960" cy="3063240"/>
           </a:xfrm>
           <a:prstGeom prst="roundRect">
             <a:avLst>
-              <a:gd name="adj" fmla="val 1311"/>
+              <a:gd name="adj" fmla="val 1194"/>
             </a:avLst>
           </a:prstGeom>
           <a:solidFill>
-            <a:srgbClr val="F1F3F3"/>
+            <a:srgbClr val="F7E7E4"/>
           </a:solidFill>
           <a:ln w="12700">
             <a:solidFill>
-              <a:srgbClr val="F1F3F3"/>
+              <a:srgbClr val="F7E7E4"/>
             </a:solidFill>
             <a:prstDash val="solid"/>
           </a:ln>
@@ -3595,40 +3407,37 @@
         </p:nvSpPr>
         <p:spPr>
           <a:xfrm>
-            <a:off x="822960" y="2121408"/>
-            <a:ext cx="384048" cy="384048"/>
-          </a:xfrm>
-          <a:prstGeom prst="ellipse">
-            <a:avLst/>
-          </a:prstGeom>
-          <a:solidFill>
-            <a:srgbClr val="56676C"/>
-          </a:solidFill>
-          <a:ln>
-            <a:solidFill>
-              <a:srgbClr val="56676C"/>
-            </a:solidFill>
-          </a:ln>
-        </p:spPr>
-        <p:txBody>
-          <a:bodyPr wrap="square" rtlCol="0" anchor="ctr"/>
-          <a:lstStyle/>
-          <a:p>
-            <a:pPr algn="ctr" indent="0" marL="0">
-              <a:buNone/>
-            </a:pPr>
-            <a:r>
-              <a:rPr lang="en-US" sz="1300" b="1" dirty="0">
-                <a:solidFill>
-                  <a:srgbClr val="FFFFFF"/>
+            <a:off x="822960" y="1956816"/>
+            <a:ext cx="4846320" cy="256032"/>
+          </a:xfrm>
+          <a:prstGeom prst="rect">
+            <a:avLst/>
+          </a:prstGeom>
+          <a:noFill/>
+          <a:ln/>
+        </p:spPr>
+        <p:txBody>
+          <a:bodyPr wrap="square" rtlCol="0" anchor="t"/>
+          <a:lstStyle/>
+          <a:p>
+            <a:pPr algn="l" indent="0" marL="0">
+              <a:lnSpc>
+                <a:spcPct val="115000"/>
+              </a:lnSpc>
+              <a:buNone/>
+            </a:pPr>
+            <a:r>
+              <a:rPr lang="en-US" sz="900" dirty="0">
+                <a:solidFill>
+                  <a:srgbClr val="A8443A"/>
                 </a:solidFill>
                 <a:latin typeface="Calibri" pitchFamily="34" charset="0"/>
                 <a:ea typeface="Calibri" pitchFamily="34" charset="-122"/>
                 <a:cs typeface="Calibri" pitchFamily="34" charset="-120"/>
               </a:rPr>
-              <a:t>1</a:t>
-            </a:r>
-            <a:endParaRPr lang="en-US" sz="1300" dirty="0"/>
+              <a:t>AS-IS</a:t>
+            </a:r>
+            <a:endParaRPr lang="en-US" sz="900" dirty="0"/>
           </a:p>
         </p:txBody>
       </p:sp>
@@ -3640,8 +3449,50 @@
         </p:nvSpPr>
         <p:spPr>
           <a:xfrm>
-            <a:off x="1325880" y="2157984"/>
-            <a:ext cx="2377440" cy="310896"/>
+            <a:off x="822960" y="2267712"/>
+            <a:ext cx="4846320" cy="457200"/>
+          </a:xfrm>
+          <a:prstGeom prst="rect">
+            <a:avLst/>
+          </a:prstGeom>
+          <a:noFill/>
+          <a:ln/>
+        </p:spPr>
+        <p:txBody>
+          <a:bodyPr wrap="square" rtlCol="0" anchor="t"/>
+          <a:lstStyle/>
+          <a:p>
+            <a:pPr algn="l" indent="0" marL="0">
+              <a:lnSpc>
+                <a:spcPct val="115000"/>
+              </a:lnSpc>
+              <a:buNone/>
+            </a:pPr>
+            <a:r>
+              <a:rPr lang="en-US" sz="1800" dirty="0">
+                <a:solidFill>
+                  <a:srgbClr val="08323B"/>
+                </a:solidFill>
+                <a:latin typeface="Cambria" pitchFamily="34" charset="0"/>
+                <a:ea typeface="Cambria" pitchFamily="34" charset="-122"/>
+                <a:cs typeface="Cambria" pitchFamily="34" charset="-120"/>
+              </a:rPr>
+              <a:t>Staff scan and click</a:t>
+            </a:r>
+            <a:endParaRPr lang="en-US" sz="1800" dirty="0"/>
+          </a:p>
+        </p:txBody>
+      </p:sp>
+      <p:sp>
+        <p:nvSpPr>
+          <p:cNvPr id="7" name="Text 5"/>
+          <p:cNvSpPr/>
+          <p:nvPr/>
+        </p:nvSpPr>
+        <p:spPr>
+          <a:xfrm>
+            <a:off x="822960" y="2816352"/>
+            <a:ext cx="4846320" cy="658368"/>
           </a:xfrm>
           <a:prstGeom prst="rect">
             <a:avLst/>
@@ -3657,30 +3508,47 @@
               <a:buNone/>
             </a:pPr>
             <a:r>
-              <a:rPr lang="en-US" sz="1300" dirty="0">
-                <a:solidFill>
-                  <a:srgbClr val="56676C"/>
+              <a:rPr lang="en-US" sz="1150" dirty="0">
+                <a:solidFill>
+                  <a:srgbClr val="08323B"/>
                 </a:solidFill>
                 <a:latin typeface="Courier New" pitchFamily="34" charset="0"/>
                 <a:ea typeface="Courier New" pitchFamily="34" charset="-122"/>
                 <a:cs typeface="Courier New" pitchFamily="34" charset="-120"/>
               </a:rPr>
-              <a:t>today</a:t>
-            </a:r>
-            <a:endParaRPr lang="en-US" sz="1300" dirty="0"/>
-          </a:p>
-        </p:txBody>
-      </p:sp>
-      <p:sp>
-        <p:nvSpPr>
-          <p:cNvPr id="7" name="Text 5"/>
-          <p:cNvSpPr/>
-          <p:nvPr/>
-        </p:nvSpPr>
-        <p:spPr>
-          <a:xfrm>
-            <a:off x="822960" y="2743200"/>
-            <a:ext cx="2852928" cy="502920"/>
+              <a:t>scan the specimen label</a:t>
+            </a:r>
+            <a:endParaRPr lang="en-US" sz="1150" dirty="0"/>
+          </a:p>
+          <a:p>
+            <a:pPr algn="l" indent="0" marL="0">
+              <a:buNone/>
+            </a:pPr>
+            <a:r>
+              <a:rPr lang="en-US" sz="1150" dirty="0">
+                <a:solidFill>
+                  <a:srgbClr val="08323B"/>
+                </a:solidFill>
+                <a:latin typeface="Courier New" pitchFamily="34" charset="0"/>
+                <a:ea typeface="Courier New" pitchFamily="34" charset="-122"/>
+                <a:cs typeface="Courier New" pitchFamily="34" charset="-120"/>
+              </a:rPr>
+              <a:t>press Send-out or Register</a:t>
+            </a:r>
+            <a:endParaRPr lang="en-US" sz="1150" dirty="0"/>
+          </a:p>
+        </p:txBody>
+      </p:sp>
+      <p:sp>
+        <p:nvSpPr>
+          <p:cNvPr id="8" name="Text 6"/>
+          <p:cNvSpPr/>
+          <p:nvPr/>
+        </p:nvSpPr>
+        <p:spPr>
+          <a:xfrm>
+            <a:off x="822960" y="3621024"/>
+            <a:ext cx="4846320" cy="996696"/>
           </a:xfrm>
           <a:prstGeom prst="rect">
             <a:avLst/>
@@ -3694,7 +3562,138 @@
           <a:p>
             <a:pPr algn="l" indent="0" marL="0">
               <a:lnSpc>
-                <a:spcPct val="110000"/>
+                <a:spcPct val="140000"/>
+              </a:lnSpc>
+              <a:buNone/>
+            </a:pPr>
+            <a:r>
+              <a:rPr lang="en-US" sz="1300" dirty="0">
+                <a:solidFill>
+                  <a:srgbClr val="56676C"/>
+                </a:solidFill>
+                <a:latin typeface="Calibri" pitchFamily="34" charset="0"/>
+                <a:ea typeface="Calibri" pitchFamily="34" charset="-122"/>
+                <a:cs typeface="Calibri" pitchFamily="34" charset="-120"/>
+              </a:rPr>
+              <a:t>·  On Specimen Acknowledgement</a:t>
+            </a:r>
+            <a:endParaRPr lang="en-US" sz="1300" dirty="0"/>
+          </a:p>
+          <a:p>
+            <a:pPr algn="l" indent="0" marL="0">
+              <a:lnSpc>
+                <a:spcPct val="140000"/>
+              </a:lnSpc>
+              <a:buNone/>
+            </a:pPr>
+            <a:r>
+              <a:rPr lang="en-US" sz="1300" dirty="0">
+                <a:solidFill>
+                  <a:srgbClr val="56676C"/>
+                </a:solidFill>
+                <a:latin typeface="Calibri" pitchFamily="34" charset="0"/>
+                <a:ea typeface="Calibri" pitchFamily="34" charset="-122"/>
+                <a:cs typeface="Calibri" pitchFamily="34" charset="-120"/>
+              </a:rPr>
+              <a:t>·  One tube, one staff action</a:t>
+            </a:r>
+            <a:endParaRPr lang="en-US" sz="1300" dirty="0"/>
+          </a:p>
+        </p:txBody>
+      </p:sp>
+      <p:sp>
+        <p:nvSpPr>
+          <p:cNvPr id="9" name="Shape 7"/>
+          <p:cNvSpPr/>
+          <p:nvPr/>
+        </p:nvSpPr>
+        <p:spPr>
+          <a:xfrm>
+            <a:off x="6245352" y="1737360"/>
+            <a:ext cx="5394960" cy="3063240"/>
+          </a:xfrm>
+          <a:prstGeom prst="roundRect">
+            <a:avLst>
+              <a:gd name="adj" fmla="val 1194"/>
+            </a:avLst>
+          </a:prstGeom>
+          <a:solidFill>
+            <a:srgbClr val="E4F0F2"/>
+          </a:solidFill>
+          <a:ln w="12700">
+            <a:solidFill>
+              <a:srgbClr val="E4F0F2"/>
+            </a:solidFill>
+            <a:prstDash val="solid"/>
+          </a:ln>
+        </p:spPr>
+      </p:sp>
+      <p:sp>
+        <p:nvSpPr>
+          <p:cNvPr id="10" name="Text 8"/>
+          <p:cNvSpPr/>
+          <p:nvPr/>
+        </p:nvSpPr>
+        <p:spPr>
+          <a:xfrm>
+            <a:off x="6519672" y="1956816"/>
+            <a:ext cx="4846320" cy="256032"/>
+          </a:xfrm>
+          <a:prstGeom prst="rect">
+            <a:avLst/>
+          </a:prstGeom>
+          <a:noFill/>
+          <a:ln/>
+        </p:spPr>
+        <p:txBody>
+          <a:bodyPr wrap="square" rtlCol="0" anchor="t"/>
+          <a:lstStyle/>
+          <a:p>
+            <a:pPr algn="l" indent="0" marL="0">
+              <a:lnSpc>
+                <a:spcPct val="115000"/>
+              </a:lnSpc>
+              <a:buNone/>
+            </a:pPr>
+            <a:r>
+              <a:rPr lang="en-US" sz="900" dirty="0">
+                <a:solidFill>
+                  <a:srgbClr val="0B6E7F"/>
+                </a:solidFill>
+                <a:latin typeface="Calibri" pitchFamily="34" charset="0"/>
+                <a:ea typeface="Calibri" pitchFamily="34" charset="-122"/>
+                <a:cs typeface="Calibri" pitchFamily="34" charset="-120"/>
+              </a:rPr>
+              <a:t>TO-BE</a:t>
+            </a:r>
+            <a:endParaRPr lang="en-US" sz="900" dirty="0"/>
+          </a:p>
+        </p:txBody>
+      </p:sp>
+      <p:sp>
+        <p:nvSpPr>
+          <p:cNvPr id="11" name="Text 9"/>
+          <p:cNvSpPr/>
+          <p:nvPr/>
+        </p:nvSpPr>
+        <p:spPr>
+          <a:xfrm>
+            <a:off x="6519672" y="2267712"/>
+            <a:ext cx="4846320" cy="457200"/>
+          </a:xfrm>
+          <a:prstGeom prst="rect">
+            <a:avLst/>
+          </a:prstGeom>
+          <a:noFill/>
+          <a:ln/>
+        </p:spPr>
+        <p:txBody>
+          <a:bodyPr wrap="square" rtlCol="0" anchor="t"/>
+          <a:lstStyle/>
+          <a:p>
+            <a:pPr algn="l" indent="0" marL="0">
+              <a:lnSpc>
+                <a:spcPct val="115000"/>
               </a:lnSpc>
               <a:buNone/>
             </a:pPr>
@@ -3707,7 +3706,7 @@
                 <a:ea typeface="Cambria" pitchFamily="34" charset="-122"/>
                 <a:cs typeface="Cambria" pitchFamily="34" charset="-120"/>
               </a:rPr>
-              <a:t>Scan and click</a:t>
+              <a:t>Sorter scans, LIS answers</a:t>
             </a:r>
             <a:endParaRPr lang="en-US" sz="1800" dirty="0"/>
           </a:p>
@@ -3715,14 +3714,70 @@
       </p:sp>
       <p:sp>
         <p:nvSpPr>
-          <p:cNvPr id="8" name="Text 6"/>
-          <p:cNvSpPr/>
-          <p:nvPr/>
-        </p:nvSpPr>
-        <p:spPr>
-          <a:xfrm>
-            <a:off x="822960" y="3310128"/>
-            <a:ext cx="2852928" cy="1106424"/>
+          <p:cNvPr id="12" name="Text 10"/>
+          <p:cNvSpPr/>
+          <p:nvPr/>
+        </p:nvSpPr>
+        <p:spPr>
+          <a:xfrm>
+            <a:off x="6519672" y="2816352"/>
+            <a:ext cx="4846320" cy="658368"/>
+          </a:xfrm>
+          <a:prstGeom prst="rect">
+            <a:avLst/>
+          </a:prstGeom>
+          <a:noFill/>
+          <a:ln/>
+        </p:spPr>
+        <p:txBody>
+          <a:bodyPr wrap="square" rtlCol="0" anchor="ctr"/>
+          <a:lstStyle/>
+          <a:p>
+            <a:pPr algn="l" indent="0" marL="0">
+              <a:buNone/>
+            </a:pPr>
+            <a:r>
+              <a:rPr lang="en-US" sz="1150" dirty="0">
+                <a:solidFill>
+                  <a:srgbClr val="08323B"/>
+                </a:solidFill>
+                <a:latin typeface="Courier New" pitchFamily="34" charset="0"/>
+                <a:ea typeface="Courier New" pitchFamily="34" charset="-122"/>
+                <a:cs typeface="Courier New" pitchFamily="34" charset="-120"/>
+              </a:rPr>
+              <a:t>sorter scans for sort and transport</a:t>
+            </a:r>
+            <a:endParaRPr lang="en-US" sz="1150" dirty="0"/>
+          </a:p>
+          <a:p>
+            <a:pPr algn="l" indent="0" marL="0">
+              <a:buNone/>
+            </a:pPr>
+            <a:r>
+              <a:rPr lang="en-US" sz="1150" dirty="0">
+                <a:solidFill>
+                  <a:srgbClr val="08323B"/>
+                </a:solidFill>
+                <a:latin typeface="Courier New" pitchFamily="34" charset="0"/>
+                <a:ea typeface="Courier New" pitchFamily="34" charset="-122"/>
+                <a:cs typeface="Courier New" pitchFamily="34" charset="-120"/>
+              </a:rPr>
+              <a:t>LIS API for send-out or register</a:t>
+            </a:r>
+            <a:endParaRPr lang="en-US" sz="1150" dirty="0"/>
+          </a:p>
+        </p:txBody>
+      </p:sp>
+      <p:sp>
+        <p:nvSpPr>
+          <p:cNvPr id="13" name="Text 11"/>
+          <p:cNvSpPr/>
+          <p:nvPr/>
+        </p:nvSpPr>
+        <p:spPr>
+          <a:xfrm>
+            <a:off x="6519672" y="3621024"/>
+            <a:ext cx="4846320" cy="996696"/>
           </a:xfrm>
           <a:prstGeom prst="rect">
             <a:avLst/>
@@ -3736,12 +3791,12 @@
           <a:p>
             <a:pPr algn="l" indent="0" marL="0">
               <a:lnSpc>
-                <a:spcPct val="135000"/>
+                <a:spcPct val="140000"/>
               </a:lnSpc>
               <a:buNone/>
             </a:pPr>
             <a:r>
-              <a:rPr lang="en-US" sz="1400" dirty="0">
+              <a:rPr lang="en-US" sz="1300" dirty="0">
                 <a:solidFill>
                   <a:srgbClr val="56676C"/>
                 </a:solidFill>
@@ -3749,51 +3804,46 @@
                 <a:ea typeface="Calibri" pitchFamily="34" charset="-122"/>
                 <a:cs typeface="Calibri" pitchFamily="34" charset="-120"/>
               </a:rPr>
-              <a:t>Staff scan the specimen label on Specimen Acknowledgement and press Send-out or Register.</a:t>
-            </a:r>
-            <a:endParaRPr lang="en-US" sz="1400" dirty="0"/>
-          </a:p>
-        </p:txBody>
-      </p:sp>
-      <p:sp>
-        <p:nvSpPr>
-          <p:cNvPr id="9" name="Shape 7"/>
-          <p:cNvSpPr/>
-          <p:nvPr/>
-        </p:nvSpPr>
-        <p:spPr>
-          <a:xfrm>
-            <a:off x="4005072" y="3063240"/>
-            <a:ext cx="274320" cy="237744"/>
-          </a:xfrm>
-          <a:prstGeom prst="rightArrow">
-            <a:avLst/>
-          </a:prstGeom>
-          <a:solidFill>
-            <a:srgbClr val="8FBAC3"/>
-          </a:solidFill>
-          <a:ln w="12700">
-            <a:solidFill>
-              <a:srgbClr val="8FBAC3"/>
-            </a:solidFill>
-            <a:prstDash val="solid"/>
-          </a:ln>
-        </p:spPr>
-      </p:sp>
-      <p:sp>
-        <p:nvSpPr>
-          <p:cNvPr id="10" name="Shape 8"/>
-          <p:cNvSpPr/>
-          <p:nvPr/>
-        </p:nvSpPr>
-        <p:spPr>
-          <a:xfrm>
-            <a:off x="4334256" y="1828800"/>
-            <a:ext cx="3401568" cy="2788920"/>
+              <a:t>·  One call, then a bin</a:t>
+            </a:r>
+            <a:endParaRPr lang="en-US" sz="1300" dirty="0"/>
+          </a:p>
+          <a:p>
+            <a:pPr algn="l" indent="0" marL="0">
+              <a:lnSpc>
+                <a:spcPct val="140000"/>
+              </a:lnSpc>
+              <a:buNone/>
+            </a:pPr>
+            <a:r>
+              <a:rPr lang="en-US" sz="1300" dirty="0">
+                <a:solidFill>
+                  <a:srgbClr val="56676C"/>
+                </a:solidFill>
+                <a:latin typeface="Calibri" pitchFamily="34" charset="0"/>
+                <a:ea typeface="Calibri" pitchFamily="34" charset="-122"/>
+                <a:cs typeface="Calibri" pitchFamily="34" charset="-120"/>
+              </a:rPr>
+              <a:t>·  Staff screen stays as fallback</a:t>
+            </a:r>
+            <a:endParaRPr lang="en-US" sz="1300" dirty="0"/>
+          </a:p>
+        </p:txBody>
+      </p:sp>
+      <p:sp>
+        <p:nvSpPr>
+          <p:cNvPr id="14" name="Shape 12"/>
+          <p:cNvSpPr/>
+          <p:nvPr/>
+        </p:nvSpPr>
+        <p:spPr>
+          <a:xfrm>
+            <a:off x="548640" y="4983480"/>
+            <a:ext cx="11091672" cy="868680"/>
           </a:xfrm>
           <a:prstGeom prst="roundRect">
             <a:avLst>
-              <a:gd name="adj" fmla="val 1311"/>
+              <a:gd name="adj" fmla="val 4211"/>
             </a:avLst>
           </a:prstGeom>
           <a:solidFill>
@@ -3809,422 +3859,7 @@
       </p:sp>
       <p:sp>
         <p:nvSpPr>
-          <p:cNvPr id="11" name="Text 9"/>
-          <p:cNvSpPr/>
-          <p:nvPr/>
-        </p:nvSpPr>
-        <p:spPr>
-          <a:xfrm>
-            <a:off x="4608576" y="2121408"/>
-            <a:ext cx="384048" cy="384048"/>
-          </a:xfrm>
-          <a:prstGeom prst="ellipse">
-            <a:avLst/>
-          </a:prstGeom>
-          <a:solidFill>
-            <a:srgbClr val="9A5C15"/>
-          </a:solidFill>
-          <a:ln>
-            <a:solidFill>
-              <a:srgbClr val="9A5C15"/>
-            </a:solidFill>
-          </a:ln>
-        </p:spPr>
-        <p:txBody>
-          <a:bodyPr wrap="square" rtlCol="0" anchor="ctr"/>
-          <a:lstStyle/>
-          <a:p>
-            <a:pPr algn="ctr" indent="0" marL="0">
-              <a:buNone/>
-            </a:pPr>
-            <a:r>
-              <a:rPr lang="en-US" sz="1300" b="1" dirty="0">
-                <a:solidFill>
-                  <a:srgbClr val="FFFFFF"/>
-                </a:solidFill>
-                <a:latin typeface="Calibri" pitchFamily="34" charset="0"/>
-                <a:ea typeface="Calibri" pitchFamily="34" charset="-122"/>
-                <a:cs typeface="Calibri" pitchFamily="34" charset="-120"/>
-              </a:rPr>
-              <a:t>2</a:t>
-            </a:r>
-            <a:endParaRPr lang="en-US" sz="1300" dirty="0"/>
-          </a:p>
-        </p:txBody>
-      </p:sp>
-      <p:sp>
-        <p:nvSpPr>
-          <p:cNvPr id="12" name="Text 10"/>
-          <p:cNvSpPr/>
-          <p:nvPr/>
-        </p:nvSpPr>
-        <p:spPr>
-          <a:xfrm>
-            <a:off x="5111496" y="2157984"/>
-            <a:ext cx="2377440" cy="310896"/>
-          </a:xfrm>
-          <a:prstGeom prst="rect">
-            <a:avLst/>
-          </a:prstGeom>
-          <a:noFill/>
-          <a:ln/>
-        </p:spPr>
-        <p:txBody>
-          <a:bodyPr wrap="square" rtlCol="0" anchor="ctr"/>
-          <a:lstStyle/>
-          <a:p>
-            <a:pPr algn="l" indent="0" marL="0">
-              <a:buNone/>
-            </a:pPr>
-            <a:r>
-              <a:rPr lang="en-US" sz="1300" dirty="0">
-                <a:solidFill>
-                  <a:srgbClr val="9A5C15"/>
-                </a:solidFill>
-                <a:latin typeface="Courier New" pitchFamily="34" charset="0"/>
-                <a:ea typeface="Courier New" pitchFamily="34" charset="-122"/>
-                <a:cs typeface="Courier New" pitchFamily="34" charset="-120"/>
-              </a:rPr>
-              <a:t>sorter</a:t>
-            </a:r>
-            <a:endParaRPr lang="en-US" sz="1300" dirty="0"/>
-          </a:p>
-        </p:txBody>
-      </p:sp>
-      <p:sp>
-        <p:nvSpPr>
-          <p:cNvPr id="13" name="Text 11"/>
-          <p:cNvSpPr/>
-          <p:nvPr/>
-        </p:nvSpPr>
-        <p:spPr>
-          <a:xfrm>
-            <a:off x="4608576" y="2743200"/>
-            <a:ext cx="2852928" cy="502920"/>
-          </a:xfrm>
-          <a:prstGeom prst="rect">
-            <a:avLst/>
-          </a:prstGeom>
-          <a:noFill/>
-          <a:ln/>
-        </p:spPr>
-        <p:txBody>
-          <a:bodyPr wrap="square" rtlCol="0" anchor="t"/>
-          <a:lstStyle/>
-          <a:p>
-            <a:pPr algn="l" indent="0" marL="0">
-              <a:lnSpc>
-                <a:spcPct val="110000"/>
-              </a:lnSpc>
-              <a:buNone/>
-            </a:pPr>
-            <a:r>
-              <a:rPr lang="en-US" sz="1800" dirty="0">
-                <a:solidFill>
-                  <a:srgbClr val="08323B"/>
-                </a:solidFill>
-                <a:latin typeface="Cambria" pitchFamily="34" charset="0"/>
-                <a:ea typeface="Cambria" pitchFamily="34" charset="-122"/>
-                <a:cs typeface="Cambria" pitchFamily="34" charset="-120"/>
-              </a:rPr>
-              <a:t>Tubes go on a sorter</a:t>
-            </a:r>
-            <a:endParaRPr lang="en-US" sz="1800" dirty="0"/>
-          </a:p>
-        </p:txBody>
-      </p:sp>
-      <p:sp>
-        <p:nvSpPr>
-          <p:cNvPr id="14" name="Text 12"/>
-          <p:cNvSpPr/>
-          <p:nvPr/>
-        </p:nvSpPr>
-        <p:spPr>
-          <a:xfrm>
-            <a:off x="4608576" y="3310128"/>
-            <a:ext cx="2852928" cy="1106424"/>
-          </a:xfrm>
-          <a:prstGeom prst="rect">
-            <a:avLst/>
-          </a:prstGeom>
-          <a:noFill/>
-          <a:ln/>
-        </p:spPr>
-        <p:txBody>
-          <a:bodyPr wrap="square" rtlCol="0" anchor="t"/>
-          <a:lstStyle/>
-          <a:p>
-            <a:pPr algn="l" indent="0" marL="0">
-              <a:lnSpc>
-                <a:spcPct val="135000"/>
-              </a:lnSpc>
-              <a:buNone/>
-            </a:pPr>
-            <a:r>
-              <a:rPr lang="en-US" sz="1400" dirty="0">
-                <a:solidFill>
-                  <a:srgbClr val="56676C"/>
-                </a:solidFill>
-                <a:latin typeface="Calibri" pitchFamily="34" charset="0"/>
-                <a:ea typeface="Calibri" pitchFamily="34" charset="-122"/>
-                <a:cs typeface="Calibri" pitchFamily="34" charset="-120"/>
-              </a:rPr>
-              <a:t>Labs will load tubes onto a sorter for scan, sort, and transport.</a:t>
-            </a:r>
-            <a:endParaRPr lang="en-US" sz="1400" dirty="0"/>
-          </a:p>
-        </p:txBody>
-      </p:sp>
-      <p:sp>
-        <p:nvSpPr>
-          <p:cNvPr id="15" name="Shape 13"/>
-          <p:cNvSpPr/>
-          <p:nvPr/>
-        </p:nvSpPr>
-        <p:spPr>
-          <a:xfrm>
-            <a:off x="7790688" y="3063240"/>
-            <a:ext cx="274320" cy="237744"/>
-          </a:xfrm>
-          <a:prstGeom prst="rightArrow">
-            <a:avLst/>
-          </a:prstGeom>
-          <a:solidFill>
-            <a:srgbClr val="8FBAC3"/>
-          </a:solidFill>
-          <a:ln w="12700">
-            <a:solidFill>
-              <a:srgbClr val="8FBAC3"/>
-            </a:solidFill>
-            <a:prstDash val="solid"/>
-          </a:ln>
-        </p:spPr>
-      </p:sp>
-      <p:sp>
-        <p:nvSpPr>
-          <p:cNvPr id="16" name="Shape 14"/>
-          <p:cNvSpPr/>
-          <p:nvPr/>
-        </p:nvSpPr>
-        <p:spPr>
-          <a:xfrm>
-            <a:off x="8119872" y="1828800"/>
-            <a:ext cx="3401568" cy="2788920"/>
-          </a:xfrm>
-          <a:prstGeom prst="roundRect">
-            <a:avLst>
-              <a:gd name="adj" fmla="val 1311"/>
-            </a:avLst>
-          </a:prstGeom>
-          <a:solidFill>
-            <a:srgbClr val="E4F0F2"/>
-          </a:solidFill>
-          <a:ln w="12700">
-            <a:solidFill>
-              <a:srgbClr val="E4F0F2"/>
-            </a:solidFill>
-            <a:prstDash val="solid"/>
-          </a:ln>
-        </p:spPr>
-      </p:sp>
-      <p:sp>
-        <p:nvSpPr>
-          <p:cNvPr id="17" name="Text 15"/>
-          <p:cNvSpPr/>
-          <p:nvPr/>
-        </p:nvSpPr>
-        <p:spPr>
-          <a:xfrm>
-            <a:off x="8394192" y="2121408"/>
-            <a:ext cx="384048" cy="384048"/>
-          </a:xfrm>
-          <a:prstGeom prst="ellipse">
-            <a:avLst/>
-          </a:prstGeom>
-          <a:solidFill>
-            <a:srgbClr val="0B6E7F"/>
-          </a:solidFill>
-          <a:ln>
-            <a:solidFill>
-              <a:srgbClr val="0B6E7F"/>
-            </a:solidFill>
-          </a:ln>
-        </p:spPr>
-        <p:txBody>
-          <a:bodyPr wrap="square" rtlCol="0" anchor="ctr"/>
-          <a:lstStyle/>
-          <a:p>
-            <a:pPr algn="ctr" indent="0" marL="0">
-              <a:buNone/>
-            </a:pPr>
-            <a:r>
-              <a:rPr lang="en-US" sz="1300" b="1" dirty="0">
-                <a:solidFill>
-                  <a:srgbClr val="FFFFFF"/>
-                </a:solidFill>
-                <a:latin typeface="Calibri" pitchFamily="34" charset="0"/>
-                <a:ea typeface="Calibri" pitchFamily="34" charset="-122"/>
-                <a:cs typeface="Calibri" pitchFamily="34" charset="-120"/>
-              </a:rPr>
-              <a:t>3</a:t>
-            </a:r>
-            <a:endParaRPr lang="en-US" sz="1300" dirty="0"/>
-          </a:p>
-        </p:txBody>
-      </p:sp>
-      <p:sp>
-        <p:nvSpPr>
-          <p:cNvPr id="18" name="Text 16"/>
-          <p:cNvSpPr/>
-          <p:nvPr/>
-        </p:nvSpPr>
-        <p:spPr>
-          <a:xfrm>
-            <a:off x="8897112" y="2157984"/>
-            <a:ext cx="2377440" cy="310896"/>
-          </a:xfrm>
-          <a:prstGeom prst="rect">
-            <a:avLst/>
-          </a:prstGeom>
-          <a:noFill/>
-          <a:ln/>
-        </p:spPr>
-        <p:txBody>
-          <a:bodyPr wrap="square" rtlCol="0" anchor="ctr"/>
-          <a:lstStyle/>
-          <a:p>
-            <a:pPr algn="l" indent="0" marL="0">
-              <a:buNone/>
-            </a:pPr>
-            <a:r>
-              <a:rPr lang="en-US" sz="1300" dirty="0">
-                <a:solidFill>
-                  <a:srgbClr val="0B6E7F"/>
-                </a:solidFill>
-                <a:latin typeface="Courier New" pitchFamily="34" charset="0"/>
-                <a:ea typeface="Courier New" pitchFamily="34" charset="-122"/>
-                <a:cs typeface="Courier New" pitchFamily="34" charset="-120"/>
-              </a:rPr>
-              <a:t>this CR</a:t>
-            </a:r>
-            <a:endParaRPr lang="en-US" sz="1300" dirty="0"/>
-          </a:p>
-        </p:txBody>
-      </p:sp>
-      <p:sp>
-        <p:nvSpPr>
-          <p:cNvPr id="19" name="Text 17"/>
-          <p:cNvSpPr/>
-          <p:nvPr/>
-        </p:nvSpPr>
-        <p:spPr>
-          <a:xfrm>
-            <a:off x="8394192" y="2743200"/>
-            <a:ext cx="2852928" cy="502920"/>
-          </a:xfrm>
-          <a:prstGeom prst="rect">
-            <a:avLst/>
-          </a:prstGeom>
-          <a:noFill/>
-          <a:ln/>
-        </p:spPr>
-        <p:txBody>
-          <a:bodyPr wrap="square" rtlCol="0" anchor="t"/>
-          <a:lstStyle/>
-          <a:p>
-            <a:pPr algn="l" indent="0" marL="0">
-              <a:lnSpc>
-                <a:spcPct val="110000"/>
-              </a:lnSpc>
-              <a:buNone/>
-            </a:pPr>
-            <a:r>
-              <a:rPr lang="en-US" sz="1800" dirty="0">
-                <a:solidFill>
-                  <a:srgbClr val="08323B"/>
-                </a:solidFill>
-                <a:latin typeface="Cambria" pitchFamily="34" charset="0"/>
-                <a:ea typeface="Cambria" pitchFamily="34" charset="-122"/>
-                <a:cs typeface="Cambria" pitchFamily="34" charset="-120"/>
-              </a:rPr>
-              <a:t>One LIS call, then a bin</a:t>
-            </a:r>
-            <a:endParaRPr lang="en-US" sz="1800" dirty="0"/>
-          </a:p>
-        </p:txBody>
-      </p:sp>
-      <p:sp>
-        <p:nvSpPr>
-          <p:cNvPr id="20" name="Text 18"/>
-          <p:cNvSpPr/>
-          <p:nvPr/>
-        </p:nvSpPr>
-        <p:spPr>
-          <a:xfrm>
-            <a:off x="8394192" y="3310128"/>
-            <a:ext cx="2852928" cy="1106424"/>
-          </a:xfrm>
-          <a:prstGeom prst="rect">
-            <a:avLst/>
-          </a:prstGeom>
-          <a:noFill/>
-          <a:ln/>
-        </p:spPr>
-        <p:txBody>
-          <a:bodyPr wrap="square" rtlCol="0" anchor="t"/>
-          <a:lstStyle/>
-          <a:p>
-            <a:pPr algn="l" indent="0" marL="0">
-              <a:lnSpc>
-                <a:spcPct val="135000"/>
-              </a:lnSpc>
-              <a:buNone/>
-            </a:pPr>
-            <a:r>
-              <a:rPr lang="en-US" sz="1400" dirty="0">
-                <a:solidFill>
-                  <a:srgbClr val="56676C"/>
-                </a:solidFill>
-                <a:latin typeface="Calibri" pitchFamily="34" charset="0"/>
-                <a:ea typeface="Calibri" pitchFamily="34" charset="-122"/>
-                <a:cs typeface="Calibri" pitchFamily="34" charset="-120"/>
-              </a:rPr>
-              <a:t>Middleware calls LIS so the sorter can bin from send-out or registration status.</a:t>
-            </a:r>
-            <a:endParaRPr lang="en-US" sz="1400" dirty="0"/>
-          </a:p>
-        </p:txBody>
-      </p:sp>
-      <p:sp>
-        <p:nvSpPr>
-          <p:cNvPr id="21" name="Shape 19"/>
-          <p:cNvSpPr/>
-          <p:nvPr/>
-        </p:nvSpPr>
-        <p:spPr>
-          <a:xfrm>
-            <a:off x="548640" y="4983480"/>
-            <a:ext cx="11091672" cy="868680"/>
-          </a:xfrm>
-          <a:prstGeom prst="roundRect">
-            <a:avLst>
-              <a:gd name="adj" fmla="val 4211"/>
-            </a:avLst>
-          </a:prstGeom>
-          <a:solidFill>
-            <a:srgbClr val="FAEEDB"/>
-          </a:solidFill>
-          <a:ln w="12700">
-            <a:solidFill>
-              <a:srgbClr val="FAEEDB"/>
-            </a:solidFill>
-            <a:prstDash val="solid"/>
-          </a:ln>
-        </p:spPr>
-      </p:sp>
-      <p:sp>
-        <p:nvSpPr>
-          <p:cNvPr id="22" name="Text 20"/>
+          <p:cNvPr id="15" name="Text 13"/>
           <p:cNvSpPr/>
           <p:nvPr/>
         </p:nvSpPr>
@@ -4250,31 +3885,14 @@
               <a:buNone/>
             </a:pPr>
             <a:r>
-              <a:rPr lang="en-US" sz="1400" b="1" dirty="0">
-                <a:solidFill>
-                  <a:srgbClr val="9A5C15"/>
+              <a:rPr lang="en-US" sz="1400" dirty="0">
+                <a:solidFill>
+                  <a:srgbClr val="08323B"/>
                 </a:solidFill>
                 <a:latin typeface="Calibri" pitchFamily="34" charset="0"/>
                 <a:ea typeface="Calibri" pitchFamily="34" charset="-122"/>
                 <a:cs typeface="Calibri" pitchFamily="34" charset="-120"/>
               </a:rPr>
-              <a:t>Staff screen stays:  </a:t>
-            </a:r>
-            <a:pPr algn="l" indent="0" marL="0">
-              <a:lnSpc>
-                <a:spcPct val="120000"/>
-              </a:lnSpc>
-              <a:buNone/>
-            </a:pPr>
-            <a:r>
-              <a:rPr lang="en-US" sz="1400" dirty="0">
-                <a:solidFill>
-                  <a:srgbClr val="08323B"/>
-                </a:solidFill>
-                <a:latin typeface="Calibri" pitchFamily="34" charset="0"/>
-                <a:ea typeface="Calibri" pitchFamily="34" charset="-122"/>
-                <a:cs typeface="Calibri" pitchFamily="34" charset="-120"/>
-              </a:rPr>
               <a:t>Specimen Acknowledgement remains the fallback when the sorter returns Relabel or Failure.</a:t>
             </a:r>
             <a:endParaRPr lang="en-US" sz="1400" dirty="0"/>
@@ -4283,7 +3901,7 @@
       </p:sp>
       <p:sp>
         <p:nvSpPr>
-          <p:cNvPr id="23" name="Text 21"/>
+          <p:cNvPr id="16" name="Text 14"/>
           <p:cNvSpPr/>
           <p:nvPr/>
         </p:nvSpPr>
@@ -4745,7 +4363,7 @@
                           <a:ea typeface="Calibri" pitchFamily="34" charset="-122"/>
                           <a:cs typeface="Calibri" pitchFamily="34" charset="-120"/>
                         </a:rPr>
-                        <a:t>Looks up the order</a:t>
+                        <a:t>Scan Specimen Label</a:t>
                       </a:r>
                       <a:endParaRPr lang="en-US" sz="1300" dirty="0">
                         <a:latin typeface="Calibri" charset="0"/>
@@ -5157,7 +4775,7 @@
                           <a:ea typeface="Calibri" pitchFamily="34" charset="-122"/>
                           <a:cs typeface="Calibri" pitchFamily="34" charset="-120"/>
                         </a:rPr>
-                        <a:t>Validates. Groups tests, request no., maps ward and doctor</a:t>
+                        <a:t>Presses Register Request. Validates. Groups tests, request no., maps ward and doctor</a:t>
                       </a:r>
                       <a:endParaRPr lang="en-US" sz="1300" dirty="0">
                         <a:latin typeface="Calibri" charset="0"/>

</xml_diff>